<commit_message>
Melhora leitura dos gráficos e navegação do painel
</commit_message>
<xml_diff>
--- a/docs/apresentacao_pagamentos_es_2024.pptx
+++ b/docs/apresentacao_pagamentos_es_2024.pptx
@@ -2,20 +2,20 @@
 <file path=ppt/presentation.xml><?xml version="1.0" encoding="utf-8"?>
 <p:presentation xmlns:p="http://schemas.openxmlformats.org/presentationml/2006/main">
   <p:sldMasterIdLst>
-    <p:sldMasterId xmlns:r="http://schemas.openxmlformats.org/officeDocument/2006/relationships" id="2147483648" r:id="R3b93653c460849ad"/>
+    <p:sldMasterId xmlns:r="http://schemas.openxmlformats.org/officeDocument/2006/relationships" id="2147483648" r:id="R53b66df697954928"/>
   </p:sldMasterIdLst>
   <p:notesMasterIdLst>
-    <p:notesMasterId xmlns:r="http://schemas.openxmlformats.org/officeDocument/2006/relationships" r:id="Rb553bfacc774428b"/>
+    <p:notesMasterId xmlns:r="http://schemas.openxmlformats.org/officeDocument/2006/relationships" r:id="R1f31c793365d487c"/>
   </p:notesMasterIdLst>
   <p:sldIdLst>
-    <p:sldId xmlns:r="http://schemas.openxmlformats.org/officeDocument/2006/relationships" id="256" r:id="Rad0296c491254f6e"/>
-    <p:sldId xmlns:r="http://schemas.openxmlformats.org/officeDocument/2006/relationships" id="257" r:id="R4c1e4d47d3c443f3"/>
-    <p:sldId xmlns:r="http://schemas.openxmlformats.org/officeDocument/2006/relationships" id="258" r:id="R8527cbc088f24b02"/>
-    <p:sldId xmlns:r="http://schemas.openxmlformats.org/officeDocument/2006/relationships" id="259" r:id="R220d3a7723a64f2c"/>
-    <p:sldId xmlns:r="http://schemas.openxmlformats.org/officeDocument/2006/relationships" id="260" r:id="Re7e4e6101f7a451b"/>
-    <p:sldId xmlns:r="http://schemas.openxmlformats.org/officeDocument/2006/relationships" id="261" r:id="Re79ed14d2c5941f5"/>
-    <p:sldId xmlns:r="http://schemas.openxmlformats.org/officeDocument/2006/relationships" id="262" r:id="Re0b2cd0563734135"/>
-    <p:sldId xmlns:r="http://schemas.openxmlformats.org/officeDocument/2006/relationships" id="263" r:id="R9706f7185ab84d8f"/>
+    <p:sldId xmlns:r="http://schemas.openxmlformats.org/officeDocument/2006/relationships" id="256" r:id="Rb30003042c90461a"/>
+    <p:sldId xmlns:r="http://schemas.openxmlformats.org/officeDocument/2006/relationships" id="257" r:id="Rf3de323c8fa647d6"/>
+    <p:sldId xmlns:r="http://schemas.openxmlformats.org/officeDocument/2006/relationships" id="258" r:id="Rd1c79f81323b4291"/>
+    <p:sldId xmlns:r="http://schemas.openxmlformats.org/officeDocument/2006/relationships" id="259" r:id="Rbd19b737a6bc4f5b"/>
+    <p:sldId xmlns:r="http://schemas.openxmlformats.org/officeDocument/2006/relationships" id="260" r:id="Rd870f77eb34d49f0"/>
+    <p:sldId xmlns:r="http://schemas.openxmlformats.org/officeDocument/2006/relationships" id="261" r:id="R5a6597b91db34769"/>
+    <p:sldId xmlns:r="http://schemas.openxmlformats.org/officeDocument/2006/relationships" id="262" r:id="R89b9da0e0ccc4fda"/>
+    <p:sldId xmlns:r="http://schemas.openxmlformats.org/officeDocument/2006/relationships" id="263" r:id="R57f2e09b3763452b"/>
   </p:sldIdLst>
   <p:sldSz cx="12192000" cy="6858000"/>
   <p:notesSz cx="6858000" cy="9144000"/>
@@ -969,7 +969,7 @@
           </a:p>
           <a:p xmlns:a="http://schemas.openxmlformats.org/drawingml/2006/main">
             <a:r>
-              <a:t>Explicar que esta tabela propõe a divisão futura, sem afirmar contribuições já realizadas. Produto aprova o escopo antes do pipeline. Dados entrega esquema e totais conciliados antes da integração. Desenvolvimento entrega a jornada integrada para testes. Qualidade confirma reprodução em ambiente limpo e ausência de falhas bloqueadoras. Se novos dados atrasarem, manter o conjunto validado de 2024 e registrar o recorte. O enunciado exige 5 a 8 estudantes. A composição atual informada tem quatro e precisa de alinhamento com o professor.</a:t>
+              <a:t>Explicar que esta tabela propõe a divisão futura, sem afirmar contribuições já realizadas. Os marcos descrevem a evolução da POC que já funciona e coincidem com o relatório. Semanas 1–2: produto e dados revisam perguntas e indicadores com usuários. Semanas 3–4: dados e testes ampliam a auditoria, conciliam totais e repetem a carga. Semanas 5–8: desenvolvimento melhora a usabilidade, com uma jornada executável por usuário externo. Semanas 9–12: dados e desenvolvimento integram 2025 somente com períodos e medidas comparáveis. Semanas 13–14: testes e produto validam uso e dados expostos. Semanas 15–16: toda a equipe entrega o piloto, a documentação e o pacote reproduzível, sem pendências críticas. Se 2025 ou uma integração atrasar, manter o conjunto validado de 2024 e registrar o recorte. O enunciado exige 5 a 8 estudantes. A composição atual informada tem quatro e precisa de alinhamento com o professor.</a:t>
             </a:r>
           </a:p>
           <a:p xmlns:a="http://schemas.openxmlformats.org/drawingml/2006/main">
@@ -1257,7 +1257,7 @@
   </p:cSld>
   <p:clrMap bg1="lt1" tx1="dk1" bg2="lt2" tx2="dk2" accent1="accent1" accent2="accent2" accent3="accent3" accent4="accent4" accent5="accent5" accent6="accent6" hlink="hlink" folHlink="folHlink"/>
   <p:sldLayoutIdLst>
-    <p:sldLayoutId xmlns:r="http://schemas.openxmlformats.org/officeDocument/2006/relationships" id="2147483649" r:id="R8b5a8b428d1a43b5"/>
+    <p:sldLayoutId xmlns:r="http://schemas.openxmlformats.org/officeDocument/2006/relationships" id="2147483649" r:id="Rd28bbf5d344c4436"/>
   </p:sldLayoutIdLst>
   <p:txStyles>
     <p:titleStyle>
@@ -2265,7 +2265,7 @@
           <p:cNvPr id="9" name="">
             <a:extLst xmlns:a="http://schemas.openxmlformats.org/drawingml/2006/main">
               <a:ext uri="{FF2B5EF4-FFF2-40B4-BE49-F238E27FC236}">
-                <a16:creationId xmlns:a16="http://schemas.microsoft.com/office/drawing/2014/main" id="{DA3D522E-6E80-48CB-A0D4-EF6C223DB6EA}"/>
+                <a16:creationId xmlns:a16="http://schemas.microsoft.com/office/drawing/2014/main" id="{6F84DEA8-7050-4546-B212-05D5FFFB2462}"/>
               </a:ext>
             </a:extLst>
           </p:cNvPr>
@@ -2322,7 +2322,7 @@
           <p:cNvPr id="2" name="">
             <a:extLst xmlns:a="http://schemas.openxmlformats.org/drawingml/2006/main">
               <a:ext uri="{FF2B5EF4-FFF2-40B4-BE49-F238E27FC236}">
-                <a16:creationId xmlns:a16="http://schemas.microsoft.com/office/drawing/2014/main" id="{CAF20473-F463-4686-AA0C-FCCA477DC548}"/>
+                <a16:creationId xmlns:a16="http://schemas.microsoft.com/office/drawing/2014/main" id="{0BE34AD0-CDFC-4FE2-BF73-F7F14DB0E92B}"/>
               </a:ext>
             </a:extLst>
           </p:cNvPr>
@@ -2379,7 +2379,7 @@
           <p:cNvPr id="3" name="">
             <a:extLst xmlns:a="http://schemas.openxmlformats.org/drawingml/2006/main">
               <a:ext uri="{FF2B5EF4-FFF2-40B4-BE49-F238E27FC236}">
-                <a16:creationId xmlns:a16="http://schemas.microsoft.com/office/drawing/2014/main" id="{A7D8B36E-E051-4B4D-93CB-DD7F9C34ECDE}"/>
+                <a16:creationId xmlns:a16="http://schemas.microsoft.com/office/drawing/2014/main" id="{26FFFFBF-E6EF-4D85-871B-3D9EE5A2B9E9}"/>
               </a:ext>
             </a:extLst>
           </p:cNvPr>
@@ -2436,7 +2436,7 @@
           <p:cNvPr id="4" name="">
             <a:extLst xmlns:a="http://schemas.openxmlformats.org/drawingml/2006/main">
               <a:ext uri="{FF2B5EF4-FFF2-40B4-BE49-F238E27FC236}">
-                <a16:creationId xmlns:a16="http://schemas.microsoft.com/office/drawing/2014/main" id="{F4EA1704-C6F3-41DE-AFBE-2FF59486141A}"/>
+                <a16:creationId xmlns:a16="http://schemas.microsoft.com/office/drawing/2014/main" id="{431C86AB-5252-40E7-BC22-97DBB6C0E9C2}"/>
               </a:ext>
             </a:extLst>
           </p:cNvPr>
@@ -2493,7 +2493,7 @@
           <p:cNvPr id="5" name="">
             <a:extLst xmlns:a="http://schemas.openxmlformats.org/drawingml/2006/main">
               <a:ext uri="{FF2B5EF4-FFF2-40B4-BE49-F238E27FC236}">
-                <a16:creationId xmlns:a16="http://schemas.microsoft.com/office/drawing/2014/main" id="{8FC35B88-803F-46FC-AB05-955D24B5A61E}"/>
+                <a16:creationId xmlns:a16="http://schemas.microsoft.com/office/drawing/2014/main" id="{D4668DC5-C046-4D37-98E4-35B524325F21}"/>
               </a:ext>
             </a:extLst>
           </p:cNvPr>
@@ -2573,7 +2573,7 @@
           <p:cNvPr id="6" name="">
             <a:extLst xmlns:a="http://schemas.openxmlformats.org/drawingml/2006/main">
               <a:ext uri="{FF2B5EF4-FFF2-40B4-BE49-F238E27FC236}">
-                <a16:creationId xmlns:a16="http://schemas.microsoft.com/office/drawing/2014/main" id="{0695035B-CD0E-4D9E-B7E0-33141E27C758}"/>
+                <a16:creationId xmlns:a16="http://schemas.microsoft.com/office/drawing/2014/main" id="{6F4C0DFB-039E-4784-A42B-6BF75126183F}"/>
               </a:ext>
             </a:extLst>
           </p:cNvPr>
@@ -2630,7 +2630,7 @@
           <p:cNvPr id="7" name="">
             <a:extLst xmlns:a="http://schemas.openxmlformats.org/drawingml/2006/main">
               <a:ext uri="{FF2B5EF4-FFF2-40B4-BE49-F238E27FC236}">
-                <a16:creationId xmlns:a16="http://schemas.microsoft.com/office/drawing/2014/main" id="{03F92E32-4B33-44BB-B45A-41A0559B3FA5}"/>
+                <a16:creationId xmlns:a16="http://schemas.microsoft.com/office/drawing/2014/main" id="{A6BCAFE0-0586-488A-AB31-0458369F0ABA}"/>
               </a:ext>
             </a:extLst>
           </p:cNvPr>
@@ -2710,7 +2710,7 @@
           <p:cNvPr id="8" name="">
             <a:extLst xmlns:a="http://schemas.openxmlformats.org/drawingml/2006/main">
               <a:ext uri="{FF2B5EF4-FFF2-40B4-BE49-F238E27FC236}">
-                <a16:creationId xmlns:a16="http://schemas.microsoft.com/office/drawing/2014/main" id="{856446F0-53BE-4173-A2D4-E6D6676C79F5}"/>
+                <a16:creationId xmlns:a16="http://schemas.microsoft.com/office/drawing/2014/main" id="{4A6A00E3-02C1-4540-B23F-2306F9A1DAB4}"/>
               </a:ext>
             </a:extLst>
           </p:cNvPr>
@@ -2765,7 +2765,7 @@
     </p:spTree>
     <p:extLst>
       <p:ext uri="{BB962C8B-B14F-4D97-AF65-F5344CB8AC3E}">
-        <p14:creationId xmlns:p14="http://schemas.microsoft.com/office/powerpoint/2010/main" val="399728702"/>
+        <p14:creationId xmlns:p14="http://schemas.microsoft.com/office/powerpoint/2010/main" val="936844338"/>
       </p:ext>
     </p:extLst>
   </p:cSld>
@@ -2796,7 +2796,7 @@
           <p:cNvPr id="9" name="">
             <a:extLst xmlns:a="http://schemas.openxmlformats.org/drawingml/2006/main">
               <a:ext uri="{FF2B5EF4-FFF2-40B4-BE49-F238E27FC236}">
-                <a16:creationId xmlns:a16="http://schemas.microsoft.com/office/drawing/2014/main" id="{F10AFE7F-3071-4BB2-A8BC-45DDC9986C66}"/>
+                <a16:creationId xmlns:a16="http://schemas.microsoft.com/office/drawing/2014/main" id="{306D3475-75B5-48FF-A6FB-30DD056F424F}"/>
               </a:ext>
             </a:extLst>
           </p:cNvPr>
@@ -2853,7 +2853,7 @@
           <p:cNvPr id="2" name="">
             <a:extLst xmlns:a="http://schemas.openxmlformats.org/drawingml/2006/main">
               <a:ext uri="{FF2B5EF4-FFF2-40B4-BE49-F238E27FC236}">
-                <a16:creationId xmlns:a16="http://schemas.microsoft.com/office/drawing/2014/main" id="{3FD1CB32-D5D4-4F90-9B66-5A77A80F9CC0}"/>
+                <a16:creationId xmlns:a16="http://schemas.microsoft.com/office/drawing/2014/main" id="{3B11E1C3-ED76-410B-AAD1-ADCC33747870}"/>
               </a:ext>
             </a:extLst>
           </p:cNvPr>
@@ -2910,7 +2910,7 @@
           <p:cNvPr id="3" name="">
             <a:extLst xmlns:a="http://schemas.openxmlformats.org/drawingml/2006/main">
               <a:ext uri="{FF2B5EF4-FFF2-40B4-BE49-F238E27FC236}">
-                <a16:creationId xmlns:a16="http://schemas.microsoft.com/office/drawing/2014/main" id="{AD4920D7-87BC-41CD-8FAE-2AC07CFF47B3}"/>
+                <a16:creationId xmlns:a16="http://schemas.microsoft.com/office/drawing/2014/main" id="{34E178B9-C03C-4983-89B7-050C8DEC05F1}"/>
               </a:ext>
             </a:extLst>
           </p:cNvPr>
@@ -2967,7 +2967,7 @@
           <p:cNvPr id="4" name="">
             <a:extLst xmlns:a="http://schemas.openxmlformats.org/drawingml/2006/main">
               <a:ext uri="{FF2B5EF4-FFF2-40B4-BE49-F238E27FC236}">
-                <a16:creationId xmlns:a16="http://schemas.microsoft.com/office/drawing/2014/main" id="{AC1B5900-B3BB-40CB-BAC8-D4E590A8BC73}"/>
+                <a16:creationId xmlns:a16="http://schemas.microsoft.com/office/drawing/2014/main" id="{6F42315F-551B-4001-B582-403CF92D4A65}"/>
               </a:ext>
             </a:extLst>
           </p:cNvPr>
@@ -3024,7 +3024,7 @@
           <p:cNvPr id="5" name="">
             <a:extLst xmlns:a="http://schemas.openxmlformats.org/drawingml/2006/main">
               <a:ext uri="{FF2B5EF4-FFF2-40B4-BE49-F238E27FC236}">
-                <a16:creationId xmlns:a16="http://schemas.microsoft.com/office/drawing/2014/main" id="{0B21AFEE-15BE-4536-9EF2-6BFC5A5963A3}"/>
+                <a16:creationId xmlns:a16="http://schemas.microsoft.com/office/drawing/2014/main" id="{1611B439-9B6C-49E4-B33C-A724E36437B2}"/>
               </a:ext>
             </a:extLst>
           </p:cNvPr>
@@ -3427,7 +3427,7 @@
           <p:cNvPr id="7" name="">
             <a:extLst xmlns:a="http://schemas.openxmlformats.org/drawingml/2006/main">
               <a:ext uri="{FF2B5EF4-FFF2-40B4-BE49-F238E27FC236}">
-                <a16:creationId xmlns:a16="http://schemas.microsoft.com/office/drawing/2014/main" id="{BE167533-955B-4F88-A792-4A502791EFAA}"/>
+                <a16:creationId xmlns:a16="http://schemas.microsoft.com/office/drawing/2014/main" id="{0E2DC272-A399-41E0-8A6A-7862CF4A7163}"/>
               </a:ext>
             </a:extLst>
           </p:cNvPr>
@@ -3484,7 +3484,7 @@
           <p:cNvPr id="8" name="">
             <a:extLst xmlns:a="http://schemas.openxmlformats.org/drawingml/2006/main">
               <a:ext uri="{FF2B5EF4-FFF2-40B4-BE49-F238E27FC236}">
-                <a16:creationId xmlns:a16="http://schemas.microsoft.com/office/drawing/2014/main" id="{728FF99A-F5CE-485C-816B-8C1A21BDA841}"/>
+                <a16:creationId xmlns:a16="http://schemas.microsoft.com/office/drawing/2014/main" id="{846C051C-9491-44FB-855E-AA2F9A5F7F3E}"/>
               </a:ext>
             </a:extLst>
           </p:cNvPr>
@@ -3539,7 +3539,7 @@
     </p:spTree>
     <p:extLst>
       <p:ext uri="{BB962C8B-B14F-4D97-AF65-F5344CB8AC3E}">
-        <p14:creationId xmlns:p14="http://schemas.microsoft.com/office/powerpoint/2010/main" val="51304330"/>
+        <p14:creationId xmlns:p14="http://schemas.microsoft.com/office/powerpoint/2010/main" val="1911059621"/>
       </p:ext>
     </p:extLst>
   </p:cSld>
@@ -3570,7 +3570,7 @@
           <p:cNvPr id="9" name="">
             <a:extLst xmlns:a="http://schemas.openxmlformats.org/drawingml/2006/main">
               <a:ext uri="{FF2B5EF4-FFF2-40B4-BE49-F238E27FC236}">
-                <a16:creationId xmlns:a16="http://schemas.microsoft.com/office/drawing/2014/main" id="{15C44E6E-FBE4-44B1-9C52-E7FAD4FF5E38}"/>
+                <a16:creationId xmlns:a16="http://schemas.microsoft.com/office/drawing/2014/main" id="{DF4CE51D-590B-4978-8B9E-2ED73E7C5CD8}"/>
               </a:ext>
             </a:extLst>
           </p:cNvPr>
@@ -3627,7 +3627,7 @@
           <p:cNvPr id="2" name="">
             <a:extLst xmlns:a="http://schemas.openxmlformats.org/drawingml/2006/main">
               <a:ext uri="{FF2B5EF4-FFF2-40B4-BE49-F238E27FC236}">
-                <a16:creationId xmlns:a16="http://schemas.microsoft.com/office/drawing/2014/main" id="{5B69AC4E-C372-4612-B1BC-7A505053773E}"/>
+                <a16:creationId xmlns:a16="http://schemas.microsoft.com/office/drawing/2014/main" id="{DAEA6E39-5CCC-4C4F-8E15-AC3283D802EF}"/>
               </a:ext>
             </a:extLst>
           </p:cNvPr>
@@ -3684,7 +3684,7 @@
           <p:cNvPr id="3" name="">
             <a:extLst xmlns:a="http://schemas.openxmlformats.org/drawingml/2006/main">
               <a:ext uri="{FF2B5EF4-FFF2-40B4-BE49-F238E27FC236}">
-                <a16:creationId xmlns:a16="http://schemas.microsoft.com/office/drawing/2014/main" id="{C93D914A-2462-4C6B-8E6F-1219C3B229A2}"/>
+                <a16:creationId xmlns:a16="http://schemas.microsoft.com/office/drawing/2014/main" id="{CA5271AB-D145-48EC-B90B-B038ACF950A2}"/>
               </a:ext>
             </a:extLst>
           </p:cNvPr>
@@ -3748,7 +3748,7 @@
         </p:xfrm>
         <a:graphic xmlns:a="http://schemas.openxmlformats.org/drawingml/2006/main">
           <a:graphicData uri="http://schemas.openxmlformats.org/drawingml/2006/chart">
-            <c:chart xmlns:r="http://schemas.openxmlformats.org/officeDocument/2006/relationships" xmlns:c="http://schemas.openxmlformats.org/drawingml/2006/chart" r:id="Rbdbc7d8e326a4ec0"/>
+            <c:chart xmlns:r="http://schemas.openxmlformats.org/officeDocument/2006/relationships" xmlns:c="http://schemas.openxmlformats.org/drawingml/2006/chart" r:id="Re839f346741d4800"/>
           </a:graphicData>
         </a:graphic>
       </p:graphicFrame>
@@ -3757,7 +3757,7 @@
           <p:cNvPr id="5" name="">
             <a:extLst xmlns:a="http://schemas.openxmlformats.org/drawingml/2006/main">
               <a:ext uri="{FF2B5EF4-FFF2-40B4-BE49-F238E27FC236}">
-                <a16:creationId xmlns:a16="http://schemas.microsoft.com/office/drawing/2014/main" id="{7B4CBE70-D2C2-4EFA-AB99-B25EECC17777}"/>
+                <a16:creationId xmlns:a16="http://schemas.microsoft.com/office/drawing/2014/main" id="{FAE7C030-76D1-4147-8D97-3D9B8AE6256D}"/>
               </a:ext>
             </a:extLst>
           </p:cNvPr>
@@ -3837,7 +3837,7 @@
           <p:cNvPr id="6" name="">
             <a:extLst xmlns:a="http://schemas.openxmlformats.org/drawingml/2006/main">
               <a:ext uri="{FF2B5EF4-FFF2-40B4-BE49-F238E27FC236}">
-                <a16:creationId xmlns:a16="http://schemas.microsoft.com/office/drawing/2014/main" id="{D3296671-BAAC-4B0F-8257-F1B1EEFDEBB2}"/>
+                <a16:creationId xmlns:a16="http://schemas.microsoft.com/office/drawing/2014/main" id="{4904999C-6451-403A-B245-49A5ED1D9302}"/>
               </a:ext>
             </a:extLst>
           </p:cNvPr>
@@ -3894,7 +3894,7 @@
           <p:cNvPr id="7" name="">
             <a:extLst xmlns:a="http://schemas.openxmlformats.org/drawingml/2006/main">
               <a:ext uri="{FF2B5EF4-FFF2-40B4-BE49-F238E27FC236}">
-                <a16:creationId xmlns:a16="http://schemas.microsoft.com/office/drawing/2014/main" id="{D8C87B06-8E43-4549-BBB9-B0E4C0F6F61E}"/>
+                <a16:creationId xmlns:a16="http://schemas.microsoft.com/office/drawing/2014/main" id="{A183D704-43D6-4428-BF3C-ADC845515C55}"/>
               </a:ext>
             </a:extLst>
           </p:cNvPr>
@@ -3951,7 +3951,7 @@
           <p:cNvPr id="8" name="">
             <a:extLst xmlns:a="http://schemas.openxmlformats.org/drawingml/2006/main">
               <a:ext uri="{FF2B5EF4-FFF2-40B4-BE49-F238E27FC236}">
-                <a16:creationId xmlns:a16="http://schemas.microsoft.com/office/drawing/2014/main" id="{A4C3D10E-9041-447D-BFA6-BD8B07AE4946}"/>
+                <a16:creationId xmlns:a16="http://schemas.microsoft.com/office/drawing/2014/main" id="{B5BB5AB0-BCD8-4E7A-B0CF-F52B70D9187B}"/>
               </a:ext>
             </a:extLst>
           </p:cNvPr>
@@ -4006,7 +4006,7 @@
     </p:spTree>
     <p:extLst>
       <p:ext uri="{BB962C8B-B14F-4D97-AF65-F5344CB8AC3E}">
-        <p14:creationId xmlns:p14="http://schemas.microsoft.com/office/powerpoint/2010/main" val="1186737828"/>
+        <p14:creationId xmlns:p14="http://schemas.microsoft.com/office/powerpoint/2010/main" val="802329555"/>
       </p:ext>
     </p:extLst>
   </p:cSld>
@@ -4037,7 +4037,7 @@
           <p:cNvPr id="10" name="">
             <a:extLst xmlns:a="http://schemas.openxmlformats.org/drawingml/2006/main">
               <a:ext uri="{FF2B5EF4-FFF2-40B4-BE49-F238E27FC236}">
-                <a16:creationId xmlns:a16="http://schemas.microsoft.com/office/drawing/2014/main" id="{28744D8F-A794-4D06-A52E-83ADFAC1DC27}"/>
+                <a16:creationId xmlns:a16="http://schemas.microsoft.com/office/drawing/2014/main" id="{AECD41B2-536B-4A0C-AC81-45DB445059EB}"/>
               </a:ext>
             </a:extLst>
           </p:cNvPr>
@@ -4094,7 +4094,7 @@
           <p:cNvPr id="2" name="">
             <a:extLst xmlns:a="http://schemas.openxmlformats.org/drawingml/2006/main">
               <a:ext uri="{FF2B5EF4-FFF2-40B4-BE49-F238E27FC236}">
-                <a16:creationId xmlns:a16="http://schemas.microsoft.com/office/drawing/2014/main" id="{8FF53117-8A55-4601-9564-89D74D57CA93}"/>
+                <a16:creationId xmlns:a16="http://schemas.microsoft.com/office/drawing/2014/main" id="{A733F187-FE7C-4635-B887-08C34312704B}"/>
               </a:ext>
             </a:extLst>
           </p:cNvPr>
@@ -4151,7 +4151,7 @@
           <p:cNvPr id="3" name="">
             <a:extLst xmlns:a="http://schemas.openxmlformats.org/drawingml/2006/main">
               <a:ext uri="{FF2B5EF4-FFF2-40B4-BE49-F238E27FC236}">
-                <a16:creationId xmlns:a16="http://schemas.microsoft.com/office/drawing/2014/main" id="{14EFF4EA-39BD-47DF-B0A0-E9655586628E}"/>
+                <a16:creationId xmlns:a16="http://schemas.microsoft.com/office/drawing/2014/main" id="{2B0EBFA3-5FC6-403D-BC70-9B17C1DCAF1D}"/>
               </a:ext>
             </a:extLst>
           </p:cNvPr>
@@ -4215,7 +4215,7 @@
         </p:xfrm>
         <a:graphic xmlns:a="http://schemas.openxmlformats.org/drawingml/2006/main">
           <a:graphicData uri="http://schemas.openxmlformats.org/drawingml/2006/chart">
-            <c:chart xmlns:r="http://schemas.openxmlformats.org/officeDocument/2006/relationships" xmlns:c="http://schemas.openxmlformats.org/drawingml/2006/chart" r:id="Rc5e4bc72a8a84170"/>
+            <c:chart xmlns:r="http://schemas.openxmlformats.org/officeDocument/2006/relationships" xmlns:c="http://schemas.openxmlformats.org/drawingml/2006/chart" r:id="R92ea2ab05b0b4275"/>
           </a:graphicData>
         </a:graphic>
       </p:graphicFrame>
@@ -4224,7 +4224,7 @@
           <p:cNvPr id="5" name="">
             <a:extLst xmlns:a="http://schemas.openxmlformats.org/drawingml/2006/main">
               <a:ext uri="{FF2B5EF4-FFF2-40B4-BE49-F238E27FC236}">
-                <a16:creationId xmlns:a16="http://schemas.microsoft.com/office/drawing/2014/main" id="{9F71C95E-9B99-4967-8356-33F1D7DFB26A}"/>
+                <a16:creationId xmlns:a16="http://schemas.microsoft.com/office/drawing/2014/main" id="{CCB1DE0B-1C8C-4AEB-BEFA-4874B462E05E}"/>
               </a:ext>
             </a:extLst>
           </p:cNvPr>
@@ -4281,7 +4281,7 @@
           <p:cNvPr id="6" name="">
             <a:extLst xmlns:a="http://schemas.openxmlformats.org/drawingml/2006/main">
               <a:ext uri="{FF2B5EF4-FFF2-40B4-BE49-F238E27FC236}">
-                <a16:creationId xmlns:a16="http://schemas.microsoft.com/office/drawing/2014/main" id="{45AFCC43-309C-4E3A-BE5A-F2089F3D7208}"/>
+                <a16:creationId xmlns:a16="http://schemas.microsoft.com/office/drawing/2014/main" id="{3EC96E6E-25E9-465F-BE82-63C594FD20B8}"/>
               </a:ext>
             </a:extLst>
           </p:cNvPr>
@@ -4384,7 +4384,7 @@
           <p:cNvPr id="7" name="">
             <a:extLst xmlns:a="http://schemas.openxmlformats.org/drawingml/2006/main">
               <a:ext uri="{FF2B5EF4-FFF2-40B4-BE49-F238E27FC236}">
-                <a16:creationId xmlns:a16="http://schemas.microsoft.com/office/drawing/2014/main" id="{57AFA5EE-3F98-40C9-98FF-A74CBA247025}"/>
+                <a16:creationId xmlns:a16="http://schemas.microsoft.com/office/drawing/2014/main" id="{7E2FFD40-28FA-46D0-BF40-AB4D850BE394}"/>
               </a:ext>
             </a:extLst>
           </p:cNvPr>
@@ -4441,7 +4441,7 @@
           <p:cNvPr id="8" name="">
             <a:extLst xmlns:a="http://schemas.openxmlformats.org/drawingml/2006/main">
               <a:ext uri="{FF2B5EF4-FFF2-40B4-BE49-F238E27FC236}">
-                <a16:creationId xmlns:a16="http://schemas.microsoft.com/office/drawing/2014/main" id="{23892941-A10C-49C1-A30B-277B73ADCC20}"/>
+                <a16:creationId xmlns:a16="http://schemas.microsoft.com/office/drawing/2014/main" id="{EC03EB50-9A92-4114-9274-8DAB38502057}"/>
               </a:ext>
             </a:extLst>
           </p:cNvPr>
@@ -4521,7 +4521,7 @@
           <p:cNvPr id="9" name="">
             <a:extLst xmlns:a="http://schemas.openxmlformats.org/drawingml/2006/main">
               <a:ext uri="{FF2B5EF4-FFF2-40B4-BE49-F238E27FC236}">
-                <a16:creationId xmlns:a16="http://schemas.microsoft.com/office/drawing/2014/main" id="{5D6A73D1-5A49-402B-AC56-E61294B86AEF}"/>
+                <a16:creationId xmlns:a16="http://schemas.microsoft.com/office/drawing/2014/main" id="{48F62FB7-AB2A-4834-AC5F-4F9BD4A9C863}"/>
               </a:ext>
             </a:extLst>
           </p:cNvPr>
@@ -4576,7 +4576,7 @@
     </p:spTree>
     <p:extLst>
       <p:ext uri="{BB962C8B-B14F-4D97-AF65-F5344CB8AC3E}">
-        <p14:creationId xmlns:p14="http://schemas.microsoft.com/office/powerpoint/2010/main" val="56739213"/>
+        <p14:creationId xmlns:p14="http://schemas.microsoft.com/office/powerpoint/2010/main" val="38195640"/>
       </p:ext>
     </p:extLst>
   </p:cSld>
@@ -4607,7 +4607,7 @@
           <p:cNvPr id="8" name="">
             <a:extLst xmlns:a="http://schemas.openxmlformats.org/drawingml/2006/main">
               <a:ext uri="{FF2B5EF4-FFF2-40B4-BE49-F238E27FC236}">
-                <a16:creationId xmlns:a16="http://schemas.microsoft.com/office/drawing/2014/main" id="{DA6C10DC-F4D3-45BE-AA56-11C42FB3BC4D}"/>
+                <a16:creationId xmlns:a16="http://schemas.microsoft.com/office/drawing/2014/main" id="{3DFC7A29-45BA-4D43-87FD-A334C3221431}"/>
               </a:ext>
             </a:extLst>
           </p:cNvPr>
@@ -4664,7 +4664,7 @@
           <p:cNvPr id="2" name="">
             <a:extLst xmlns:a="http://schemas.openxmlformats.org/drawingml/2006/main">
               <a:ext uri="{FF2B5EF4-FFF2-40B4-BE49-F238E27FC236}">
-                <a16:creationId xmlns:a16="http://schemas.microsoft.com/office/drawing/2014/main" id="{8FAE51D0-38EF-4909-9824-DB08E6E7ED68}"/>
+                <a16:creationId xmlns:a16="http://schemas.microsoft.com/office/drawing/2014/main" id="{17574C84-49C0-4AF0-BD99-ECC4967EB680}"/>
               </a:ext>
             </a:extLst>
           </p:cNvPr>
@@ -5013,7 +5013,7 @@
           <p:cNvPr id="4" name="">
             <a:extLst xmlns:a="http://schemas.openxmlformats.org/drawingml/2006/main">
               <a:ext uri="{FF2B5EF4-FFF2-40B4-BE49-F238E27FC236}">
-                <a16:creationId xmlns:a16="http://schemas.microsoft.com/office/drawing/2014/main" id="{C27259EA-DFE7-4378-A718-095962F5F291}"/>
+                <a16:creationId xmlns:a16="http://schemas.microsoft.com/office/drawing/2014/main" id="{1F47D3F6-F4D0-410B-ADCC-99EC3E71D718}"/>
               </a:ext>
             </a:extLst>
           </p:cNvPr>
@@ -5070,7 +5070,7 @@
           <p:cNvPr id="5" name="">
             <a:extLst xmlns:a="http://schemas.openxmlformats.org/drawingml/2006/main">
               <a:ext uri="{FF2B5EF4-FFF2-40B4-BE49-F238E27FC236}">
-                <a16:creationId xmlns:a16="http://schemas.microsoft.com/office/drawing/2014/main" id="{5A5443B8-63EF-45F1-8927-668D43D453D4}"/>
+                <a16:creationId xmlns:a16="http://schemas.microsoft.com/office/drawing/2014/main" id="{6E0C341A-2934-445F-BB29-E299E0C9F2D0}"/>
               </a:ext>
             </a:extLst>
           </p:cNvPr>
@@ -5150,7 +5150,7 @@
           <p:cNvPr id="6" name="">
             <a:extLst xmlns:a="http://schemas.openxmlformats.org/drawingml/2006/main">
               <a:ext uri="{FF2B5EF4-FFF2-40B4-BE49-F238E27FC236}">
-                <a16:creationId xmlns:a16="http://schemas.microsoft.com/office/drawing/2014/main" id="{C0D9D522-663D-4F9D-9B35-4D1E2E8471F7}"/>
+                <a16:creationId xmlns:a16="http://schemas.microsoft.com/office/drawing/2014/main" id="{D9409559-1A9E-42F2-BE84-5F6D0AC4D330}"/>
               </a:ext>
             </a:extLst>
           </p:cNvPr>
@@ -5207,7 +5207,7 @@
           <p:cNvPr id="7" name="">
             <a:extLst xmlns:a="http://schemas.openxmlformats.org/drawingml/2006/main">
               <a:ext uri="{FF2B5EF4-FFF2-40B4-BE49-F238E27FC236}">
-                <a16:creationId xmlns:a16="http://schemas.microsoft.com/office/drawing/2014/main" id="{AF34D215-3F1D-4782-ADE7-798345B28651}"/>
+                <a16:creationId xmlns:a16="http://schemas.microsoft.com/office/drawing/2014/main" id="{BB9EB03A-0C90-4F38-A830-60612F6FF87B}"/>
               </a:ext>
             </a:extLst>
           </p:cNvPr>
@@ -5262,7 +5262,7 @@
     </p:spTree>
     <p:extLst>
       <p:ext uri="{BB962C8B-B14F-4D97-AF65-F5344CB8AC3E}">
-        <p14:creationId xmlns:p14="http://schemas.microsoft.com/office/powerpoint/2010/main" val="525012404"/>
+        <p14:creationId xmlns:p14="http://schemas.microsoft.com/office/powerpoint/2010/main" val="446818158"/>
       </p:ext>
     </p:extLst>
   </p:cSld>
@@ -5293,7 +5293,7 @@
           <p:cNvPr id="6" name="">
             <a:extLst xmlns:a="http://schemas.openxmlformats.org/drawingml/2006/main">
               <a:ext uri="{FF2B5EF4-FFF2-40B4-BE49-F238E27FC236}">
-                <a16:creationId xmlns:a16="http://schemas.microsoft.com/office/drawing/2014/main" id="{EACAD6A8-C98D-44BF-84F5-64B08EE4AB5E}"/>
+                <a16:creationId xmlns:a16="http://schemas.microsoft.com/office/drawing/2014/main" id="{336B08F8-FDA2-4E47-ACF5-A894CAED2C45}"/>
               </a:ext>
             </a:extLst>
           </p:cNvPr>
@@ -5350,7 +5350,7 @@
           <p:cNvPr id="2" name="">
             <a:extLst xmlns:a="http://schemas.openxmlformats.org/drawingml/2006/main">
               <a:ext uri="{FF2B5EF4-FFF2-40B4-BE49-F238E27FC236}">
-                <a16:creationId xmlns:a16="http://schemas.microsoft.com/office/drawing/2014/main" id="{042414DC-0595-4820-9066-52A91564E011}"/>
+                <a16:creationId xmlns:a16="http://schemas.microsoft.com/office/drawing/2014/main" id="{C39E7EE8-2A7D-4D3B-8172-B8F24A6F11E5}"/>
               </a:ext>
             </a:extLst>
           </p:cNvPr>
@@ -5410,7 +5410,7 @@
         </p:nvGraphicFramePr>
         <p:xfrm>
           <a:off xmlns:a="http://schemas.openxmlformats.org/drawingml/2006/main" x="609600" y="1390650"/>
-          <a:ext xmlns:a="http://schemas.openxmlformats.org/drawingml/2006/main" cx="10972800" cy="2476500"/>
+          <a:ext xmlns:a="http://schemas.openxmlformats.org/drawingml/2006/main" cx="10972800" cy="2047875"/>
         </p:xfrm>
         <a:graphic xmlns:a="http://schemas.openxmlformats.org/drawingml/2006/main">
           <a:graphicData uri="http://schemas.openxmlformats.org/drawingml/2006/table">
@@ -5421,7 +5421,7 @@
                 <a:gridCol w="4448175"/>
                 <a:gridCol w="3810000"/>
               </a:tblGrid>
-              <a:tr h="495300">
+              <a:tr h="409575">
                 <a:tc>
                   <a:txBody>
                     <a:bodyPr lIns="114300" tIns="76200" rIns="114300" bIns="76200">
@@ -5501,7 +5501,7 @@
                   </a:tcPr>
                 </a:tc>
               </a:tr>
-              <a:tr h="495300">
+              <a:tr h="409575">
                 <a:tc>
                   <a:txBody>
                     <a:bodyPr lIns="114300" tIns="76200" rIns="114300" bIns="76200">
@@ -5581,7 +5581,7 @@
                   </a:tcPr>
                 </a:tc>
               </a:tr>
-              <a:tr h="495300">
+              <a:tr h="409575">
                 <a:tc>
                   <a:txBody>
                     <a:bodyPr lIns="114300" tIns="76200" rIns="114300" bIns="76200">
@@ -5661,7 +5661,7 @@
                   </a:tcPr>
                 </a:tc>
               </a:tr>
-              <a:tr h="495300">
+              <a:tr h="409575">
                 <a:tc>
                   <a:txBody>
                     <a:bodyPr lIns="114300" tIns="76200" rIns="114300" bIns="76200">
@@ -5741,7 +5741,7 @@
                   </a:tcPr>
                 </a:tc>
               </a:tr>
-              <a:tr h="495300">
+              <a:tr h="409575">
                 <a:tc>
                   <a:txBody>
                     <a:bodyPr lIns="114300" tIns="76200" rIns="114300" bIns="76200">
@@ -5832,8 +5832,8 @@
           <p:nvPr/>
         </p:nvGraphicFramePr>
         <p:xfrm>
-          <a:off xmlns:a="http://schemas.openxmlformats.org/drawingml/2006/main" x="609600" y="4219575"/>
-          <a:ext xmlns:a="http://schemas.openxmlformats.org/drawingml/2006/main" cx="10972800" cy="1952625"/>
+          <a:off xmlns:a="http://schemas.openxmlformats.org/drawingml/2006/main" x="609600" y="3619500"/>
+          <a:ext xmlns:a="http://schemas.openxmlformats.org/drawingml/2006/main" cx="10972800" cy="2524125"/>
         </p:xfrm>
         <a:graphic xmlns:a="http://schemas.openxmlformats.org/drawingml/2006/main">
           <a:graphicData uri="http://schemas.openxmlformats.org/drawingml/2006/table">
@@ -5844,7 +5844,7 @@
                 <a:gridCol w="2857500"/>
                 <a:gridCol w="6591300"/>
               </a:tblGrid>
-              <a:tr h="390525">
+              <a:tr h="360589">
                 <a:tc>
                   <a:txBody>
                     <a:bodyPr lIns="114300" tIns="76200" rIns="114300" bIns="76200">
@@ -5924,7 +5924,7 @@
                   </a:tcPr>
                 </a:tc>
               </a:tr>
-              <a:tr h="390525">
+              <a:tr h="360589">
                 <a:tc>
                   <a:txBody>
                     <a:bodyPr lIns="114300" tIns="76200" rIns="114300" bIns="76200">
@@ -5967,7 +5967,7 @@
                           <a:ea typeface="Arial"/>
                           <a:cs typeface="Arial"/>
                         </a:rPr>
-                        <a:t>Escopo e regras</a:t>
+                        <a:t>Validação com usuários</a:t>
                       </a:r>
                     </a:p>
                   </a:txBody>
@@ -5993,7 +5993,7 @@
                           <a:ea typeface="Arial"/>
                           <a:cs typeface="Arial"/>
                         </a:rPr>
-                        <a:t>Perguntas e recortes aprovados</a:t>
+                        <a:t>POC atual, perguntas e indicadores aprovados</a:t>
                       </a:r>
                     </a:p>
                   </a:txBody>
@@ -6004,7 +6004,7 @@
                   </a:tcPr>
                 </a:tc>
               </a:tr>
-              <a:tr h="390525">
+              <a:tr h="360589">
                 <a:tc>
                   <a:txBody>
                     <a:bodyPr lIns="114300" tIns="76200" rIns="114300" bIns="76200">
@@ -6021,7 +6021,7 @@
                           <a:ea typeface="Arial"/>
                           <a:cs typeface="Arial"/>
                         </a:rPr>
-                        <a:t>3–5</a:t>
+                        <a:t>3–4</a:t>
                       </a:r>
                     </a:p>
                   </a:txBody>
@@ -6047,7 +6047,7 @@
                           <a:ea typeface="Arial"/>
                           <a:cs typeface="Arial"/>
                         </a:rPr>
-                        <a:t>Pipeline</a:t>
+                        <a:t>Auditoria ampliada</a:t>
                       </a:r>
                     </a:p>
                   </a:txBody>
@@ -6073,7 +6073,7 @@
                           <a:ea typeface="Arial"/>
                           <a:cs typeface="Arial"/>
                         </a:rPr>
-                        <a:t>Esquema validado, total conciliado</a:t>
+                        <a:t>Requisitos revistos, totais conciliados e carga repetível</a:t>
                       </a:r>
                     </a:p>
                   </a:txBody>
@@ -6084,7 +6084,7 @@
                   </a:tcPr>
                 </a:tc>
               </a:tr>
-              <a:tr h="390525">
+              <a:tr h="360589">
                 <a:tc>
                   <a:txBody>
                     <a:bodyPr lIns="114300" tIns="76200" rIns="114300" bIns="76200">
@@ -6101,7 +6101,7 @@
                           <a:ea typeface="Arial"/>
                           <a:cs typeface="Arial"/>
                         </a:rPr>
-                        <a:t>6–10</a:t>
+                        <a:t>5–8</a:t>
                       </a:r>
                     </a:p>
                   </a:txBody>
@@ -6127,7 +6127,7 @@
                           <a:ea typeface="Arial"/>
                           <a:cs typeface="Arial"/>
                         </a:rPr>
-                        <a:t>POC integrada</a:t>
+                        <a:t>Usabilidade</a:t>
                       </a:r>
                     </a:p>
                   </a:txBody>
@@ -6153,7 +6153,7 @@
                           <a:ea typeface="Arial"/>
                           <a:cs typeface="Arial"/>
                         </a:rPr>
-                        <a:t>Dados prontos, jornada completa</a:t>
+                        <a:t>Base pronta, jornada por usuário externo</a:t>
                       </a:r>
                     </a:p>
                   </a:txBody>
@@ -6164,7 +6164,7 @@
                   </a:tcPr>
                 </a:tc>
               </a:tr>
-              <a:tr h="390525">
+              <a:tr h="360589">
                 <a:tc>
                   <a:txBody>
                     <a:bodyPr lIns="114300" tIns="76200" rIns="114300" bIns="76200">
@@ -6181,7 +6181,7 @@
                           <a:ea typeface="Arial"/>
                           <a:cs typeface="Arial"/>
                         </a:rPr>
-                        <a:t>11–16</a:t>
+                        <a:t>9–12</a:t>
                       </a:r>
                     </a:p>
                   </a:txBody>
@@ -6207,7 +6207,7 @@
                           <a:ea typeface="Arial"/>
                           <a:cs typeface="Arial"/>
                         </a:rPr>
-                        <a:t>Validação e implantação</a:t>
+                        <a:t>Comparação com 2025</a:t>
                       </a:r>
                     </a:p>
                   </a:txBody>
@@ -6233,7 +6233,167 @@
                           <a:ea typeface="Arial"/>
                           <a:cs typeface="Arial"/>
                         </a:rPr>
-                        <a:t>Jornada testada, reprodução documentada</a:t>
+                        <a:t>2025 comparável, medidas e períodos equivalentes</a:t>
+                      </a:r>
+                    </a:p>
+                  </a:txBody>
+                  <a:tcPr marL="91440" marR="91440" marT="45720" marB="45720">
+                    <a:solidFill>
+                      <a:srgbClr val="FFFFFF"/>
+                    </a:solidFill>
+                  </a:tcPr>
+                </a:tc>
+              </a:tr>
+              <a:tr h="360589">
+                <a:tc>
+                  <a:txBody>
+                    <a:bodyPr lIns="114300" tIns="76200" rIns="114300" bIns="76200">
+                      <a:noAutofit/>
+                    </a:bodyPr>
+                    <a:lstStyle/>
+                    <a:p>
+                      <a:r>
+                        <a:rPr sz="1650" b="0">
+                          <a:solidFill>
+                            <a:srgbClr val="122D3D"/>
+                          </a:solidFill>
+                          <a:latin typeface="Arial"/>
+                          <a:ea typeface="Arial"/>
+                          <a:cs typeface="Arial"/>
+                        </a:rPr>
+                        <a:t>13–14</a:t>
+                      </a:r>
+                    </a:p>
+                  </a:txBody>
+                  <a:tcPr marL="91440" marR="91440" marT="45720" marB="45720">
+                    <a:solidFill>
+                      <a:srgbClr val="FFFFFF"/>
+                    </a:solidFill>
+                  </a:tcPr>
+                </a:tc>
+                <a:tc>
+                  <a:txBody>
+                    <a:bodyPr lIns="114300" tIns="76200" rIns="114300" bIns="76200">
+                      <a:noAutofit/>
+                    </a:bodyPr>
+                    <a:lstStyle/>
+                    <a:p>
+                      <a:r>
+                        <a:rPr sz="1650" b="0">
+                          <a:solidFill>
+                            <a:srgbClr val="122D3D"/>
+                          </a:solidFill>
+                          <a:latin typeface="Arial"/>
+                          <a:ea typeface="Arial"/>
+                          <a:cs typeface="Arial"/>
+                        </a:rPr>
+                        <a:t>Validação integrada</a:t>
+                      </a:r>
+                    </a:p>
+                  </a:txBody>
+                  <a:tcPr marL="91440" marR="91440" marT="45720" marB="45720">
+                    <a:solidFill>
+                      <a:srgbClr val="FFFFFF"/>
+                    </a:solidFill>
+                  </a:tcPr>
+                </a:tc>
+                <a:tc>
+                  <a:txBody>
+                    <a:bodyPr lIns="114300" tIns="76200" rIns="114300" bIns="76200">
+                      <a:noAutofit/>
+                    </a:bodyPr>
+                    <a:lstStyle/>
+                    <a:p>
+                      <a:r>
+                        <a:rPr sz="1650" b="0">
+                          <a:solidFill>
+                            <a:srgbClr val="122D3D"/>
+                          </a:solidFill>
+                          <a:latin typeface="Arial"/>
+                          <a:ea typeface="Arial"/>
+                          <a:cs typeface="Arial"/>
+                        </a:rPr>
+                        <a:t>Versão integrada, revisão de uso e dados expostos</a:t>
+                      </a:r>
+                    </a:p>
+                  </a:txBody>
+                  <a:tcPr marL="91440" marR="91440" marT="45720" marB="45720">
+                    <a:solidFill>
+                      <a:srgbClr val="FFFFFF"/>
+                    </a:solidFill>
+                  </a:tcPr>
+                </a:tc>
+              </a:tr>
+              <a:tr h="360589">
+                <a:tc>
+                  <a:txBody>
+                    <a:bodyPr lIns="114300" tIns="76200" rIns="114300" bIns="76200">
+                      <a:noAutofit/>
+                    </a:bodyPr>
+                    <a:lstStyle/>
+                    <a:p>
+                      <a:r>
+                        <a:rPr sz="1650" b="0">
+                          <a:solidFill>
+                            <a:srgbClr val="122D3D"/>
+                          </a:solidFill>
+                          <a:latin typeface="Arial"/>
+                          <a:ea typeface="Arial"/>
+                          <a:cs typeface="Arial"/>
+                        </a:rPr>
+                        <a:t>15–16</a:t>
+                      </a:r>
+                    </a:p>
+                  </a:txBody>
+                  <a:tcPr marL="91440" marR="91440" marT="45720" marB="45720">
+                    <a:solidFill>
+                      <a:srgbClr val="FFFFFF"/>
+                    </a:solidFill>
+                  </a:tcPr>
+                </a:tc>
+                <a:tc>
+                  <a:txBody>
+                    <a:bodyPr lIns="114300" tIns="76200" rIns="114300" bIns="76200">
+                      <a:noAutofit/>
+                    </a:bodyPr>
+                    <a:lstStyle/>
+                    <a:p>
+                      <a:r>
+                        <a:rPr sz="1650" b="0">
+                          <a:solidFill>
+                            <a:srgbClr val="122D3D"/>
+                          </a:solidFill>
+                          <a:latin typeface="Arial"/>
+                          <a:ea typeface="Arial"/>
+                          <a:cs typeface="Arial"/>
+                        </a:rPr>
+                        <a:t>Piloto e documentação</a:t>
+                      </a:r>
+                    </a:p>
+                  </a:txBody>
+                  <a:tcPr marL="91440" marR="91440" marT="45720" marB="45720">
+                    <a:solidFill>
+                      <a:srgbClr val="FFFFFF"/>
+                    </a:solidFill>
+                  </a:tcPr>
+                </a:tc>
+                <a:tc>
+                  <a:txBody>
+                    <a:bodyPr lIns="114300" tIns="76200" rIns="114300" bIns="76200">
+                      <a:noAutofit/>
+                    </a:bodyPr>
+                    <a:lstStyle/>
+                    <a:p>
+                      <a:r>
+                        <a:rPr sz="1650" b="0">
+                          <a:solidFill>
+                            <a:srgbClr val="122D3D"/>
+                          </a:solidFill>
+                          <a:latin typeface="Arial"/>
+                          <a:ea typeface="Arial"/>
+                          <a:cs typeface="Arial"/>
+                        </a:rPr>
+                        <a:t>Sem pendências críticas, pacote reproduzível</a:t>
                       </a:r>
                     </a:p>
                   </a:txBody>
@@ -6253,7 +6413,7 @@
           <p:cNvPr id="5" name="">
             <a:extLst xmlns:a="http://schemas.openxmlformats.org/drawingml/2006/main">
               <a:ext uri="{FF2B5EF4-FFF2-40B4-BE49-F238E27FC236}">
-                <a16:creationId xmlns:a16="http://schemas.microsoft.com/office/drawing/2014/main" id="{417DBEFA-4AC1-49A0-A0F2-3B2BFEF26496}"/>
+                <a16:creationId xmlns:a16="http://schemas.microsoft.com/office/drawing/2014/main" id="{6E84873C-5B84-4B1D-9164-28A51E1308B9}"/>
               </a:ext>
             </a:extLst>
           </p:cNvPr>
@@ -6308,7 +6468,7 @@
     </p:spTree>
     <p:extLst>
       <p:ext uri="{BB962C8B-B14F-4D97-AF65-F5344CB8AC3E}">
-        <p14:creationId xmlns:p14="http://schemas.microsoft.com/office/powerpoint/2010/main" val="430962442"/>
+        <p14:creationId xmlns:p14="http://schemas.microsoft.com/office/powerpoint/2010/main" val="1090815155"/>
       </p:ext>
     </p:extLst>
   </p:cSld>
@@ -6339,7 +6499,7 @@
           <p:cNvPr id="13" name="">
             <a:extLst xmlns:a="http://schemas.openxmlformats.org/drawingml/2006/main">
               <a:ext uri="{FF2B5EF4-FFF2-40B4-BE49-F238E27FC236}">
-                <a16:creationId xmlns:a16="http://schemas.microsoft.com/office/drawing/2014/main" id="{25FA2A5D-6376-4DF1-B1D7-C9BA218F82C1}"/>
+                <a16:creationId xmlns:a16="http://schemas.microsoft.com/office/drawing/2014/main" id="{97A4D4CE-9964-4F2D-A24C-DDA8F7D6F528}"/>
               </a:ext>
             </a:extLst>
           </p:cNvPr>
@@ -6396,7 +6556,7 @@
           <p:cNvPr id="2" name="">
             <a:extLst xmlns:a="http://schemas.openxmlformats.org/drawingml/2006/main">
               <a:ext uri="{FF2B5EF4-FFF2-40B4-BE49-F238E27FC236}">
-                <a16:creationId xmlns:a16="http://schemas.microsoft.com/office/drawing/2014/main" id="{E4F0A5EF-2E07-462C-88AE-DD50007E381E}"/>
+                <a16:creationId xmlns:a16="http://schemas.microsoft.com/office/drawing/2014/main" id="{7977AC7D-EACD-405E-8465-8D275FBF0645}"/>
               </a:ext>
             </a:extLst>
           </p:cNvPr>
@@ -6907,7 +7067,7 @@
           <p:cNvPr id="4" name="">
             <a:extLst xmlns:a="http://schemas.openxmlformats.org/drawingml/2006/main">
               <a:ext uri="{FF2B5EF4-FFF2-40B4-BE49-F238E27FC236}">
-                <a16:creationId xmlns:a16="http://schemas.microsoft.com/office/drawing/2014/main" id="{EA0B9F81-9D57-467B-BBEE-79B07E3BDD2D}"/>
+                <a16:creationId xmlns:a16="http://schemas.microsoft.com/office/drawing/2014/main" id="{D4132F94-85DC-4F9E-9855-9E99ADF042B6}"/>
               </a:ext>
             </a:extLst>
           </p:cNvPr>
@@ -6964,7 +7124,7 @@
           <p:cNvPr id="5" name="">
             <a:extLst xmlns:a="http://schemas.openxmlformats.org/drawingml/2006/main">
               <a:ext uri="{FF2B5EF4-FFF2-40B4-BE49-F238E27FC236}">
-                <a16:creationId xmlns:a16="http://schemas.microsoft.com/office/drawing/2014/main" id="{7947EEA6-7692-440A-B4E7-12A9739462D9}"/>
+                <a16:creationId xmlns:a16="http://schemas.microsoft.com/office/drawing/2014/main" id="{71AE72CD-E737-47A7-B109-95AD02FD7BA7}"/>
               </a:ext>
             </a:extLst>
           </p:cNvPr>
@@ -7021,7 +7181,7 @@
           <p:cNvPr id="6" name="">
             <a:extLst xmlns:a="http://schemas.openxmlformats.org/drawingml/2006/main">
               <a:ext uri="{FF2B5EF4-FFF2-40B4-BE49-F238E27FC236}">
-                <a16:creationId xmlns:a16="http://schemas.microsoft.com/office/drawing/2014/main" id="{A7169660-99AB-45CD-B581-126822BBD823}"/>
+                <a16:creationId xmlns:a16="http://schemas.microsoft.com/office/drawing/2014/main" id="{913EFF9D-96A4-47DF-A620-DA9492B9C9AE}"/>
               </a:ext>
             </a:extLst>
           </p:cNvPr>
@@ -7078,7 +7238,7 @@
           <p:cNvPr id="7" name="">
             <a:extLst xmlns:a="http://schemas.openxmlformats.org/drawingml/2006/main">
               <a:ext uri="{FF2B5EF4-FFF2-40B4-BE49-F238E27FC236}">
-                <a16:creationId xmlns:a16="http://schemas.microsoft.com/office/drawing/2014/main" id="{A578279D-7A29-41D3-966D-5E1B2B9D686F}"/>
+                <a16:creationId xmlns:a16="http://schemas.microsoft.com/office/drawing/2014/main" id="{2AEA93CC-5A20-4795-86AE-792932EFFF91}"/>
               </a:ext>
             </a:extLst>
           </p:cNvPr>
@@ -7135,7 +7295,7 @@
           <p:cNvPr id="8" name="">
             <a:extLst xmlns:a="http://schemas.openxmlformats.org/drawingml/2006/main">
               <a:ext uri="{FF2B5EF4-FFF2-40B4-BE49-F238E27FC236}">
-                <a16:creationId xmlns:a16="http://schemas.microsoft.com/office/drawing/2014/main" id="{E1DC789C-4236-459E-822B-81F19748C750}"/>
+                <a16:creationId xmlns:a16="http://schemas.microsoft.com/office/drawing/2014/main" id="{494167FB-8703-4FE0-8DAD-C08BF7AFC605}"/>
               </a:ext>
             </a:extLst>
           </p:cNvPr>
@@ -7192,7 +7352,7 @@
           <p:cNvPr id="9" name="">
             <a:extLst xmlns:a="http://schemas.openxmlformats.org/drawingml/2006/main">
               <a:ext uri="{FF2B5EF4-FFF2-40B4-BE49-F238E27FC236}">
-                <a16:creationId xmlns:a16="http://schemas.microsoft.com/office/drawing/2014/main" id="{D25BA306-5442-42DF-B0B9-C7CFB4CE6D8D}"/>
+                <a16:creationId xmlns:a16="http://schemas.microsoft.com/office/drawing/2014/main" id="{CE565F0D-B6F2-4F08-9531-729478CD3534}"/>
               </a:ext>
             </a:extLst>
           </p:cNvPr>
@@ -7249,7 +7409,7 @@
           <p:cNvPr id="10" name="">
             <a:extLst xmlns:a="http://schemas.openxmlformats.org/drawingml/2006/main">
               <a:ext uri="{FF2B5EF4-FFF2-40B4-BE49-F238E27FC236}">
-                <a16:creationId xmlns:a16="http://schemas.microsoft.com/office/drawing/2014/main" id="{5AFBC403-4120-4B28-8318-21294C3910DF}"/>
+                <a16:creationId xmlns:a16="http://schemas.microsoft.com/office/drawing/2014/main" id="{DC9E9A34-2A2E-43C1-9226-8E818A723E86}"/>
               </a:ext>
             </a:extLst>
           </p:cNvPr>
@@ -7306,7 +7466,7 @@
           <p:cNvPr id="11" name="">
             <a:extLst xmlns:a="http://schemas.openxmlformats.org/drawingml/2006/main">
               <a:ext uri="{FF2B5EF4-FFF2-40B4-BE49-F238E27FC236}">
-                <a16:creationId xmlns:a16="http://schemas.microsoft.com/office/drawing/2014/main" id="{C047EF3E-5F61-4646-AD75-5C7A74D8B32A}"/>
+                <a16:creationId xmlns:a16="http://schemas.microsoft.com/office/drawing/2014/main" id="{20CA095F-4BAB-4F38-80CD-8C93B9706B5D}"/>
               </a:ext>
             </a:extLst>
           </p:cNvPr>
@@ -7363,7 +7523,7 @@
           <p:cNvPr id="12" name="">
             <a:extLst xmlns:a="http://schemas.openxmlformats.org/drawingml/2006/main">
               <a:ext uri="{FF2B5EF4-FFF2-40B4-BE49-F238E27FC236}">
-                <a16:creationId xmlns:a16="http://schemas.microsoft.com/office/drawing/2014/main" id="{657E688D-93C6-4B38-BA50-5CA670C5E40D}"/>
+                <a16:creationId xmlns:a16="http://schemas.microsoft.com/office/drawing/2014/main" id="{D4E8DC9F-7B87-4607-9240-65F24209DA5F}"/>
               </a:ext>
             </a:extLst>
           </p:cNvPr>
@@ -7418,7 +7578,7 @@
     </p:spTree>
     <p:extLst>
       <p:ext uri="{BB962C8B-B14F-4D97-AF65-F5344CB8AC3E}">
-        <p14:creationId xmlns:p14="http://schemas.microsoft.com/office/powerpoint/2010/main" val="2096128243"/>
+        <p14:creationId xmlns:p14="http://schemas.microsoft.com/office/powerpoint/2010/main" val="431199363"/>
       </p:ext>
     </p:extLst>
   </p:cSld>
@@ -7449,7 +7609,7 @@
           <p:cNvPr id="10" name="">
             <a:extLst xmlns:a="http://schemas.openxmlformats.org/drawingml/2006/main">
               <a:ext uri="{FF2B5EF4-FFF2-40B4-BE49-F238E27FC236}">
-                <a16:creationId xmlns:a16="http://schemas.microsoft.com/office/drawing/2014/main" id="{8FE60B37-5E8B-4321-9C18-7ACBAECE9C75}"/>
+                <a16:creationId xmlns:a16="http://schemas.microsoft.com/office/drawing/2014/main" id="{8C13F32C-5F24-4611-B598-E250E35F3BC0}"/>
               </a:ext>
             </a:extLst>
           </p:cNvPr>
@@ -7506,7 +7666,7 @@
           <p:cNvPr id="2" name="">
             <a:extLst xmlns:a="http://schemas.openxmlformats.org/drawingml/2006/main">
               <a:ext uri="{FF2B5EF4-FFF2-40B4-BE49-F238E27FC236}">
-                <a16:creationId xmlns:a16="http://schemas.microsoft.com/office/drawing/2014/main" id="{04690B65-59CF-4588-98C8-511B35E4A229}"/>
+                <a16:creationId xmlns:a16="http://schemas.microsoft.com/office/drawing/2014/main" id="{B81BD73A-2365-4231-B225-582B0C7580A2}"/>
               </a:ext>
             </a:extLst>
           </p:cNvPr>
@@ -7563,7 +7723,7 @@
           <p:cNvPr id="3" name="">
             <a:extLst xmlns:a="http://schemas.openxmlformats.org/drawingml/2006/main">
               <a:ext uri="{FF2B5EF4-FFF2-40B4-BE49-F238E27FC236}">
-                <a16:creationId xmlns:a16="http://schemas.microsoft.com/office/drawing/2014/main" id="{4F8F4EA1-C963-45C9-ACCE-549429646D2F}"/>
+                <a16:creationId xmlns:a16="http://schemas.microsoft.com/office/drawing/2014/main" id="{90D1DEFE-5C94-480E-AF94-1B1CEF74EAF7}"/>
               </a:ext>
             </a:extLst>
           </p:cNvPr>
@@ -7620,7 +7780,7 @@
           <p:cNvPr id="4" name="">
             <a:extLst xmlns:a="http://schemas.openxmlformats.org/drawingml/2006/main">
               <a:ext uri="{FF2B5EF4-FFF2-40B4-BE49-F238E27FC236}">
-                <a16:creationId xmlns:a16="http://schemas.microsoft.com/office/drawing/2014/main" id="{8D09648C-E5C5-430D-9170-3BDF089C6995}"/>
+                <a16:creationId xmlns:a16="http://schemas.microsoft.com/office/drawing/2014/main" id="{821FC01D-FE2C-494E-ACC5-8D0C5CA74C7E}"/>
               </a:ext>
             </a:extLst>
           </p:cNvPr>
@@ -7769,7 +7929,7 @@
           <p:cNvPr id="5" name="">
             <a:extLst xmlns:a="http://schemas.openxmlformats.org/drawingml/2006/main">
               <a:ext uri="{FF2B5EF4-FFF2-40B4-BE49-F238E27FC236}">
-                <a16:creationId xmlns:a16="http://schemas.microsoft.com/office/drawing/2014/main" id="{CB11AFF1-01D1-434A-BC1B-DBE1AC09222B}"/>
+                <a16:creationId xmlns:a16="http://schemas.microsoft.com/office/drawing/2014/main" id="{1DDFF5FE-731F-4C07-8A42-94FFC68E6135}"/>
               </a:ext>
             </a:extLst>
           </p:cNvPr>
@@ -7826,7 +7986,7 @@
           <p:cNvPr id="6" name="">
             <a:extLst xmlns:a="http://schemas.openxmlformats.org/drawingml/2006/main">
               <a:ext uri="{FF2B5EF4-FFF2-40B4-BE49-F238E27FC236}">
-                <a16:creationId xmlns:a16="http://schemas.microsoft.com/office/drawing/2014/main" id="{DB652631-1B04-4BFF-A088-8D6F083BC60B}"/>
+                <a16:creationId xmlns:a16="http://schemas.microsoft.com/office/drawing/2014/main" id="{DEE0D3EA-BA5D-4BB3-AFF1-B2C8661FACE5}"/>
               </a:ext>
             </a:extLst>
           </p:cNvPr>
@@ -7952,7 +8112,7 @@
           <p:cNvPr id="7" name="">
             <a:extLst xmlns:a="http://schemas.openxmlformats.org/drawingml/2006/main">
               <a:ext uri="{FF2B5EF4-FFF2-40B4-BE49-F238E27FC236}">
-                <a16:creationId xmlns:a16="http://schemas.microsoft.com/office/drawing/2014/main" id="{4C43992E-C2ED-4327-9B6C-B1AA90DC176F}"/>
+                <a16:creationId xmlns:a16="http://schemas.microsoft.com/office/drawing/2014/main" id="{E52AC77C-EA8E-45C6-A536-6007F5114226}"/>
               </a:ext>
             </a:extLst>
           </p:cNvPr>
@@ -8009,7 +8169,7 @@
           <p:cNvPr id="8" name="">
             <a:extLst xmlns:a="http://schemas.openxmlformats.org/drawingml/2006/main">
               <a:ext uri="{FF2B5EF4-FFF2-40B4-BE49-F238E27FC236}">
-                <a16:creationId xmlns:a16="http://schemas.microsoft.com/office/drawing/2014/main" id="{2A95FD62-031C-42B7-B79C-B7557DF33755}"/>
+                <a16:creationId xmlns:a16="http://schemas.microsoft.com/office/drawing/2014/main" id="{5E9425ED-3B98-46D3-9734-9AEB7C8AF6FB}"/>
               </a:ext>
             </a:extLst>
           </p:cNvPr>
@@ -8089,7 +8249,7 @@
           <p:cNvPr id="9" name="">
             <a:extLst xmlns:a="http://schemas.openxmlformats.org/drawingml/2006/main">
               <a:ext uri="{FF2B5EF4-FFF2-40B4-BE49-F238E27FC236}">
-                <a16:creationId xmlns:a16="http://schemas.microsoft.com/office/drawing/2014/main" id="{47C39231-E758-4B85-B52F-80710D61FC7A}"/>
+                <a16:creationId xmlns:a16="http://schemas.microsoft.com/office/drawing/2014/main" id="{94C65538-69F5-405A-B735-6D592F134235}"/>
               </a:ext>
             </a:extLst>
           </p:cNvPr>
@@ -8144,7 +8304,7 @@
     </p:spTree>
     <p:extLst>
       <p:ext uri="{BB962C8B-B14F-4D97-AF65-F5344CB8AC3E}">
-        <p14:creationId xmlns:p14="http://schemas.microsoft.com/office/powerpoint/2010/main" val="1003672252"/>
+        <p14:creationId xmlns:p14="http://schemas.microsoft.com/office/powerpoint/2010/main" val="595169527"/>
       </p:ext>
     </p:extLst>
   </p:cSld>

</xml_diff>

<commit_message>
Completa identificação do grupo e valida dados incompletos
</commit_message>
<xml_diff>
--- a/docs/apresentacao_pagamentos_es_2024.pptx
+++ b/docs/apresentacao_pagamentos_es_2024.pptx
@@ -2,20 +2,20 @@
 <file path=ppt/presentation.xml><?xml version="1.0" encoding="utf-8"?>
 <p:presentation xmlns:p="http://schemas.openxmlformats.org/presentationml/2006/main">
   <p:sldMasterIdLst>
-    <p:sldMasterId xmlns:r="http://schemas.openxmlformats.org/officeDocument/2006/relationships" id="2147483648" r:id="R53b66df697954928"/>
+    <p:sldMasterId xmlns:r="http://schemas.openxmlformats.org/officeDocument/2006/relationships" id="2147483648" r:id="R55b8c605549d41b8"/>
   </p:sldMasterIdLst>
   <p:notesMasterIdLst>
-    <p:notesMasterId xmlns:r="http://schemas.openxmlformats.org/officeDocument/2006/relationships" r:id="R1f31c793365d487c"/>
+    <p:notesMasterId xmlns:r="http://schemas.openxmlformats.org/officeDocument/2006/relationships" r:id="Rcb07aa4b80ae4758"/>
   </p:notesMasterIdLst>
   <p:sldIdLst>
-    <p:sldId xmlns:r="http://schemas.openxmlformats.org/officeDocument/2006/relationships" id="256" r:id="Rb30003042c90461a"/>
-    <p:sldId xmlns:r="http://schemas.openxmlformats.org/officeDocument/2006/relationships" id="257" r:id="Rf3de323c8fa647d6"/>
-    <p:sldId xmlns:r="http://schemas.openxmlformats.org/officeDocument/2006/relationships" id="258" r:id="Rd1c79f81323b4291"/>
-    <p:sldId xmlns:r="http://schemas.openxmlformats.org/officeDocument/2006/relationships" id="259" r:id="Rbd19b737a6bc4f5b"/>
-    <p:sldId xmlns:r="http://schemas.openxmlformats.org/officeDocument/2006/relationships" id="260" r:id="Rd870f77eb34d49f0"/>
-    <p:sldId xmlns:r="http://schemas.openxmlformats.org/officeDocument/2006/relationships" id="261" r:id="R5a6597b91db34769"/>
-    <p:sldId xmlns:r="http://schemas.openxmlformats.org/officeDocument/2006/relationships" id="262" r:id="R89b9da0e0ccc4fda"/>
-    <p:sldId xmlns:r="http://schemas.openxmlformats.org/officeDocument/2006/relationships" id="263" r:id="R57f2e09b3763452b"/>
+    <p:sldId xmlns:r="http://schemas.openxmlformats.org/officeDocument/2006/relationships" id="256" r:id="Rcd0f63dcecca4eca"/>
+    <p:sldId xmlns:r="http://schemas.openxmlformats.org/officeDocument/2006/relationships" id="257" r:id="R58a3d79eb1e64f16"/>
+    <p:sldId xmlns:r="http://schemas.openxmlformats.org/officeDocument/2006/relationships" id="258" r:id="Rd2e7e420ba97493e"/>
+    <p:sldId xmlns:r="http://schemas.openxmlformats.org/officeDocument/2006/relationships" id="259" r:id="Rc5977e3616714445"/>
+    <p:sldId xmlns:r="http://schemas.openxmlformats.org/officeDocument/2006/relationships" id="260" r:id="R5827e4c987f64d9f"/>
+    <p:sldId xmlns:r="http://schemas.openxmlformats.org/officeDocument/2006/relationships" id="261" r:id="Rce014f287a464f8e"/>
+    <p:sldId xmlns:r="http://schemas.openxmlformats.org/officeDocument/2006/relationships" id="262" r:id="Re4217211f5ab495d"/>
+    <p:sldId xmlns:r="http://schemas.openxmlformats.org/officeDocument/2006/relationships" id="263" r:id="R2c14da5cd60e42c9"/>
   </p:sldIdLst>
   <p:sldSz cx="12192000" cy="6858000"/>
   <p:notesSz cx="6858000" cy="9144000"/>
@@ -449,7 +449,7 @@
           <a:lstStyle xmlns:a="http://schemas.openxmlformats.org/drawingml/2006/main"/>
           <a:p xmlns:a="http://schemas.openxmlformats.org/drawingml/2006/main">
             <a:r>
-              <a:t>Roteiro sugerido. Integrante 1. Tempo 55 segundos.</a:t>
+              <a:t>Roteiro sugerido. Luigi Mendes Cabrini · RM 563552. Tempo 65 segundos.</a:t>
             </a:r>
           </a:p>
           <a:p xmlns:a="http://schemas.openxmlformats.org/drawingml/2006/main">
@@ -544,7 +544,7 @@
           <a:lstStyle xmlns:a="http://schemas.openxmlformats.org/drawingml/2006/main"/>
           <a:p xmlns:a="http://schemas.openxmlformats.org/drawingml/2006/main">
             <a:r>
-              <a:t>Roteiro sugerido. Integrante 1. Tempo 65 segundos.</a:t>
+              <a:t>Roteiro sugerido. Luigi Mendes Cabrini · RM 563552. Tempo 85 segundos.</a:t>
             </a:r>
           </a:p>
           <a:p xmlns:a="http://schemas.openxmlformats.org/drawingml/2006/main">
@@ -649,7 +649,7 @@
           <a:lstStyle xmlns:a="http://schemas.openxmlformats.org/drawingml/2006/main"/>
           <a:p xmlns:a="http://schemas.openxmlformats.org/drawingml/2006/main">
             <a:r>
-              <a:t>Roteiro sugerido. Integrante 2. Tempo 80 segundos.</a:t>
+              <a:t>Roteiro sugerido. Bruno Koeke · RM 561309. Tempo 80 segundos.</a:t>
             </a:r>
           </a:p>
           <a:p xmlns:a="http://schemas.openxmlformats.org/drawingml/2006/main">
@@ -754,12 +754,12 @@
           <a:lstStyle xmlns:a="http://schemas.openxmlformats.org/drawingml/2006/main"/>
           <a:p xmlns:a="http://schemas.openxmlformats.org/drawingml/2006/main">
             <a:r>
-              <a:t>Roteiro sugerido. Integrante 2. Tempo 100 segundos.</a:t>
-            </a:r>
-          </a:p>
-          <a:p xmlns:a="http://schemas.openxmlformats.org/drawingml/2006/main">
-            <a:r>
-              <a:t>Descrever a pergunta 2 e a série mensal. Dezembro soma R$ 1.648.054.158,32, em 55.327 registros. A média dos 12 totais é R$ 861.424.904,89, mediana R$ 830.429.539,28 e desvio padrão amostral R$ 308.017.812,38. Os 12 meses observados são completos dentro dos arquivos locais. Não há evidência suficiente para atribuir causalidade ao aumento. A data representa a data do documento/registro conforme o dicionário, não prova a data de saída efetiva de caixa. O total do conjunto é uma soma observada. Média, mediana e desvio padrão mensal são estatísticas descritivas. Não calcular IC da média mensal porque há possível sazonalidade e dependência entre meses. O complemento didático usa uma amostra aleatória simples interna de registros com semente 2024 e intervalo de Wilson de 95% para a proporção de linhas com ValorPago &gt; 0. A população-alvo é somente o conjunto fornecido e não todo o Estado. O fato de o conjunto de origem possivelmente ser sistemático não permite extrapolação estadual. O sorteio interno é aleatório e reprodutível. A amostra tem n=10000 e k=3126 registros positivos, proporção 31,26%. Wilson resulta em 30,36% a 32,18%. A proporção exata conhecida na base é 30,87%. O intervalo usa aproximação binomial sem correção da população finita, conservadora frente ao sorteio sem reposição. O conjunto tem N=505950 linhas elegíveis e amostra de 1,98%</a:t>
+              <a:t>Roteiro sugerido. Bruno Koeke · RM 561309. Tempo 100 segundos.</a:t>
+            </a:r>
+          </a:p>
+          <a:p xmlns:a="http://schemas.openxmlformats.org/drawingml/2006/main">
+            <a:r>
+              <a:t>Descrever a pergunta 2 e a série mensal. Dezembro soma R$ 1.648.054.158,32, em 55.327 registros. A média dos 12 totais é R$ 861.424.904,89, mediana R$ 830.429.539,28 e desvio padrão amostral R$ 308.017.812,38. Os 12 meses observados são completos dentro dos arquivos locais. Não há evidência suficiente para atribuir causalidade ao aumento. A data representa a data do documento/registro conforme o dicionário, não prova a data de saída efetiva de caixa. O total do conjunto é uma soma observada. Média, mediana e desvio padrão mensal são estatísticas descritivas. Não calcular IC da média mensal porque há possível sazonalidade e dependência entre meses. O complemento didático usa uma amostra aleatória simples interna de registros com semente 2024 e intervalo de Wilson de 95% para a proporção de linhas com ValorPago &gt; 0. A população-alvo é somente o conjunto fornecido e não todo o Estado. O recorte sistemático de origem não permite extrapolação estadual. O sorteio interno é aleatório e reprodutível. A amostra tem n=10000 e k=3126 registros positivos, proporção 31,26%. Wilson resulta em 30,36% a 32,18%. A proporção exata conhecida na base é 30,87%. O intervalo usa aproximação binomial sem correção da população finita, conservadora frente ao sorteio sem reposição. O conjunto tem N=505950 linhas elegíveis e amostra de 1,98%</a:t>
             </a:r>
           </a:p>
           <a:p xmlns:a="http://schemas.openxmlformats.org/drawingml/2006/main">
@@ -864,7 +864,7 @@
           <a:lstStyle xmlns:a="http://schemas.openxmlformats.org/drawingml/2006/main"/>
           <a:p xmlns:a="http://schemas.openxmlformats.org/drawingml/2006/main">
             <a:r>
-              <a:t>Roteiro sugerido. Integrante 3. Tempo 240 segundos.</a:t>
+              <a:t>Roteiro sugerido. Rogério Cruz Arroyo · RM 563517. Tempo 210 segundos.</a:t>
             </a:r>
           </a:p>
           <a:p xmlns:a="http://schemas.openxmlformats.org/drawingml/2006/main">
@@ -884,7 +884,7 @@
           </a:p>
           <a:p xmlns:a="http://schemas.openxmlformats.org/drawingml/2006/main">
             <a:r>
-              <a:t>Código da POC em outputs/pagamentos_es_2024, Python biblioteca padrão e SQLite.</a:t>
+              <a:t>Código da POC no projeto cp5-data, Python biblioteca padrão e SQLite.</a:t>
             </a:r>
           </a:p>
           <a:p xmlns:a="http://schemas.openxmlformats.org/drawingml/2006/main">
@@ -964,12 +964,12 @@
           <a:lstStyle xmlns:a="http://schemas.openxmlformats.org/drawingml/2006/main"/>
           <a:p xmlns:a="http://schemas.openxmlformats.org/drawingml/2006/main">
             <a:r>
-              <a:t>Roteiro sugerido. Integrante 4. Tempo 70 segundos.</a:t>
-            </a:r>
-          </a:p>
-          <a:p xmlns:a="http://schemas.openxmlformats.org/drawingml/2006/main">
-            <a:r>
-              <a:t>Explicar que esta tabela propõe a divisão futura, sem afirmar contribuições já realizadas. Os marcos descrevem a evolução da POC que já funciona e coincidem com o relatório. Semanas 1–2: produto e dados revisam perguntas e indicadores com usuários. Semanas 3–4: dados e testes ampliam a auditoria, conciliam totais e repetem a carga. Semanas 5–8: desenvolvimento melhora a usabilidade, com uma jornada executável por usuário externo. Semanas 9–12: dados e desenvolvimento integram 2025 somente com períodos e medidas comparáveis. Semanas 13–14: testes e produto validam uso e dados expostos. Semanas 15–16: toda a equipe entrega o piloto, a documentação e o pacote reproduzível, sem pendências críticas. Se 2025 ou uma integração atrasar, manter o conjunto validado de 2024 e registrar o recorte. O enunciado exige 5 a 8 estudantes. A composição atual informada tem quatro e precisa de alinhamento com o professor.</a:t>
+              <a:t>Roteiro sugerido. Anthony Sforzin · RM 562096. Tempo 70 segundos.</a:t>
+            </a:r>
+          </a:p>
+          <a:p xmlns:a="http://schemas.openxmlformats.org/drawingml/2006/main">
+            <a:r>
+              <a:t>Explicar que esta tabela propõe a divisão futura, sem afirmar contribuições já realizadas. Os marcos descrevem a evolução da POC que já funciona e coincidem com o relatório. Semanas 1–2: produto e dados revisam perguntas e indicadores com usuários. Semanas 3–4: dados e testes ampliam a auditoria, conciliam totais e repetem a carga. Semanas 5–8: desenvolvimento melhora a usabilidade, com uma jornada executável por usuário externo. Semanas 9–12: dados e desenvolvimento integram 2025 somente com períodos e medidas comparáveis. Semanas 13–14: testes e produto entregam relatório de validação, testes sem falhas e aprovação documentada dos campos exportados. Semanas 15–16: toda a equipe entrega piloto, README e pacote, reproduzindo a jornada e o total de referência em ambiente limpo. Se 2025 ou uma integração atrasar, manter o conjunto validado de 2024 e registrar o recorte. O enunciado exige 5 a 8 estudantes. O grupo optou por manter quatro integrantes. A exceção com o professor permanece pendente.</a:t>
             </a:r>
           </a:p>
           <a:p xmlns:a="http://schemas.openxmlformats.org/drawingml/2006/main">
@@ -1059,7 +1059,7 @@
           <a:lstStyle xmlns:a="http://schemas.openxmlformats.org/drawingml/2006/main"/>
           <a:p xmlns:a="http://schemas.openxmlformats.org/drawingml/2006/main">
             <a:r>
-              <a:t>Roteiro sugerido. Integrante 4. Tempo 60 segundos.</a:t>
+              <a:t>Roteiro sugerido. Anthony Sforzin · RM 562096. Tempo 60 segundos.</a:t>
             </a:r>
           </a:p>
           <a:p xmlns:a="http://schemas.openxmlformats.org/drawingml/2006/main">
@@ -1154,12 +1154,12 @@
           <a:lstStyle xmlns:a="http://schemas.openxmlformats.org/drawingml/2006/main"/>
           <a:p xmlns:a="http://schemas.openxmlformats.org/drawingml/2006/main">
             <a:r>
-              <a:t>Roteiro sugerido. Integrante 4. Tempo 50 segundos.</a:t>
-            </a:r>
-          </a:p>
-          <a:p xmlns:a="http://schemas.openxmlformats.org/drawingml/2006/main">
-            <a:r>
-              <a:t>Concluir retomando o valor da jornada demonstrada. Identificar o que funciona e o que pertence ao plano posterior. Explicar que dados incompletos e a semântica de Data limitam as conclusões. Informar que a equipe precisa preencher os links de entrega e conferir o acesso da banca. Preparar respostas sobre as duas perguntas, o indicador, a rastreabilidade, as funções, o cronograma e o orçamento. A soma dos tempos sugeridos é 720 segundos, 12 minutos.</a:t>
+              <a:t>Roteiro sugerido. Anthony Sforzin · RM 562096. Tempo 50 segundos.</a:t>
+            </a:r>
+          </a:p>
+          <a:p xmlns:a="http://schemas.openxmlformats.org/drawingml/2006/main">
+            <a:r>
+              <a:t>Concluir retomando o valor da jornada demonstrada. Identificar o que funciona e o que pertence ao plano posterior. Explicar que dados incompletos e a semântica de Data limitam as conclusões. Informar que os links estão preenchidos e que o acesso da banca ainda deve ser validado. Preparar respostas sobre as duas perguntas, o indicador, a rastreabilidade, as funções, o cronograma e o orçamento. A soma dos tempos sugeridos é 720 segundos, 12 minutos.</a:t>
             </a:r>
           </a:p>
           <a:p xmlns:a="http://schemas.openxmlformats.org/drawingml/2006/main">
@@ -1257,7 +1257,7 @@
   </p:cSld>
   <p:clrMap bg1="lt1" tx1="dk1" bg2="lt2" tx2="dk2" accent1="accent1" accent2="accent2" accent3="accent3" accent4="accent4" accent5="accent5" accent6="accent6" hlink="hlink" folHlink="folHlink"/>
   <p:sldLayoutIdLst>
-    <p:sldLayoutId xmlns:r="http://schemas.openxmlformats.org/officeDocument/2006/relationships" id="2147483649" r:id="Rd28bbf5d344c4436"/>
+    <p:sldLayoutId xmlns:r="http://schemas.openxmlformats.org/officeDocument/2006/relationships" id="2147483649" r:id="R4c1748d7a66b4070"/>
   </p:sldLayoutIdLst>
   <p:txStyles>
     <p:titleStyle>
@@ -2262,10 +2262,10 @@
       </p:grpSpPr>
       <p:sp>
         <p:nvSpPr>
-          <p:cNvPr id="9" name="">
+          <p:cNvPr id="11" name="">
             <a:extLst xmlns:a="http://schemas.openxmlformats.org/drawingml/2006/main">
               <a:ext uri="{FF2B5EF4-FFF2-40B4-BE49-F238E27FC236}">
-                <a16:creationId xmlns:a16="http://schemas.microsoft.com/office/drawing/2014/main" id="{6F84DEA8-7050-4546-B212-05D5FFFB2462}"/>
+                <a16:creationId xmlns:a16="http://schemas.microsoft.com/office/drawing/2014/main" id="{18949BE6-B6D6-4BC7-84C8-D0AC48FE51EB}"/>
               </a:ext>
             </a:extLst>
           </p:cNvPr>
@@ -2322,7 +2322,7 @@
           <p:cNvPr id="2" name="">
             <a:extLst xmlns:a="http://schemas.openxmlformats.org/drawingml/2006/main">
               <a:ext uri="{FF2B5EF4-FFF2-40B4-BE49-F238E27FC236}">
-                <a16:creationId xmlns:a16="http://schemas.microsoft.com/office/drawing/2014/main" id="{0BE34AD0-CDFC-4FE2-BF73-F7F14DB0E92B}"/>
+                <a16:creationId xmlns:a16="http://schemas.microsoft.com/office/drawing/2014/main" id="{E2CCB318-3825-4FF7-9D93-749B6C4F1DB1}"/>
               </a:ext>
             </a:extLst>
           </p:cNvPr>
@@ -2379,7 +2379,7 @@
           <p:cNvPr id="3" name="">
             <a:extLst xmlns:a="http://schemas.openxmlformats.org/drawingml/2006/main">
               <a:ext uri="{FF2B5EF4-FFF2-40B4-BE49-F238E27FC236}">
-                <a16:creationId xmlns:a16="http://schemas.microsoft.com/office/drawing/2014/main" id="{26FFFFBF-E6EF-4D85-871B-3D9EE5A2B9E9}"/>
+                <a16:creationId xmlns:a16="http://schemas.microsoft.com/office/drawing/2014/main" id="{ECD4FA1D-0318-4AA4-8842-A17D716B0EDB}"/>
               </a:ext>
             </a:extLst>
           </p:cNvPr>
@@ -2436,7 +2436,7 @@
           <p:cNvPr id="4" name="">
             <a:extLst xmlns:a="http://schemas.openxmlformats.org/drawingml/2006/main">
               <a:ext uri="{FF2B5EF4-FFF2-40B4-BE49-F238E27FC236}">
-                <a16:creationId xmlns:a16="http://schemas.microsoft.com/office/drawing/2014/main" id="{431C86AB-5252-40E7-BC22-97DBB6C0E9C2}"/>
+                <a16:creationId xmlns:a16="http://schemas.microsoft.com/office/drawing/2014/main" id="{5B3F1CDA-1D64-44AE-8FE0-3838B39AEE0D}"/>
               </a:ext>
             </a:extLst>
           </p:cNvPr>
@@ -2493,7 +2493,7 @@
           <p:cNvPr id="5" name="">
             <a:extLst xmlns:a="http://schemas.openxmlformats.org/drawingml/2006/main">
               <a:ext uri="{FF2B5EF4-FFF2-40B4-BE49-F238E27FC236}">
-                <a16:creationId xmlns:a16="http://schemas.microsoft.com/office/drawing/2014/main" id="{D4668DC5-C046-4D37-98E4-35B524325F21}"/>
+                <a16:creationId xmlns:a16="http://schemas.microsoft.com/office/drawing/2014/main" id="{B4FC9CB9-0DBA-4BC3-97EE-1A0E38B8651A}"/>
               </a:ext>
             </a:extLst>
           </p:cNvPr>
@@ -2573,7 +2573,7 @@
           <p:cNvPr id="6" name="">
             <a:extLst xmlns:a="http://schemas.openxmlformats.org/drawingml/2006/main">
               <a:ext uri="{FF2B5EF4-FFF2-40B4-BE49-F238E27FC236}">
-                <a16:creationId xmlns:a16="http://schemas.microsoft.com/office/drawing/2014/main" id="{6F4C0DFB-039E-4784-A42B-6BF75126183F}"/>
+                <a16:creationId xmlns:a16="http://schemas.microsoft.com/office/drawing/2014/main" id="{FF0351A4-DE2C-4B8A-AAFD-02123BCF929D}"/>
               </a:ext>
             </a:extLst>
           </p:cNvPr>
@@ -2630,7 +2630,7 @@
           <p:cNvPr id="7" name="">
             <a:extLst xmlns:a="http://schemas.openxmlformats.org/drawingml/2006/main">
               <a:ext uri="{FF2B5EF4-FFF2-40B4-BE49-F238E27FC236}">
-                <a16:creationId xmlns:a16="http://schemas.microsoft.com/office/drawing/2014/main" id="{A6BCAFE0-0586-488A-AB31-0458369F0ABA}"/>
+                <a16:creationId xmlns:a16="http://schemas.microsoft.com/office/drawing/2014/main" id="{774FA5C7-A0C6-45E3-9397-71C40F8EB0D9}"/>
               </a:ext>
             </a:extLst>
           </p:cNvPr>
@@ -2710,7 +2710,167 @@
           <p:cNvPr id="8" name="">
             <a:extLst xmlns:a="http://schemas.openxmlformats.org/drawingml/2006/main">
               <a:ext uri="{FF2B5EF4-FFF2-40B4-BE49-F238E27FC236}">
-                <a16:creationId xmlns:a16="http://schemas.microsoft.com/office/drawing/2014/main" id="{4A6A00E3-02C1-4540-B23F-2306F9A1DAB4}"/>
+                <a16:creationId xmlns:a16="http://schemas.microsoft.com/office/drawing/2014/main" id="{4DC3AE8E-846F-4E4D-A790-3F81F84690AE}"/>
+              </a:ext>
+            </a:extLst>
+          </p:cNvPr>
+          <p:cNvSpPr>
+            <a:spLocks xmlns:a="http://schemas.openxmlformats.org/drawingml/2006/main" noGrp="1"/>
+          </p:cNvSpPr>
+          <p:nvPr/>
+        </p:nvSpPr>
+        <p:spPr>
+          <a:xfrm xmlns:a="http://schemas.openxmlformats.org/drawingml/2006/main">
+            <a:off x="609600" y="5619750"/>
+            <a:ext cx="5295900" cy="609600"/>
+          </a:xfrm>
+          <a:prstGeom xmlns:a="http://schemas.openxmlformats.org/drawingml/2006/main" prst="rect">
+            <a:avLst/>
+          </a:prstGeom>
+          <a:noFill xmlns:a="http://schemas.openxmlformats.org/drawingml/2006/main"/>
+          <a:ln xmlns:a="http://schemas.openxmlformats.org/drawingml/2006/main" w="0">
+            <a:noFill/>
+          </a:ln>
+        </p:spPr>
+        <p:txBody>
+          <a:bodyPr xmlns:a="http://schemas.openxmlformats.org/drawingml/2006/main" wrap="square" lIns="0" tIns="0" rIns="0" bIns="0">
+            <a:noAutofit/>
+          </a:bodyPr>
+          <a:lstStyle xmlns:a="http://schemas.openxmlformats.org/drawingml/2006/main"/>
+          <a:p xmlns:a="http://schemas.openxmlformats.org/drawingml/2006/main">
+            <a:pPr>
+              <a:defRPr sz="1725" b="0">
+                <a:solidFill>
+                  <a:srgbClr val="4F6570"/>
+                </a:solidFill>
+                <a:latin typeface="Arial"/>
+                <a:ea typeface="Arial"/>
+                <a:cs typeface="Arial"/>
+              </a:defRPr>
+            </a:pPr>
+            <a:r>
+              <a:rPr sz="1725" b="0">
+                <a:solidFill>
+                  <a:srgbClr val="4F6570"/>
+                </a:solidFill>
+                <a:latin typeface="Arial"/>
+                <a:ea typeface="Arial"/>
+                <a:cs typeface="Arial"/>
+              </a:rPr>
+              <a:t>Luigi Mendes Cabrini · RM 563552</a:t>
+            </a:r>
+          </a:p>
+          <a:p xmlns:a="http://schemas.openxmlformats.org/drawingml/2006/main">
+            <a:pPr>
+              <a:defRPr sz="1725" b="0">
+                <a:solidFill>
+                  <a:srgbClr val="4F6570"/>
+                </a:solidFill>
+                <a:latin typeface="Arial"/>
+                <a:ea typeface="Arial"/>
+                <a:cs typeface="Arial"/>
+              </a:defRPr>
+            </a:pPr>
+            <a:r>
+              <a:rPr sz="1725" b="0">
+                <a:solidFill>
+                  <a:srgbClr val="4F6570"/>
+                </a:solidFill>
+                <a:latin typeface="Arial"/>
+                <a:ea typeface="Arial"/>
+                <a:cs typeface="Arial"/>
+              </a:rPr>
+              <a:t>Bruno Koeke · RM 561309</a:t>
+            </a:r>
+          </a:p>
+        </p:txBody>
+      </p:sp>
+      <p:sp>
+        <p:nvSpPr>
+          <p:cNvPr id="9" name="">
+            <a:extLst xmlns:a="http://schemas.openxmlformats.org/drawingml/2006/main">
+              <a:ext uri="{FF2B5EF4-FFF2-40B4-BE49-F238E27FC236}">
+                <a16:creationId xmlns:a16="http://schemas.microsoft.com/office/drawing/2014/main" id="{86EDA423-0F67-4462-ADEF-B99F17471961}"/>
+              </a:ext>
+            </a:extLst>
+          </p:cNvPr>
+          <p:cNvSpPr>
+            <a:spLocks xmlns:a="http://schemas.openxmlformats.org/drawingml/2006/main" noGrp="1"/>
+          </p:cNvSpPr>
+          <p:nvPr/>
+        </p:nvSpPr>
+        <p:spPr>
+          <a:xfrm xmlns:a="http://schemas.openxmlformats.org/drawingml/2006/main">
+            <a:off x="6191250" y="5619750"/>
+            <a:ext cx="5381625" cy="609600"/>
+          </a:xfrm>
+          <a:prstGeom xmlns:a="http://schemas.openxmlformats.org/drawingml/2006/main" prst="rect">
+            <a:avLst/>
+          </a:prstGeom>
+          <a:noFill xmlns:a="http://schemas.openxmlformats.org/drawingml/2006/main"/>
+          <a:ln xmlns:a="http://schemas.openxmlformats.org/drawingml/2006/main" w="0">
+            <a:noFill/>
+          </a:ln>
+        </p:spPr>
+        <p:txBody>
+          <a:bodyPr xmlns:a="http://schemas.openxmlformats.org/drawingml/2006/main" wrap="square" lIns="0" tIns="0" rIns="0" bIns="0">
+            <a:noAutofit/>
+          </a:bodyPr>
+          <a:lstStyle xmlns:a="http://schemas.openxmlformats.org/drawingml/2006/main"/>
+          <a:p xmlns:a="http://schemas.openxmlformats.org/drawingml/2006/main">
+            <a:pPr>
+              <a:defRPr sz="1725" b="0">
+                <a:solidFill>
+                  <a:srgbClr val="4F6570"/>
+                </a:solidFill>
+                <a:latin typeface="Arial"/>
+                <a:ea typeface="Arial"/>
+                <a:cs typeface="Arial"/>
+              </a:defRPr>
+            </a:pPr>
+            <a:r>
+              <a:rPr sz="1725" b="0">
+                <a:solidFill>
+                  <a:srgbClr val="4F6570"/>
+                </a:solidFill>
+                <a:latin typeface="Arial"/>
+                <a:ea typeface="Arial"/>
+                <a:cs typeface="Arial"/>
+              </a:rPr>
+              <a:t>Rogério Cruz Arroyo · RM 563517</a:t>
+            </a:r>
+          </a:p>
+          <a:p xmlns:a="http://schemas.openxmlformats.org/drawingml/2006/main">
+            <a:pPr>
+              <a:defRPr sz="1725" b="0">
+                <a:solidFill>
+                  <a:srgbClr val="4F6570"/>
+                </a:solidFill>
+                <a:latin typeface="Arial"/>
+                <a:ea typeface="Arial"/>
+                <a:cs typeface="Arial"/>
+              </a:defRPr>
+            </a:pPr>
+            <a:r>
+              <a:rPr sz="1725" b="0">
+                <a:solidFill>
+                  <a:srgbClr val="4F6570"/>
+                </a:solidFill>
+                <a:latin typeface="Arial"/>
+                <a:ea typeface="Arial"/>
+                <a:cs typeface="Arial"/>
+              </a:rPr>
+              <a:t>Anthony Sforzin · RM 562096</a:t>
+            </a:r>
+          </a:p>
+        </p:txBody>
+      </p:sp>
+      <p:sp>
+        <p:nvSpPr>
+          <p:cNvPr id="10" name="">
+            <a:extLst xmlns:a="http://schemas.openxmlformats.org/drawingml/2006/main">
+              <a:ext uri="{FF2B5EF4-FFF2-40B4-BE49-F238E27FC236}">
+                <a16:creationId xmlns:a16="http://schemas.microsoft.com/office/drawing/2014/main" id="{D9E4DD05-9253-4179-8593-806953ED48FB}"/>
               </a:ext>
             </a:extLst>
           </p:cNvPr>
@@ -2757,7 +2917,7 @@
                 <a:ea typeface="Arial"/>
                 <a:cs typeface="Arial"/>
               </a:rPr>
-              <a:t>2ESPH-2026  ·  CPSI acadêmico simulado  ·  Apresentação de 12 minutos</a:t>
+              <a:t>2ESPH-2026  ·  Equipe Pagamentos ES 2024, proponente fictícia no CPSI simulado</a:t>
             </a:r>
           </a:p>
         </p:txBody>
@@ -2765,7 +2925,7 @@
     </p:spTree>
     <p:extLst>
       <p:ext uri="{BB962C8B-B14F-4D97-AF65-F5344CB8AC3E}">
-        <p14:creationId xmlns:p14="http://schemas.microsoft.com/office/powerpoint/2010/main" val="936844338"/>
+        <p14:creationId xmlns:p14="http://schemas.microsoft.com/office/powerpoint/2010/main" val="1011734185"/>
       </p:ext>
     </p:extLst>
   </p:cSld>
@@ -2796,7 +2956,7 @@
           <p:cNvPr id="9" name="">
             <a:extLst xmlns:a="http://schemas.openxmlformats.org/drawingml/2006/main">
               <a:ext uri="{FF2B5EF4-FFF2-40B4-BE49-F238E27FC236}">
-                <a16:creationId xmlns:a16="http://schemas.microsoft.com/office/drawing/2014/main" id="{306D3475-75B5-48FF-A6FB-30DD056F424F}"/>
+                <a16:creationId xmlns:a16="http://schemas.microsoft.com/office/drawing/2014/main" id="{F219D261-6DF8-400D-B6F8-A19A21761192}"/>
               </a:ext>
             </a:extLst>
           </p:cNvPr>
@@ -2853,7 +3013,7 @@
           <p:cNvPr id="2" name="">
             <a:extLst xmlns:a="http://schemas.openxmlformats.org/drawingml/2006/main">
               <a:ext uri="{FF2B5EF4-FFF2-40B4-BE49-F238E27FC236}">
-                <a16:creationId xmlns:a16="http://schemas.microsoft.com/office/drawing/2014/main" id="{3B11E1C3-ED76-410B-AAD1-ADCC33747870}"/>
+                <a16:creationId xmlns:a16="http://schemas.microsoft.com/office/drawing/2014/main" id="{FDF59231-EB74-4886-ADE1-E34B383E4202}"/>
               </a:ext>
             </a:extLst>
           </p:cNvPr>
@@ -2910,7 +3070,7 @@
           <p:cNvPr id="3" name="">
             <a:extLst xmlns:a="http://schemas.openxmlformats.org/drawingml/2006/main">
               <a:ext uri="{FF2B5EF4-FFF2-40B4-BE49-F238E27FC236}">
-                <a16:creationId xmlns:a16="http://schemas.microsoft.com/office/drawing/2014/main" id="{34E178B9-C03C-4983-89B7-050C8DEC05F1}"/>
+                <a16:creationId xmlns:a16="http://schemas.microsoft.com/office/drawing/2014/main" id="{4874E86C-3841-4707-ADBE-150F0EA1067D}"/>
               </a:ext>
             </a:extLst>
           </p:cNvPr>
@@ -2967,7 +3127,7 @@
           <p:cNvPr id="4" name="">
             <a:extLst xmlns:a="http://schemas.openxmlformats.org/drawingml/2006/main">
               <a:ext uri="{FF2B5EF4-FFF2-40B4-BE49-F238E27FC236}">
-                <a16:creationId xmlns:a16="http://schemas.microsoft.com/office/drawing/2014/main" id="{6F42315F-551B-4001-B582-403CF92D4A65}"/>
+                <a16:creationId xmlns:a16="http://schemas.microsoft.com/office/drawing/2014/main" id="{80B80F21-36A8-4422-8062-0277D9FE65CB}"/>
               </a:ext>
             </a:extLst>
           </p:cNvPr>
@@ -3024,7 +3184,7 @@
           <p:cNvPr id="5" name="">
             <a:extLst xmlns:a="http://schemas.openxmlformats.org/drawingml/2006/main">
               <a:ext uri="{FF2B5EF4-FFF2-40B4-BE49-F238E27FC236}">
-                <a16:creationId xmlns:a16="http://schemas.microsoft.com/office/drawing/2014/main" id="{1611B439-9B6C-49E4-B33C-A724E36437B2}"/>
+                <a16:creationId xmlns:a16="http://schemas.microsoft.com/office/drawing/2014/main" id="{B8C01B9F-EA4A-4521-A676-3967A1E88047}"/>
               </a:ext>
             </a:extLst>
           </p:cNvPr>
@@ -3427,7 +3587,7 @@
           <p:cNvPr id="7" name="">
             <a:extLst xmlns:a="http://schemas.openxmlformats.org/drawingml/2006/main">
               <a:ext uri="{FF2B5EF4-FFF2-40B4-BE49-F238E27FC236}">
-                <a16:creationId xmlns:a16="http://schemas.microsoft.com/office/drawing/2014/main" id="{0E2DC272-A399-41E0-8A6A-7862CF4A7163}"/>
+                <a16:creationId xmlns:a16="http://schemas.microsoft.com/office/drawing/2014/main" id="{5C621185-6CDF-4C8D-B006-D5D70A3DDBA8}"/>
               </a:ext>
             </a:extLst>
           </p:cNvPr>
@@ -3484,7 +3644,7 @@
           <p:cNvPr id="8" name="">
             <a:extLst xmlns:a="http://schemas.openxmlformats.org/drawingml/2006/main">
               <a:ext uri="{FF2B5EF4-FFF2-40B4-BE49-F238E27FC236}">
-                <a16:creationId xmlns:a16="http://schemas.microsoft.com/office/drawing/2014/main" id="{846C051C-9491-44FB-855E-AA2F9A5F7F3E}"/>
+                <a16:creationId xmlns:a16="http://schemas.microsoft.com/office/drawing/2014/main" id="{8C1C3A7E-F27F-47A2-8326-487F3B3A456B}"/>
               </a:ext>
             </a:extLst>
           </p:cNvPr>
@@ -3531,7 +3691,7 @@
                 <a:ea typeface="Arial"/>
                 <a:cs typeface="Arial"/>
               </a:rPr>
-              <a:t>Fonte: dados oficiais do ES e dicionário fornecidos. Recorte de 2024.</a:t>
+              <a:t>Fonte: quatro partes e dicionário fornecidos. Recorte sistemático de 2024.</a:t>
             </a:r>
           </a:p>
         </p:txBody>
@@ -3539,7 +3699,7 @@
     </p:spTree>
     <p:extLst>
       <p:ext uri="{BB962C8B-B14F-4D97-AF65-F5344CB8AC3E}">
-        <p14:creationId xmlns:p14="http://schemas.microsoft.com/office/powerpoint/2010/main" val="1911059621"/>
+        <p14:creationId xmlns:p14="http://schemas.microsoft.com/office/powerpoint/2010/main" val="1039455158"/>
       </p:ext>
     </p:extLst>
   </p:cSld>
@@ -3570,7 +3730,7 @@
           <p:cNvPr id="9" name="">
             <a:extLst xmlns:a="http://schemas.openxmlformats.org/drawingml/2006/main">
               <a:ext uri="{FF2B5EF4-FFF2-40B4-BE49-F238E27FC236}">
-                <a16:creationId xmlns:a16="http://schemas.microsoft.com/office/drawing/2014/main" id="{DF4CE51D-590B-4978-8B9E-2ED73E7C5CD8}"/>
+                <a16:creationId xmlns:a16="http://schemas.microsoft.com/office/drawing/2014/main" id="{7851D8D6-FD0E-4781-9CA8-9F02F1109C4E}"/>
               </a:ext>
             </a:extLst>
           </p:cNvPr>
@@ -3627,7 +3787,7 @@
           <p:cNvPr id="2" name="">
             <a:extLst xmlns:a="http://schemas.openxmlformats.org/drawingml/2006/main">
               <a:ext uri="{FF2B5EF4-FFF2-40B4-BE49-F238E27FC236}">
-                <a16:creationId xmlns:a16="http://schemas.microsoft.com/office/drawing/2014/main" id="{DAEA6E39-5CCC-4C4F-8E15-AC3283D802EF}"/>
+                <a16:creationId xmlns:a16="http://schemas.microsoft.com/office/drawing/2014/main" id="{8255BA58-4B22-492B-8BFB-C02887986088}"/>
               </a:ext>
             </a:extLst>
           </p:cNvPr>
@@ -3684,7 +3844,7 @@
           <p:cNvPr id="3" name="">
             <a:extLst xmlns:a="http://schemas.openxmlformats.org/drawingml/2006/main">
               <a:ext uri="{FF2B5EF4-FFF2-40B4-BE49-F238E27FC236}">
-                <a16:creationId xmlns:a16="http://schemas.microsoft.com/office/drawing/2014/main" id="{CA5271AB-D145-48EC-B90B-B038ACF950A2}"/>
+                <a16:creationId xmlns:a16="http://schemas.microsoft.com/office/drawing/2014/main" id="{C9F9B566-6C95-410A-872A-281AFF79EC74}"/>
               </a:ext>
             </a:extLst>
           </p:cNvPr>
@@ -3748,7 +3908,7 @@
         </p:xfrm>
         <a:graphic xmlns:a="http://schemas.openxmlformats.org/drawingml/2006/main">
           <a:graphicData uri="http://schemas.openxmlformats.org/drawingml/2006/chart">
-            <c:chart xmlns:r="http://schemas.openxmlformats.org/officeDocument/2006/relationships" xmlns:c="http://schemas.openxmlformats.org/drawingml/2006/chart" r:id="Re839f346741d4800"/>
+            <c:chart xmlns:r="http://schemas.openxmlformats.org/officeDocument/2006/relationships" xmlns:c="http://schemas.openxmlformats.org/drawingml/2006/chart" r:id="Rafdf025559d1421d"/>
           </a:graphicData>
         </a:graphic>
       </p:graphicFrame>
@@ -3757,7 +3917,7 @@
           <p:cNvPr id="5" name="">
             <a:extLst xmlns:a="http://schemas.openxmlformats.org/drawingml/2006/main">
               <a:ext uri="{FF2B5EF4-FFF2-40B4-BE49-F238E27FC236}">
-                <a16:creationId xmlns:a16="http://schemas.microsoft.com/office/drawing/2014/main" id="{FAE7C030-76D1-4147-8D97-3D9B8AE6256D}"/>
+                <a16:creationId xmlns:a16="http://schemas.microsoft.com/office/drawing/2014/main" id="{69EFF1BA-6CAB-4FBC-A6F1-A5849225996F}"/>
               </a:ext>
             </a:extLst>
           </p:cNvPr>
@@ -3837,7 +3997,7 @@
           <p:cNvPr id="6" name="">
             <a:extLst xmlns:a="http://schemas.openxmlformats.org/drawingml/2006/main">
               <a:ext uri="{FF2B5EF4-FFF2-40B4-BE49-F238E27FC236}">
-                <a16:creationId xmlns:a16="http://schemas.microsoft.com/office/drawing/2014/main" id="{4904999C-6451-403A-B245-49A5ED1D9302}"/>
+                <a16:creationId xmlns:a16="http://schemas.microsoft.com/office/drawing/2014/main" id="{39AEDAFF-8897-43F9-849B-B34B368F387C}"/>
               </a:ext>
             </a:extLst>
           </p:cNvPr>
@@ -3894,7 +4054,7 @@
           <p:cNvPr id="7" name="">
             <a:extLst xmlns:a="http://schemas.openxmlformats.org/drawingml/2006/main">
               <a:ext uri="{FF2B5EF4-FFF2-40B4-BE49-F238E27FC236}">
-                <a16:creationId xmlns:a16="http://schemas.microsoft.com/office/drawing/2014/main" id="{A183D704-43D6-4428-BF3C-ADC845515C55}"/>
+                <a16:creationId xmlns:a16="http://schemas.microsoft.com/office/drawing/2014/main" id="{06E93DC5-9D8D-48E6-B061-8679E94BA6BD}"/>
               </a:ext>
             </a:extLst>
           </p:cNvPr>
@@ -3951,7 +4111,7 @@
           <p:cNvPr id="8" name="">
             <a:extLst xmlns:a="http://schemas.openxmlformats.org/drawingml/2006/main">
               <a:ext uri="{FF2B5EF4-FFF2-40B4-BE49-F238E27FC236}">
-                <a16:creationId xmlns:a16="http://schemas.microsoft.com/office/drawing/2014/main" id="{B5BB5AB0-BCD8-4E7A-B0CF-F52B70D9187B}"/>
+                <a16:creationId xmlns:a16="http://schemas.microsoft.com/office/drawing/2014/main" id="{CA93AF28-C812-4EA3-8D4F-CBD2D2BCCF4B}"/>
               </a:ext>
             </a:extLst>
           </p:cNvPr>
@@ -4006,7 +4166,7 @@
     </p:spTree>
     <p:extLst>
       <p:ext uri="{BB962C8B-B14F-4D97-AF65-F5344CB8AC3E}">
-        <p14:creationId xmlns:p14="http://schemas.microsoft.com/office/powerpoint/2010/main" val="802329555"/>
+        <p14:creationId xmlns:p14="http://schemas.microsoft.com/office/powerpoint/2010/main" val="1862905308"/>
       </p:ext>
     </p:extLst>
   </p:cSld>
@@ -4037,7 +4197,7 @@
           <p:cNvPr id="10" name="">
             <a:extLst xmlns:a="http://schemas.openxmlformats.org/drawingml/2006/main">
               <a:ext uri="{FF2B5EF4-FFF2-40B4-BE49-F238E27FC236}">
-                <a16:creationId xmlns:a16="http://schemas.microsoft.com/office/drawing/2014/main" id="{AECD41B2-536B-4A0C-AC81-45DB445059EB}"/>
+                <a16:creationId xmlns:a16="http://schemas.microsoft.com/office/drawing/2014/main" id="{C9296F4D-102A-4416-AD20-491B324D5791}"/>
               </a:ext>
             </a:extLst>
           </p:cNvPr>
@@ -4094,7 +4254,7 @@
           <p:cNvPr id="2" name="">
             <a:extLst xmlns:a="http://schemas.openxmlformats.org/drawingml/2006/main">
               <a:ext uri="{FF2B5EF4-FFF2-40B4-BE49-F238E27FC236}">
-                <a16:creationId xmlns:a16="http://schemas.microsoft.com/office/drawing/2014/main" id="{A733F187-FE7C-4635-B887-08C34312704B}"/>
+                <a16:creationId xmlns:a16="http://schemas.microsoft.com/office/drawing/2014/main" id="{6FE8594B-CE26-4150-B068-00A63962DCFC}"/>
               </a:ext>
             </a:extLst>
           </p:cNvPr>
@@ -4151,7 +4311,7 @@
           <p:cNvPr id="3" name="">
             <a:extLst xmlns:a="http://schemas.openxmlformats.org/drawingml/2006/main">
               <a:ext uri="{FF2B5EF4-FFF2-40B4-BE49-F238E27FC236}">
-                <a16:creationId xmlns:a16="http://schemas.microsoft.com/office/drawing/2014/main" id="{2B0EBFA3-5FC6-403D-BC70-9B17C1DCAF1D}"/>
+                <a16:creationId xmlns:a16="http://schemas.microsoft.com/office/drawing/2014/main" id="{7D2A1FBE-BC08-4B60-9F72-3193F28703E4}"/>
               </a:ext>
             </a:extLst>
           </p:cNvPr>
@@ -4215,7 +4375,7 @@
         </p:xfrm>
         <a:graphic xmlns:a="http://schemas.openxmlformats.org/drawingml/2006/main">
           <a:graphicData uri="http://schemas.openxmlformats.org/drawingml/2006/chart">
-            <c:chart xmlns:r="http://schemas.openxmlformats.org/officeDocument/2006/relationships" xmlns:c="http://schemas.openxmlformats.org/drawingml/2006/chart" r:id="R92ea2ab05b0b4275"/>
+            <c:chart xmlns:r="http://schemas.openxmlformats.org/officeDocument/2006/relationships" xmlns:c="http://schemas.openxmlformats.org/drawingml/2006/chart" r:id="Raaf3c670b1834ddd"/>
           </a:graphicData>
         </a:graphic>
       </p:graphicFrame>
@@ -4224,7 +4384,7 @@
           <p:cNvPr id="5" name="">
             <a:extLst xmlns:a="http://schemas.openxmlformats.org/drawingml/2006/main">
               <a:ext uri="{FF2B5EF4-FFF2-40B4-BE49-F238E27FC236}">
-                <a16:creationId xmlns:a16="http://schemas.microsoft.com/office/drawing/2014/main" id="{CCB1DE0B-1C8C-4AEB-BEFA-4874B462E05E}"/>
+                <a16:creationId xmlns:a16="http://schemas.microsoft.com/office/drawing/2014/main" id="{1A866E17-F494-4572-9480-2B8BEA0DD40D}"/>
               </a:ext>
             </a:extLst>
           </p:cNvPr>
@@ -4281,7 +4441,7 @@
           <p:cNvPr id="6" name="">
             <a:extLst xmlns:a="http://schemas.openxmlformats.org/drawingml/2006/main">
               <a:ext uri="{FF2B5EF4-FFF2-40B4-BE49-F238E27FC236}">
-                <a16:creationId xmlns:a16="http://schemas.microsoft.com/office/drawing/2014/main" id="{3EC96E6E-25E9-465F-BE82-63C594FD20B8}"/>
+                <a16:creationId xmlns:a16="http://schemas.microsoft.com/office/drawing/2014/main" id="{E983E483-2386-46BE-8CC0-1A2BD7782D7D}"/>
               </a:ext>
             </a:extLst>
           </p:cNvPr>
@@ -4384,7 +4544,7 @@
           <p:cNvPr id="7" name="">
             <a:extLst xmlns:a="http://schemas.openxmlformats.org/drawingml/2006/main">
               <a:ext uri="{FF2B5EF4-FFF2-40B4-BE49-F238E27FC236}">
-                <a16:creationId xmlns:a16="http://schemas.microsoft.com/office/drawing/2014/main" id="{7E2FFD40-28FA-46D0-BF40-AB4D850BE394}"/>
+                <a16:creationId xmlns:a16="http://schemas.microsoft.com/office/drawing/2014/main" id="{5BEC3D0D-B753-43B5-944A-50487F012013}"/>
               </a:ext>
             </a:extLst>
           </p:cNvPr>
@@ -4441,7 +4601,7 @@
           <p:cNvPr id="8" name="">
             <a:extLst xmlns:a="http://schemas.openxmlformats.org/drawingml/2006/main">
               <a:ext uri="{FF2B5EF4-FFF2-40B4-BE49-F238E27FC236}">
-                <a16:creationId xmlns:a16="http://schemas.microsoft.com/office/drawing/2014/main" id="{EC03EB50-9A92-4114-9274-8DAB38502057}"/>
+                <a16:creationId xmlns:a16="http://schemas.microsoft.com/office/drawing/2014/main" id="{770D946F-7C51-43D9-AA18-AF04B29723D1}"/>
               </a:ext>
             </a:extLst>
           </p:cNvPr>
@@ -4521,7 +4681,7 @@
           <p:cNvPr id="9" name="">
             <a:extLst xmlns:a="http://schemas.openxmlformats.org/drawingml/2006/main">
               <a:ext uri="{FF2B5EF4-FFF2-40B4-BE49-F238E27FC236}">
-                <a16:creationId xmlns:a16="http://schemas.microsoft.com/office/drawing/2014/main" id="{48F62FB7-AB2A-4834-AC5F-4F9BD4A9C863}"/>
+                <a16:creationId xmlns:a16="http://schemas.microsoft.com/office/drawing/2014/main" id="{846C6AAC-E58B-4EDE-B872-3D9B80349852}"/>
               </a:ext>
             </a:extLst>
           </p:cNvPr>
@@ -4576,7 +4736,7 @@
     </p:spTree>
     <p:extLst>
       <p:ext uri="{BB962C8B-B14F-4D97-AF65-F5344CB8AC3E}">
-        <p14:creationId xmlns:p14="http://schemas.microsoft.com/office/powerpoint/2010/main" val="38195640"/>
+        <p14:creationId xmlns:p14="http://schemas.microsoft.com/office/powerpoint/2010/main" val="1194591531"/>
       </p:ext>
     </p:extLst>
   </p:cSld>
@@ -4607,7 +4767,7 @@
           <p:cNvPr id="8" name="">
             <a:extLst xmlns:a="http://schemas.openxmlformats.org/drawingml/2006/main">
               <a:ext uri="{FF2B5EF4-FFF2-40B4-BE49-F238E27FC236}">
-                <a16:creationId xmlns:a16="http://schemas.microsoft.com/office/drawing/2014/main" id="{3DFC7A29-45BA-4D43-87FD-A334C3221431}"/>
+                <a16:creationId xmlns:a16="http://schemas.microsoft.com/office/drawing/2014/main" id="{081EAF1A-6985-4451-AB11-C47119CF9130}"/>
               </a:ext>
             </a:extLst>
           </p:cNvPr>
@@ -4664,7 +4824,7 @@
           <p:cNvPr id="2" name="">
             <a:extLst xmlns:a="http://schemas.openxmlformats.org/drawingml/2006/main">
               <a:ext uri="{FF2B5EF4-FFF2-40B4-BE49-F238E27FC236}">
-                <a16:creationId xmlns:a16="http://schemas.microsoft.com/office/drawing/2014/main" id="{17574C84-49C0-4AF0-BD99-ECC4967EB680}"/>
+                <a16:creationId xmlns:a16="http://schemas.microsoft.com/office/drawing/2014/main" id="{C61FD9A9-760E-402A-8A59-68B786868BA1}"/>
               </a:ext>
             </a:extLst>
           </p:cNvPr>
@@ -5013,7 +5173,7 @@
           <p:cNvPr id="4" name="">
             <a:extLst xmlns:a="http://schemas.openxmlformats.org/drawingml/2006/main">
               <a:ext uri="{FF2B5EF4-FFF2-40B4-BE49-F238E27FC236}">
-                <a16:creationId xmlns:a16="http://schemas.microsoft.com/office/drawing/2014/main" id="{1F47D3F6-F4D0-410B-ADCC-99EC3E71D718}"/>
+                <a16:creationId xmlns:a16="http://schemas.microsoft.com/office/drawing/2014/main" id="{F3190326-E5A4-4A98-A1DA-E07EB5B21DAA}"/>
               </a:ext>
             </a:extLst>
           </p:cNvPr>
@@ -5070,7 +5230,7 @@
           <p:cNvPr id="5" name="">
             <a:extLst xmlns:a="http://schemas.openxmlformats.org/drawingml/2006/main">
               <a:ext uri="{FF2B5EF4-FFF2-40B4-BE49-F238E27FC236}">
-                <a16:creationId xmlns:a16="http://schemas.microsoft.com/office/drawing/2014/main" id="{6E0C341A-2934-445F-BB29-E299E0C9F2D0}"/>
+                <a16:creationId xmlns:a16="http://schemas.microsoft.com/office/drawing/2014/main" id="{99248532-C36C-456D-910E-698013D8CAD6}"/>
               </a:ext>
             </a:extLst>
           </p:cNvPr>
@@ -5150,7 +5310,7 @@
           <p:cNvPr id="6" name="">
             <a:extLst xmlns:a="http://schemas.openxmlformats.org/drawingml/2006/main">
               <a:ext uri="{FF2B5EF4-FFF2-40B4-BE49-F238E27FC236}">
-                <a16:creationId xmlns:a16="http://schemas.microsoft.com/office/drawing/2014/main" id="{D9409559-1A9E-42F2-BE84-5F6D0AC4D330}"/>
+                <a16:creationId xmlns:a16="http://schemas.microsoft.com/office/drawing/2014/main" id="{0E560EE2-06AB-464A-AC0B-5F06F0C8863F}"/>
               </a:ext>
             </a:extLst>
           </p:cNvPr>
@@ -5207,7 +5367,7 @@
           <p:cNvPr id="7" name="">
             <a:extLst xmlns:a="http://schemas.openxmlformats.org/drawingml/2006/main">
               <a:ext uri="{FF2B5EF4-FFF2-40B4-BE49-F238E27FC236}">
-                <a16:creationId xmlns:a16="http://schemas.microsoft.com/office/drawing/2014/main" id="{BB9EB03A-0C90-4F38-A830-60612F6FF87B}"/>
+                <a16:creationId xmlns:a16="http://schemas.microsoft.com/office/drawing/2014/main" id="{3E16F86B-3956-40B1-B1B3-A021834F566B}"/>
               </a:ext>
             </a:extLst>
           </p:cNvPr>
@@ -5262,7 +5422,7 @@
     </p:spTree>
     <p:extLst>
       <p:ext uri="{BB962C8B-B14F-4D97-AF65-F5344CB8AC3E}">
-        <p14:creationId xmlns:p14="http://schemas.microsoft.com/office/powerpoint/2010/main" val="446818158"/>
+        <p14:creationId xmlns:p14="http://schemas.microsoft.com/office/powerpoint/2010/main" val="537081872"/>
       </p:ext>
     </p:extLst>
   </p:cSld>
@@ -5293,7 +5453,7 @@
           <p:cNvPr id="6" name="">
             <a:extLst xmlns:a="http://schemas.openxmlformats.org/drawingml/2006/main">
               <a:ext uri="{FF2B5EF4-FFF2-40B4-BE49-F238E27FC236}">
-                <a16:creationId xmlns:a16="http://schemas.microsoft.com/office/drawing/2014/main" id="{336B08F8-FDA2-4E47-ACF5-A894CAED2C45}"/>
+                <a16:creationId xmlns:a16="http://schemas.microsoft.com/office/drawing/2014/main" id="{58637495-1A4C-424F-BAEA-A85D6C4F49CA}"/>
               </a:ext>
             </a:extLst>
           </p:cNvPr>
@@ -5350,7 +5510,7 @@
           <p:cNvPr id="2" name="">
             <a:extLst xmlns:a="http://schemas.openxmlformats.org/drawingml/2006/main">
               <a:ext uri="{FF2B5EF4-FFF2-40B4-BE49-F238E27FC236}">
-                <a16:creationId xmlns:a16="http://schemas.microsoft.com/office/drawing/2014/main" id="{C39E7EE8-2A7D-4D3B-8172-B8F24A6F11E5}"/>
+                <a16:creationId xmlns:a16="http://schemas.microsoft.com/office/drawing/2014/main" id="{767A450A-91A2-40C8-9B3E-758728BF91CF}"/>
               </a:ext>
             </a:extLst>
           </p:cNvPr>
@@ -5518,7 +5678,7 @@
                           <a:ea typeface="Arial"/>
                           <a:cs typeface="Arial"/>
                         </a:rPr>
-                        <a:t>Integrante 1</a:t>
+                        <a:t>Luigi Mendes Cabrini</a:t>
                       </a:r>
                     </a:p>
                   </a:txBody>
@@ -5598,7 +5758,7 @@
                           <a:ea typeface="Arial"/>
                           <a:cs typeface="Arial"/>
                         </a:rPr>
-                        <a:t>Integrante 2</a:t>
+                        <a:t>Bruno Koeke</a:t>
                       </a:r>
                     </a:p>
                   </a:txBody>
@@ -5678,7 +5838,7 @@
                           <a:ea typeface="Arial"/>
                           <a:cs typeface="Arial"/>
                         </a:rPr>
-                        <a:t>Integrante 3</a:t>
+                        <a:t>Rogério Cruz Arroyo</a:t>
                       </a:r>
                     </a:p>
                   </a:txBody>
@@ -5758,7 +5918,7 @@
                           <a:ea typeface="Arial"/>
                           <a:cs typeface="Arial"/>
                         </a:rPr>
-                        <a:t>Integrante 4</a:t>
+                        <a:t>Anthony Sforzin</a:t>
                       </a:r>
                     </a:p>
                   </a:txBody>
@@ -5832,7 +5992,7 @@
           <p:nvPr/>
         </p:nvGraphicFramePr>
         <p:xfrm>
-          <a:off xmlns:a="http://schemas.openxmlformats.org/drawingml/2006/main" x="609600" y="3619500"/>
+          <a:off xmlns:a="http://schemas.openxmlformats.org/drawingml/2006/main" x="609600" y="3562350"/>
           <a:ext xmlns:a="http://schemas.openxmlformats.org/drawingml/2006/main" cx="10972800" cy="2524125"/>
         </p:xfrm>
         <a:graphic xmlns:a="http://schemas.openxmlformats.org/drawingml/2006/main">
@@ -5865,7 +6025,7 @@
                       </a:r>
                     </a:p>
                   </a:txBody>
-                  <a:tcPr marL="91440" marR="91440" marT="45720" marB="45720">
+                  <a:tcPr marL="95250" marR="95250" marT="19050" marB="19050">
                     <a:solidFill>
                       <a:srgbClr val="122D3D"/>
                     </a:solidFill>
@@ -5891,7 +6051,7 @@
                       </a:r>
                     </a:p>
                   </a:txBody>
-                  <a:tcPr marL="91440" marR="91440" marT="45720" marB="45720">
+                  <a:tcPr marL="95250" marR="95250" marT="19050" marB="19050">
                     <a:solidFill>
                       <a:srgbClr val="122D3D"/>
                     </a:solidFill>
@@ -5917,7 +6077,7 @@
                       </a:r>
                     </a:p>
                   </a:txBody>
-                  <a:tcPr marL="91440" marR="91440" marT="45720" marB="45720">
+                  <a:tcPr marL="95250" marR="95250" marT="19050" marB="19050">
                     <a:solidFill>
                       <a:srgbClr val="122D3D"/>
                     </a:solidFill>
@@ -5945,7 +6105,7 @@
                       </a:r>
                     </a:p>
                   </a:txBody>
-                  <a:tcPr marL="91440" marR="91440" marT="45720" marB="45720">
+                  <a:tcPr marL="95250" marR="95250" marT="19050" marB="19050">
                     <a:solidFill>
                       <a:srgbClr val="FFFFFF"/>
                     </a:solidFill>
@@ -5971,7 +6131,7 @@
                       </a:r>
                     </a:p>
                   </a:txBody>
-                  <a:tcPr marL="91440" marR="91440" marT="45720" marB="45720">
+                  <a:tcPr marL="95250" marR="95250" marT="19050" marB="19050">
                     <a:solidFill>
                       <a:srgbClr val="FFFFFF"/>
                     </a:solidFill>
@@ -5997,7 +6157,7 @@
                       </a:r>
                     </a:p>
                   </a:txBody>
-                  <a:tcPr marL="91440" marR="91440" marT="45720" marB="45720">
+                  <a:tcPr marL="95250" marR="95250" marT="19050" marB="19050">
                     <a:solidFill>
                       <a:srgbClr val="FFFFFF"/>
                     </a:solidFill>
@@ -6025,7 +6185,7 @@
                       </a:r>
                     </a:p>
                   </a:txBody>
-                  <a:tcPr marL="91440" marR="91440" marT="45720" marB="45720">
+                  <a:tcPr marL="95250" marR="95250" marT="19050" marB="19050">
                     <a:solidFill>
                       <a:srgbClr val="FFFFFF"/>
                     </a:solidFill>
@@ -6051,7 +6211,7 @@
                       </a:r>
                     </a:p>
                   </a:txBody>
-                  <a:tcPr marL="91440" marR="91440" marT="45720" marB="45720">
+                  <a:tcPr marL="95250" marR="95250" marT="19050" marB="19050">
                     <a:solidFill>
                       <a:srgbClr val="FFFFFF"/>
                     </a:solidFill>
@@ -6077,7 +6237,7 @@
                       </a:r>
                     </a:p>
                   </a:txBody>
-                  <a:tcPr marL="91440" marR="91440" marT="45720" marB="45720">
+                  <a:tcPr marL="95250" marR="95250" marT="19050" marB="19050">
                     <a:solidFill>
                       <a:srgbClr val="FFFFFF"/>
                     </a:solidFill>
@@ -6105,7 +6265,7 @@
                       </a:r>
                     </a:p>
                   </a:txBody>
-                  <a:tcPr marL="91440" marR="91440" marT="45720" marB="45720">
+                  <a:tcPr marL="95250" marR="95250" marT="19050" marB="19050">
                     <a:solidFill>
                       <a:srgbClr val="FFFFFF"/>
                     </a:solidFill>
@@ -6131,7 +6291,7 @@
                       </a:r>
                     </a:p>
                   </a:txBody>
-                  <a:tcPr marL="91440" marR="91440" marT="45720" marB="45720">
+                  <a:tcPr marL="95250" marR="95250" marT="19050" marB="19050">
                     <a:solidFill>
                       <a:srgbClr val="FFFFFF"/>
                     </a:solidFill>
@@ -6157,7 +6317,7 @@
                       </a:r>
                     </a:p>
                   </a:txBody>
-                  <a:tcPr marL="91440" marR="91440" marT="45720" marB="45720">
+                  <a:tcPr marL="95250" marR="95250" marT="19050" marB="19050">
                     <a:solidFill>
                       <a:srgbClr val="FFFFFF"/>
                     </a:solidFill>
@@ -6185,7 +6345,7 @@
                       </a:r>
                     </a:p>
                   </a:txBody>
-                  <a:tcPr marL="91440" marR="91440" marT="45720" marB="45720">
+                  <a:tcPr marL="95250" marR="95250" marT="19050" marB="19050">
                     <a:solidFill>
                       <a:srgbClr val="FFFFFF"/>
                     </a:solidFill>
@@ -6211,7 +6371,7 @@
                       </a:r>
                     </a:p>
                   </a:txBody>
-                  <a:tcPr marL="91440" marR="91440" marT="45720" marB="45720">
+                  <a:tcPr marL="95250" marR="95250" marT="19050" marB="19050">
                     <a:solidFill>
                       <a:srgbClr val="FFFFFF"/>
                     </a:solidFill>
@@ -6237,7 +6397,7 @@
                       </a:r>
                     </a:p>
                   </a:txBody>
-                  <a:tcPr marL="91440" marR="91440" marT="45720" marB="45720">
+                  <a:tcPr marL="95250" marR="95250" marT="19050" marB="19050">
                     <a:solidFill>
                       <a:srgbClr val="FFFFFF"/>
                     </a:solidFill>
@@ -6265,7 +6425,7 @@
                       </a:r>
                     </a:p>
                   </a:txBody>
-                  <a:tcPr marL="91440" marR="91440" marT="45720" marB="45720">
+                  <a:tcPr marL="95250" marR="95250" marT="19050" marB="19050">
                     <a:solidFill>
                       <a:srgbClr val="FFFFFF"/>
                     </a:solidFill>
@@ -6291,7 +6451,7 @@
                       </a:r>
                     </a:p>
                   </a:txBody>
-                  <a:tcPr marL="91440" marR="91440" marT="45720" marB="45720">
+                  <a:tcPr marL="95250" marR="95250" marT="19050" marB="19050">
                     <a:solidFill>
                       <a:srgbClr val="FFFFFF"/>
                     </a:solidFill>
@@ -6313,11 +6473,11 @@
                           <a:ea typeface="Arial"/>
                           <a:cs typeface="Arial"/>
                         </a:rPr>
-                        <a:t>Versão integrada, revisão de uso e dados expostos</a:t>
+                        <a:t>Testes sem falhas e exportação aprovada em ata</a:t>
                       </a:r>
                     </a:p>
                   </a:txBody>
-                  <a:tcPr marL="91440" marR="91440" marT="45720" marB="45720">
+                  <a:tcPr marL="95250" marR="95250" marT="19050" marB="19050">
                     <a:solidFill>
                       <a:srgbClr val="FFFFFF"/>
                     </a:solidFill>
@@ -6345,7 +6505,7 @@
                       </a:r>
                     </a:p>
                   </a:txBody>
-                  <a:tcPr marL="91440" marR="91440" marT="45720" marB="45720">
+                  <a:tcPr marL="95250" marR="95250" marT="19050" marB="19050">
                     <a:solidFill>
                       <a:srgbClr val="FFFFFF"/>
                     </a:solidFill>
@@ -6371,7 +6531,7 @@
                       </a:r>
                     </a:p>
                   </a:txBody>
-                  <a:tcPr marL="91440" marR="91440" marT="45720" marB="45720">
+                  <a:tcPr marL="95250" marR="95250" marT="19050" marB="19050">
                     <a:solidFill>
                       <a:srgbClr val="FFFFFF"/>
                     </a:solidFill>
@@ -6393,11 +6553,11 @@
                           <a:ea typeface="Arial"/>
                           <a:cs typeface="Arial"/>
                         </a:rPr>
-                        <a:t>Sem pendências críticas, pacote reproduzível</a:t>
+                        <a:t>Ambiente limpo: jornada e total de referência</a:t>
                       </a:r>
                     </a:p>
                   </a:txBody>
-                  <a:tcPr marL="91440" marR="91440" marT="45720" marB="45720">
+                  <a:tcPr marL="95250" marR="95250" marT="19050" marB="19050">
                     <a:solidFill>
                       <a:srgbClr val="FFFFFF"/>
                     </a:solidFill>
@@ -6413,7 +6573,7 @@
           <p:cNvPr id="5" name="">
             <a:extLst xmlns:a="http://schemas.openxmlformats.org/drawingml/2006/main">
               <a:ext uri="{FF2B5EF4-FFF2-40B4-BE49-F238E27FC236}">
-                <a16:creationId xmlns:a16="http://schemas.microsoft.com/office/drawing/2014/main" id="{6E84873C-5B84-4B1D-9164-28A51E1308B9}"/>
+                <a16:creationId xmlns:a16="http://schemas.microsoft.com/office/drawing/2014/main" id="{567F14BD-D936-40D5-BA73-B90925A93139}"/>
               </a:ext>
             </a:extLst>
           </p:cNvPr>
@@ -6460,7 +6620,7 @@
                 <a:ea typeface="Arial"/>
                 <a:cs typeface="Arial"/>
               </a:rPr>
-              <a:t>Funções e horas planejadas. A POC da atividade funciona agora. Evolução posterior simulada.</a:t>
+              <a:t>Papéis propostos. Evolução da POC pronta. Grupo de 4: exceção ao requisito 5–8 pendente.</a:t>
             </a:r>
           </a:p>
         </p:txBody>
@@ -6468,7 +6628,7 @@
     </p:spTree>
     <p:extLst>
       <p:ext uri="{BB962C8B-B14F-4D97-AF65-F5344CB8AC3E}">
-        <p14:creationId xmlns:p14="http://schemas.microsoft.com/office/powerpoint/2010/main" val="1090815155"/>
+        <p14:creationId xmlns:p14="http://schemas.microsoft.com/office/powerpoint/2010/main" val="1497970044"/>
       </p:ext>
     </p:extLst>
   </p:cSld>
@@ -6499,7 +6659,7 @@
           <p:cNvPr id="13" name="">
             <a:extLst xmlns:a="http://schemas.openxmlformats.org/drawingml/2006/main">
               <a:ext uri="{FF2B5EF4-FFF2-40B4-BE49-F238E27FC236}">
-                <a16:creationId xmlns:a16="http://schemas.microsoft.com/office/drawing/2014/main" id="{97A4D4CE-9964-4F2D-A24C-DDA8F7D6F528}"/>
+                <a16:creationId xmlns:a16="http://schemas.microsoft.com/office/drawing/2014/main" id="{9EFEE35E-E169-48A2-9637-E13452B218D6}"/>
               </a:ext>
             </a:extLst>
           </p:cNvPr>
@@ -6556,7 +6716,7 @@
           <p:cNvPr id="2" name="">
             <a:extLst xmlns:a="http://schemas.openxmlformats.org/drawingml/2006/main">
               <a:ext uri="{FF2B5EF4-FFF2-40B4-BE49-F238E27FC236}">
-                <a16:creationId xmlns:a16="http://schemas.microsoft.com/office/drawing/2014/main" id="{7977AC7D-EACD-405E-8465-8D275FBF0645}"/>
+                <a16:creationId xmlns:a16="http://schemas.microsoft.com/office/drawing/2014/main" id="{2EEEE176-5B9D-403D-AE63-BC6E3A31FB3F}"/>
               </a:ext>
             </a:extLst>
           </p:cNvPr>
@@ -7067,7 +7227,7 @@
           <p:cNvPr id="4" name="">
             <a:extLst xmlns:a="http://schemas.openxmlformats.org/drawingml/2006/main">
               <a:ext uri="{FF2B5EF4-FFF2-40B4-BE49-F238E27FC236}">
-                <a16:creationId xmlns:a16="http://schemas.microsoft.com/office/drawing/2014/main" id="{D4132F94-85DC-4F9E-9855-9E99ADF042B6}"/>
+                <a16:creationId xmlns:a16="http://schemas.microsoft.com/office/drawing/2014/main" id="{25017396-3E5A-4613-9882-2D5065C91F44}"/>
               </a:ext>
             </a:extLst>
           </p:cNvPr>
@@ -7124,7 +7284,7 @@
           <p:cNvPr id="5" name="">
             <a:extLst xmlns:a="http://schemas.openxmlformats.org/drawingml/2006/main">
               <a:ext uri="{FF2B5EF4-FFF2-40B4-BE49-F238E27FC236}">
-                <a16:creationId xmlns:a16="http://schemas.microsoft.com/office/drawing/2014/main" id="{71AE72CD-E737-47A7-B109-95AD02FD7BA7}"/>
+                <a16:creationId xmlns:a16="http://schemas.microsoft.com/office/drawing/2014/main" id="{C0D663EA-AAFE-400A-8BFB-616309680A5D}"/>
               </a:ext>
             </a:extLst>
           </p:cNvPr>
@@ -7181,7 +7341,7 @@
           <p:cNvPr id="6" name="">
             <a:extLst xmlns:a="http://schemas.openxmlformats.org/drawingml/2006/main">
               <a:ext uri="{FF2B5EF4-FFF2-40B4-BE49-F238E27FC236}">
-                <a16:creationId xmlns:a16="http://schemas.microsoft.com/office/drawing/2014/main" id="{913EFF9D-96A4-47DF-A620-DA9492B9C9AE}"/>
+                <a16:creationId xmlns:a16="http://schemas.microsoft.com/office/drawing/2014/main" id="{BD29E54B-893E-430B-8E79-FA4899239C5D}"/>
               </a:ext>
             </a:extLst>
           </p:cNvPr>
@@ -7238,7 +7398,7 @@
           <p:cNvPr id="7" name="">
             <a:extLst xmlns:a="http://schemas.openxmlformats.org/drawingml/2006/main">
               <a:ext uri="{FF2B5EF4-FFF2-40B4-BE49-F238E27FC236}">
-                <a16:creationId xmlns:a16="http://schemas.microsoft.com/office/drawing/2014/main" id="{2AEA93CC-5A20-4795-86AE-792932EFFF91}"/>
+                <a16:creationId xmlns:a16="http://schemas.microsoft.com/office/drawing/2014/main" id="{0984251E-3C39-43DD-96B1-12C24163C143}"/>
               </a:ext>
             </a:extLst>
           </p:cNvPr>
@@ -7295,7 +7455,7 @@
           <p:cNvPr id="8" name="">
             <a:extLst xmlns:a="http://schemas.openxmlformats.org/drawingml/2006/main">
               <a:ext uri="{FF2B5EF4-FFF2-40B4-BE49-F238E27FC236}">
-                <a16:creationId xmlns:a16="http://schemas.microsoft.com/office/drawing/2014/main" id="{494167FB-8703-4FE0-8DAD-C08BF7AFC605}"/>
+                <a16:creationId xmlns:a16="http://schemas.microsoft.com/office/drawing/2014/main" id="{4E183D8B-F6B9-425C-8AA2-9BD4D7ACF3F1}"/>
               </a:ext>
             </a:extLst>
           </p:cNvPr>
@@ -7342,7 +7502,7 @@
                 <a:ea typeface="Arial"/>
                 <a:cs typeface="Arial"/>
               </a:rPr>
-              <a:t>Volume e desempenho</a:t>
+              <a:t>Soma e medidas</a:t>
             </a:r>
           </a:p>
         </p:txBody>
@@ -7352,7 +7512,7 @@
           <p:cNvPr id="9" name="">
             <a:extLst xmlns:a="http://schemas.openxmlformats.org/drawingml/2006/main">
               <a:ext uri="{FF2B5EF4-FFF2-40B4-BE49-F238E27FC236}">
-                <a16:creationId xmlns:a16="http://schemas.microsoft.com/office/drawing/2014/main" id="{CE565F0D-B6F2-4F08-9531-729478CD3534}"/>
+                <a16:creationId xmlns:a16="http://schemas.microsoft.com/office/drawing/2014/main" id="{C90C05F6-057C-40A7-9CBA-F093E0EFE954}"/>
               </a:ext>
             </a:extLst>
           </p:cNvPr>
@@ -7399,7 +7559,7 @@
                 <a:ea typeface="Arial"/>
                 <a:cs typeface="Arial"/>
               </a:rPr>
-              <a:t>Impacto: consulta lenta. Desenvolvimento usa índices e agrega no servidor.</a:t>
+              <a:t>Impacto: total incorreto. Testes reconcilia centavos e confere ValorPago.</a:t>
             </a:r>
           </a:p>
         </p:txBody>
@@ -7409,7 +7569,7 @@
           <p:cNvPr id="10" name="">
             <a:extLst xmlns:a="http://schemas.openxmlformats.org/drawingml/2006/main">
               <a:ext uri="{FF2B5EF4-FFF2-40B4-BE49-F238E27FC236}">
-                <a16:creationId xmlns:a16="http://schemas.microsoft.com/office/drawing/2014/main" id="{DC9E9A34-2A2E-43C1-9226-8E818A723E86}"/>
+                <a16:creationId xmlns:a16="http://schemas.microsoft.com/office/drawing/2014/main" id="{AA916096-CB8E-48D9-B0EC-9FDEB454859A}"/>
               </a:ext>
             </a:extLst>
           </p:cNvPr>
@@ -7466,7 +7626,7 @@
           <p:cNvPr id="11" name="">
             <a:extLst xmlns:a="http://schemas.openxmlformats.org/drawingml/2006/main">
               <a:ext uri="{FF2B5EF4-FFF2-40B4-BE49-F238E27FC236}">
-                <a16:creationId xmlns:a16="http://schemas.microsoft.com/office/drawing/2014/main" id="{20CA095F-4BAB-4F38-80CD-8C93B9706B5D}"/>
+                <a16:creationId xmlns:a16="http://schemas.microsoft.com/office/drawing/2014/main" id="{3FEDF11A-27A3-4543-AD64-DB6E73C7300D}"/>
               </a:ext>
             </a:extLst>
           </p:cNvPr>
@@ -7523,7 +7683,7 @@
           <p:cNvPr id="12" name="">
             <a:extLst xmlns:a="http://schemas.openxmlformats.org/drawingml/2006/main">
               <a:ext uri="{FF2B5EF4-FFF2-40B4-BE49-F238E27FC236}">
-                <a16:creationId xmlns:a16="http://schemas.microsoft.com/office/drawing/2014/main" id="{D4E8DC9F-7B87-4607-9240-65F24209DA5F}"/>
+                <a16:creationId xmlns:a16="http://schemas.microsoft.com/office/drawing/2014/main" id="{08AE3951-173A-4C51-B7E2-AA73B7AFF85A}"/>
               </a:ext>
             </a:extLst>
           </p:cNvPr>
@@ -7578,7 +7738,7 @@
     </p:spTree>
     <p:extLst>
       <p:ext uri="{BB962C8B-B14F-4D97-AF65-F5344CB8AC3E}">
-        <p14:creationId xmlns:p14="http://schemas.microsoft.com/office/powerpoint/2010/main" val="431199363"/>
+        <p14:creationId xmlns:p14="http://schemas.microsoft.com/office/powerpoint/2010/main" val="647987135"/>
       </p:ext>
     </p:extLst>
   </p:cSld>
@@ -7609,7 +7769,7 @@
           <p:cNvPr id="10" name="">
             <a:extLst xmlns:a="http://schemas.openxmlformats.org/drawingml/2006/main">
               <a:ext uri="{FF2B5EF4-FFF2-40B4-BE49-F238E27FC236}">
-                <a16:creationId xmlns:a16="http://schemas.microsoft.com/office/drawing/2014/main" id="{8C13F32C-5F24-4611-B598-E250E35F3BC0}"/>
+                <a16:creationId xmlns:a16="http://schemas.microsoft.com/office/drawing/2014/main" id="{ECDC9A8C-D39D-41C1-8A37-A4E3D490481A}"/>
               </a:ext>
             </a:extLst>
           </p:cNvPr>
@@ -7666,7 +7826,7 @@
           <p:cNvPr id="2" name="">
             <a:extLst xmlns:a="http://schemas.openxmlformats.org/drawingml/2006/main">
               <a:ext uri="{FF2B5EF4-FFF2-40B4-BE49-F238E27FC236}">
-                <a16:creationId xmlns:a16="http://schemas.microsoft.com/office/drawing/2014/main" id="{B81BD73A-2365-4231-B225-582B0C7580A2}"/>
+                <a16:creationId xmlns:a16="http://schemas.microsoft.com/office/drawing/2014/main" id="{794AEC6E-0818-4428-AA45-E1F7D0B2D79A}"/>
               </a:ext>
             </a:extLst>
           </p:cNvPr>
@@ -7723,7 +7883,7 @@
           <p:cNvPr id="3" name="">
             <a:extLst xmlns:a="http://schemas.openxmlformats.org/drawingml/2006/main">
               <a:ext uri="{FF2B5EF4-FFF2-40B4-BE49-F238E27FC236}">
-                <a16:creationId xmlns:a16="http://schemas.microsoft.com/office/drawing/2014/main" id="{90D1DEFE-5C94-480E-AF94-1B1CEF74EAF7}"/>
+                <a16:creationId xmlns:a16="http://schemas.microsoft.com/office/drawing/2014/main" id="{429B26A1-69A3-40A3-A70A-838904A3F0BF}"/>
               </a:ext>
             </a:extLst>
           </p:cNvPr>
@@ -7780,7 +7940,7 @@
           <p:cNvPr id="4" name="">
             <a:extLst xmlns:a="http://schemas.openxmlformats.org/drawingml/2006/main">
               <a:ext uri="{FF2B5EF4-FFF2-40B4-BE49-F238E27FC236}">
-                <a16:creationId xmlns:a16="http://schemas.microsoft.com/office/drawing/2014/main" id="{821FC01D-FE2C-494E-ACC5-8D0C5CA74C7E}"/>
+                <a16:creationId xmlns:a16="http://schemas.microsoft.com/office/drawing/2014/main" id="{A5F39475-6E12-406E-A25B-B73918E077F3}"/>
               </a:ext>
             </a:extLst>
           </p:cNvPr>
@@ -7929,7 +8089,7 @@
           <p:cNvPr id="5" name="">
             <a:extLst xmlns:a="http://schemas.openxmlformats.org/drawingml/2006/main">
               <a:ext uri="{FF2B5EF4-FFF2-40B4-BE49-F238E27FC236}">
-                <a16:creationId xmlns:a16="http://schemas.microsoft.com/office/drawing/2014/main" id="{1DDFF5FE-731F-4C07-8A42-94FFC68E6135}"/>
+                <a16:creationId xmlns:a16="http://schemas.microsoft.com/office/drawing/2014/main" id="{BF63997E-AE58-462C-A5FE-EEDB04A46672}"/>
               </a:ext>
             </a:extLst>
           </p:cNvPr>
@@ -7986,7 +8146,7 @@
           <p:cNvPr id="6" name="">
             <a:extLst xmlns:a="http://schemas.openxmlformats.org/drawingml/2006/main">
               <a:ext uri="{FF2B5EF4-FFF2-40B4-BE49-F238E27FC236}">
-                <a16:creationId xmlns:a16="http://schemas.microsoft.com/office/drawing/2014/main" id="{DEE0D3EA-BA5D-4BB3-AFF1-B2C8661FACE5}"/>
+                <a16:creationId xmlns:a16="http://schemas.microsoft.com/office/drawing/2014/main" id="{10DBFBC0-72DB-4D5B-A2CE-E8F6BFE01E3D}"/>
               </a:ext>
             </a:extLst>
           </p:cNvPr>
@@ -8112,7 +8272,7 @@
           <p:cNvPr id="7" name="">
             <a:extLst xmlns:a="http://schemas.openxmlformats.org/drawingml/2006/main">
               <a:ext uri="{FF2B5EF4-FFF2-40B4-BE49-F238E27FC236}">
-                <a16:creationId xmlns:a16="http://schemas.microsoft.com/office/drawing/2014/main" id="{E52AC77C-EA8E-45C6-A536-6007F5114226}"/>
+                <a16:creationId xmlns:a16="http://schemas.microsoft.com/office/drawing/2014/main" id="{0D1B8CD1-7FDA-494B-9E78-052A994BD93A}"/>
               </a:ext>
             </a:extLst>
           </p:cNvPr>
@@ -8169,7 +8329,7 @@
           <p:cNvPr id="8" name="">
             <a:extLst xmlns:a="http://schemas.openxmlformats.org/drawingml/2006/main">
               <a:ext uri="{FF2B5EF4-FFF2-40B4-BE49-F238E27FC236}">
-                <a16:creationId xmlns:a16="http://schemas.microsoft.com/office/drawing/2014/main" id="{5E9425ED-3B98-46D3-9734-9AEB7C8AF6FB}"/>
+                <a16:creationId xmlns:a16="http://schemas.microsoft.com/office/drawing/2014/main" id="{E9BE8755-A1B9-4FF2-A214-B75332DACAC4}"/>
               </a:ext>
             </a:extLst>
           </p:cNvPr>
@@ -8249,7 +8409,7 @@
           <p:cNvPr id="9" name="">
             <a:extLst xmlns:a="http://schemas.openxmlformats.org/drawingml/2006/main">
               <a:ext uri="{FF2B5EF4-FFF2-40B4-BE49-F238E27FC236}">
-                <a16:creationId xmlns:a16="http://schemas.microsoft.com/office/drawing/2014/main" id="{94C65538-69F5-405A-B735-6D592F134235}"/>
+                <a16:creationId xmlns:a16="http://schemas.microsoft.com/office/drawing/2014/main" id="{EF4C0651-4C3B-42E8-A376-8F00314AEA35}"/>
               </a:ext>
             </a:extLst>
           </p:cNvPr>
@@ -8304,7 +8464,7 @@
     </p:spTree>
     <p:extLst>
       <p:ext uri="{BB962C8B-B14F-4D97-AF65-F5344CB8AC3E}">
-        <p14:creationId xmlns:p14="http://schemas.microsoft.com/office/powerpoint/2010/main" val="595169527"/>
+        <p14:creationId xmlns:p14="http://schemas.microsoft.com/office/powerpoint/2010/main" val="2009532175"/>
       </p:ext>
     </p:extLst>
   </p:cSld>

</xml_diff>

<commit_message>
Atualiza painel CP2 e prepara pacote reproduzivel
</commit_message>
<xml_diff>
--- a/docs/apresentacao_pagamentos_es_2024.pptx
+++ b/docs/apresentacao_pagamentos_es_2024.pptx
@@ -2,20 +2,20 @@
 <file path=ppt/presentation.xml><?xml version="1.0" encoding="utf-8"?>
 <p:presentation xmlns:p="http://schemas.openxmlformats.org/presentationml/2006/main">
   <p:sldMasterIdLst>
-    <p:sldMasterId xmlns:r="http://schemas.openxmlformats.org/officeDocument/2006/relationships" id="2147483648" r:id="R4499eac4403a481a"/>
+    <p:sldMasterId xmlns:r="http://schemas.openxmlformats.org/officeDocument/2006/relationships" id="2147483648" r:id="Rb6105f82dcdd45d1"/>
   </p:sldMasterIdLst>
   <p:notesMasterIdLst>
-    <p:notesMasterId xmlns:r="http://schemas.openxmlformats.org/officeDocument/2006/relationships" r:id="R5bc16523e76e424c"/>
+    <p:notesMasterId xmlns:r="http://schemas.openxmlformats.org/officeDocument/2006/relationships" r:id="R9301843e761549fe"/>
   </p:notesMasterIdLst>
   <p:sldIdLst>
-    <p:sldId xmlns:r="http://schemas.openxmlformats.org/officeDocument/2006/relationships" id="256" r:id="R4a37392359c641b0"/>
-    <p:sldId xmlns:r="http://schemas.openxmlformats.org/officeDocument/2006/relationships" id="257" r:id="R2001d54df6a8473c"/>
-    <p:sldId xmlns:r="http://schemas.openxmlformats.org/officeDocument/2006/relationships" id="258" r:id="Raad499b81dc64e4e"/>
-    <p:sldId xmlns:r="http://schemas.openxmlformats.org/officeDocument/2006/relationships" id="259" r:id="R78205205b20b4bf7"/>
-    <p:sldId xmlns:r="http://schemas.openxmlformats.org/officeDocument/2006/relationships" id="260" r:id="R09b46c775bf84340"/>
-    <p:sldId xmlns:r="http://schemas.openxmlformats.org/officeDocument/2006/relationships" id="261" r:id="R77f2b41c95cd4b60"/>
-    <p:sldId xmlns:r="http://schemas.openxmlformats.org/officeDocument/2006/relationships" id="262" r:id="R2933130e33854a43"/>
-    <p:sldId xmlns:r="http://schemas.openxmlformats.org/officeDocument/2006/relationships" id="263" r:id="Rc1aa9caa8cdf466f"/>
+    <p:sldId xmlns:r="http://schemas.openxmlformats.org/officeDocument/2006/relationships" id="256" r:id="R34d88100bdff40f0"/>
+    <p:sldId xmlns:r="http://schemas.openxmlformats.org/officeDocument/2006/relationships" id="257" r:id="R163e0965cb2f43ef"/>
+    <p:sldId xmlns:r="http://schemas.openxmlformats.org/officeDocument/2006/relationships" id="258" r:id="R501378dd5acc48b7"/>
+    <p:sldId xmlns:r="http://schemas.openxmlformats.org/officeDocument/2006/relationships" id="259" r:id="R11a6f9d298594b7d"/>
+    <p:sldId xmlns:r="http://schemas.openxmlformats.org/officeDocument/2006/relationships" id="260" r:id="Rad013af52b844e09"/>
+    <p:sldId xmlns:r="http://schemas.openxmlformats.org/officeDocument/2006/relationships" id="261" r:id="R611583e8bc154c9e"/>
+    <p:sldId xmlns:r="http://schemas.openxmlformats.org/officeDocument/2006/relationships" id="262" r:id="R7ee81e8ca97d4390"/>
+    <p:sldId xmlns:r="http://schemas.openxmlformats.org/officeDocument/2006/relationships" id="263" r:id="Rc3c364fb23b0400e"/>
   </p:sldIdLst>
   <p:sldSz cx="12192000" cy="6858000"/>
   <p:notesSz cx="6858000" cy="9144000"/>
@@ -449,7 +449,7 @@
           <a:lstStyle xmlns:a="http://schemas.openxmlformats.org/drawingml/2006/main"/>
           <a:p xmlns:a="http://schemas.openxmlformats.org/drawingml/2006/main">
             <a:r>
-              <a:t>Roteiro sugerido. Luigi Mendes Cabrini · RM 563552. Tempo 65 segundos.</a:t>
+              <a:t>Roteiro sugerido. Luigi Mendes Cabrini · RM 563552. Tempo 60 segundos.</a:t>
             </a:r>
           </a:p>
           <a:p xmlns:a="http://schemas.openxmlformats.org/drawingml/2006/main">
@@ -494,7 +494,7 @@
           </a:p>
           <a:p xmlns:a="http://schemas.openxmlformats.org/drawingml/2006/main">
             <a:r>
-              <a:t>Roteiro: 11 minutos de conteúdo e 1 minuto de margem para transições e imprevistos.</a:t>
+              <a:t>Proposta de fala sujeita ao ensaio: Luigi 2 minutos, Rogério 3, Bruno 4 e Anthony 2. Margem de 1 minuto. Bruno conduz a demonstração. A distribuição não comprova autoria passada. Todos devem conhecer os requisitos e responder sobre o CP2.</a:t>
             </a:r>
           </a:p>
         </p:txBody>
@@ -564,7 +564,7 @@
           <a:lstStyle xmlns:a="http://schemas.openxmlformats.org/drawingml/2006/main"/>
           <a:p xmlns:a="http://schemas.openxmlformats.org/drawingml/2006/main">
             <a:r>
-              <a:t>Roteiro sugerido. Luigi Mendes Cabrini · RM 563552. Tempo 75 segundos.</a:t>
+              <a:t>Roteiro sugerido. Luigi Mendes Cabrini · RM 563552. Tempo 60 segundos.</a:t>
             </a:r>
           </a:p>
           <a:p xmlns:a="http://schemas.openxmlformats.org/drawingml/2006/main">
@@ -619,7 +619,7 @@
           </a:p>
           <a:p xmlns:a="http://schemas.openxmlformats.org/drawingml/2006/main">
             <a:r>
-              <a:t>Roteiro: 11 minutos de conteúdo e 1 minuto de margem para transições e imprevistos.</a:t>
+              <a:t>Proposta de fala sujeita ao ensaio: Luigi 2 minutos, Rogério 3, Bruno 4 e Anthony 2. Margem de 1 minuto. Bruno conduz a demonstração. A distribuição não comprova autoria passada. Todos devem conhecer os requisitos e responder sobre o CP2.</a:t>
             </a:r>
           </a:p>
         </p:txBody>
@@ -689,7 +689,7 @@
           <a:lstStyle xmlns:a="http://schemas.openxmlformats.org/drawingml/2006/main"/>
           <a:p xmlns:a="http://schemas.openxmlformats.org/drawingml/2006/main">
             <a:r>
-              <a:t>Roteiro sugerido. Bruno Koeke · RM 561309. Tempo 75 segundos.</a:t>
+              <a:t>Roteiro sugerido. Rogério Cruz Arroyo · RM 563517. Tempo 80 segundos.</a:t>
             </a:r>
           </a:p>
           <a:p xmlns:a="http://schemas.openxmlformats.org/drawingml/2006/main">
@@ -744,7 +744,7 @@
           </a:p>
           <a:p xmlns:a="http://schemas.openxmlformats.org/drawingml/2006/main">
             <a:r>
-              <a:t>Roteiro: 11 minutos de conteúdo e 1 minuto de margem para transições e imprevistos.</a:t>
+              <a:t>Proposta de fala sujeita ao ensaio: Luigi 2 minutos, Rogério 3, Bruno 4 e Anthony 2. Margem de 1 minuto. Bruno conduz a demonstração. A distribuição não comprova autoria passada. Todos devem conhecer os requisitos e responder sobre o CP2.</a:t>
             </a:r>
           </a:p>
         </p:txBody>
@@ -814,7 +814,7 @@
           <a:lstStyle xmlns:a="http://schemas.openxmlformats.org/drawingml/2006/main"/>
           <a:p xmlns:a="http://schemas.openxmlformats.org/drawingml/2006/main">
             <a:r>
-              <a:t>Roteiro sugerido. Bruno Koeke · RM 561309. Tempo 95 segundos.</a:t>
+              <a:t>Roteiro sugerido. Rogério Cruz Arroyo · RM 563517. Tempo 100 segundos.</a:t>
             </a:r>
           </a:p>
           <a:p xmlns:a="http://schemas.openxmlformats.org/drawingml/2006/main">
@@ -874,7 +874,7 @@
           </a:p>
           <a:p xmlns:a="http://schemas.openxmlformats.org/drawingml/2006/main">
             <a:r>
-              <a:t>Roteiro: 11 minutos de conteúdo e 1 minuto de margem para transições e imprevistos.</a:t>
+              <a:t>Proposta de fala sujeita ao ensaio: Luigi 2 minutos, Rogério 3, Bruno 4 e Anthony 2. Margem de 1 minuto. Bruno conduz a demonstração. A distribuição não comprova autoria passada. Todos devem conhecer os requisitos e responder sobre o CP2.</a:t>
             </a:r>
           </a:p>
         </p:txBody>
@@ -944,12 +944,12 @@
           <a:lstStyle xmlns:a="http://schemas.openxmlformats.org/drawingml/2006/main"/>
           <a:p xmlns:a="http://schemas.openxmlformats.org/drawingml/2006/main">
             <a:r>
-              <a:t>Roteiro sugerido. Rogério Cruz Arroyo · RM 563517. Tempo 190 segundos.</a:t>
-            </a:r>
-          </a:p>
-          <a:p xmlns:a="http://schemas.openxmlformats.org/drawingml/2006/main">
-            <a:r>
-              <a:t>Abrir o painel local. Mostrar a base carregada e selecionar uma unidade no ranking. Filtrar um mês e ler os indicadores. Consultar composição e abrir a rastreabilidade de um resultado. Exibir arquivo e linha, sem dados bancários ou pessoais. Selecionar uma combinação sem dados e observar a resposta. Mostrar o roteiro de execução do README e os testes. A tecnologia web local foi escolhida para reduzir dependências da POC, enquanto o SQLite mantém agregações reproduzíveis. Demonstrar apenas recursos implementados e explicar as limitações. Alternativa de contingência: material capturado, mantendo a demonstração ao vivo como principal.</a:t>
+              <a:t>Roteiro sugerido. Bruno Koeke · RM 561309. Tempo 240 segundos.</a:t>
+            </a:r>
+          </a:p>
+          <a:p xmlns:a="http://schemas.openxmlformats.org/drawingml/2006/main">
+            <a:r>
+              <a:t>Abrir o painel local. Mostrar a base carregada e selecionar uma unidade no ranking. Filtrar um mês e ler os indicadores. Consultar composição e abrir a rastreabilidade de um resultado. Exibir arquivo e linha, sem dados bancários ou pessoais. Selecionar uma combinação sem dados e observar a resposta. Mostrar o roteiro de execução do README e os testes. A tecnologia web local foi escolhida para reduzir dependências da POC, enquanto o SQLite mantém agregações reproduzíveis. Demonstrar apenas recursos implementados e explicar as limitações. Alternativa de contingência: pacote e PDFs de apoio, mantendo a demonstração ao vivo como principal.</a:t>
             </a:r>
           </a:p>
           <a:p xmlns:a="http://schemas.openxmlformats.org/drawingml/2006/main">
@@ -984,7 +984,7 @@
           </a:p>
           <a:p xmlns:a="http://schemas.openxmlformats.org/drawingml/2006/main">
             <a:r>
-              <a:t>Executar Saúde (440901) em dezembro: 7.790 registros e R$ 185.199.026,38. Mostrar arquivo e linha de um registro, exportar o recorte e depois Polícia Penal (460113) em janeiro, sem registros. O importador lê CSVs e grava os registros no SQLite, com auditoria e centavos inteiros. Se um arquivo vier incompleto, a interface mostra avisos de valores ausentes e da diferença entre série mensal e total. Fonte da imagem: captura própria do painel em outputs/painel_apresentacao.jpg.</a:t>
+              <a:t>Bruno conduz a demonstração. Abrir Modo apresentação e confirmar o panorama anual. Em Abrir filtros, escolher Saúde em dezembro: 7.790 registros e R$ 185.199.026,38. Aguardar as etapas reais de carregamento; resultados aparecem juntos. Fechar filtros, avançar para Distribuição e depois Registros. Mostrar arquivo e linha, baixar CSV e abrir Metodologia. Navegar não reconsulta. Voltar aos filtros e demonstrar Polícia Penal em janeiro, sem registros; restaurar Panorama completo. O ranking mostra até dez unidades, ou cinco no Modo apresentação. As animações respeitam movimento reduzido.</a:t>
             </a:r>
           </a:p>
           <a:p xmlns:a="http://schemas.openxmlformats.org/drawingml/2006/main">
@@ -994,7 +994,7 @@
           </a:p>
           <a:p xmlns:a="http://schemas.openxmlformats.org/drawingml/2006/main">
             <a:r>
-              <a:t>Roteiro: 11 minutos de conteúdo e 1 minuto de margem para transições e imprevistos.</a:t>
+              <a:t>Proposta de fala sujeita ao ensaio: Luigi 2 minutos, Rogério 3, Bruno 4 e Anthony 2. Margem de 1 minuto. Bruno conduz a demonstração. A distribuição não comprova autoria passada. Todos devem conhecer os requisitos e responder sobre o CP2.</a:t>
             </a:r>
           </a:p>
         </p:txBody>
@@ -1064,7 +1064,7 @@
           <a:lstStyle xmlns:a="http://schemas.openxmlformats.org/drawingml/2006/main"/>
           <a:p xmlns:a="http://schemas.openxmlformats.org/drawingml/2006/main">
             <a:r>
-              <a:t>Roteiro sugerido. Anthony Sforzin · RM 562096. Tempo 60 segundos.</a:t>
+              <a:t>Roteiro sugerido. Anthony Sforzin · RM 562096. Tempo 40 segundos.</a:t>
             </a:r>
           </a:p>
           <a:p xmlns:a="http://schemas.openxmlformats.org/drawingml/2006/main">
@@ -1109,7 +1109,7 @@
           </a:p>
           <a:p xmlns:a="http://schemas.openxmlformats.org/drawingml/2006/main">
             <a:r>
-              <a:t>Roteiro: 11 minutos de conteúdo e 1 minuto de margem para transições e imprevistos.</a:t>
+              <a:t>Proposta de fala sujeita ao ensaio: Luigi 2 minutos, Rogério 3, Bruno 4 e Anthony 2. Margem de 1 minuto. Bruno conduz a demonstração. A distribuição não comprova autoria passada. Todos devem conhecer os requisitos e responder sobre o CP2.</a:t>
             </a:r>
           </a:p>
         </p:txBody>
@@ -1179,7 +1179,7 @@
           <a:lstStyle xmlns:a="http://schemas.openxmlformats.org/drawingml/2006/main"/>
           <a:p xmlns:a="http://schemas.openxmlformats.org/drawingml/2006/main">
             <a:r>
-              <a:t>Roteiro sugerido. Anthony Sforzin · RM 562096. Tempo 60 segundos.</a:t>
+              <a:t>Roteiro sugerido. Anthony Sforzin · RM 562096. Tempo 50 segundos.</a:t>
             </a:r>
           </a:p>
           <a:p xmlns:a="http://schemas.openxmlformats.org/drawingml/2006/main">
@@ -1214,7 +1214,7 @@
           </a:p>
           <a:p xmlns:a="http://schemas.openxmlformats.org/drawingml/2006/main">
             <a:r>
-              <a:t>Os impactos são comparação enviesada, total incorreto e atraso da comparação de 2025. Responsáveis: Bruno, Anthony e Luigi, respectivamente. Rogério responde pela contingência de falha técnica, testando outro computador e levando pacote/captura. O relatório contém o plano completo.</a:t>
+              <a:t>Os impactos são comparação enviesada, total incorreto e atraso da comparação de 2025. Responsáveis: Bruno, Anthony e Luigi, respectivamente. Rogério responde pela contingência de falha técnica, testando outro computador e levando pacote e PDFs. O relatório contém o plano completo.</a:t>
             </a:r>
           </a:p>
           <a:p xmlns:a="http://schemas.openxmlformats.org/drawingml/2006/main">
@@ -1224,7 +1224,7 @@
           </a:p>
           <a:p xmlns:a="http://schemas.openxmlformats.org/drawingml/2006/main">
             <a:r>
-              <a:t>Roteiro: 11 minutos de conteúdo e 1 minuto de margem para transições e imprevistos.</a:t>
+              <a:t>Proposta de fala sujeita ao ensaio: Luigi 2 minutos, Rogério 3, Bruno 4 e Anthony 2. Margem de 1 minuto. Bruno conduz a demonstração. A distribuição não comprova autoria passada. Todos devem conhecer os requisitos e responder sobre o CP2.</a:t>
             </a:r>
           </a:p>
         </p:txBody>
@@ -1294,7 +1294,7 @@
           <a:lstStyle xmlns:a="http://schemas.openxmlformats.org/drawingml/2006/main"/>
           <a:p xmlns:a="http://schemas.openxmlformats.org/drawingml/2006/main">
             <a:r>
-              <a:t>Roteiro sugerido. Anthony Sforzin · RM 562096. Tempo 40 segundos.</a:t>
+              <a:t>Roteiro sugerido. Anthony Sforzin · RM 562096. Tempo 30 segundos.</a:t>
             </a:r>
           </a:p>
           <a:p xmlns:a="http://schemas.openxmlformats.org/drawingml/2006/main">
@@ -1349,7 +1349,7 @@
           </a:p>
           <a:p xmlns:a="http://schemas.openxmlformats.org/drawingml/2006/main">
             <a:r>
-              <a:t>Roteiro: 11 minutos de conteúdo e 1 minuto de margem para transições e imprevistos.</a:t>
+              <a:t>Proposta de fala sujeita ao ensaio: Luigi 2 minutos, Rogério 3, Bruno 4 e Anthony 2. Margem de 1 minuto. Bruno conduz a demonstração. A distribuição não comprova autoria passada. Todos devem conhecer os requisitos e responder sobre o CP2.</a:t>
             </a:r>
           </a:p>
         </p:txBody>
@@ -1417,7 +1417,7 @@
   </p:cSld>
   <p:clrMap bg1="lt1" tx1="dk1" bg2="lt2" tx2="dk2" accent1="accent1" accent2="accent2" accent3="accent3" accent4="accent4" accent5="accent5" accent6="accent6" hlink="hlink" folHlink="folHlink"/>
   <p:sldLayoutIdLst>
-    <p:sldLayoutId xmlns:r="http://schemas.openxmlformats.org/officeDocument/2006/relationships" id="2147483649" r:id="R347da088d7be4dab"/>
+    <p:sldLayoutId xmlns:r="http://schemas.openxmlformats.org/officeDocument/2006/relationships" id="2147483649" r:id="R5460c501046d45cb"/>
   </p:sldLayoutIdLst>
   <p:txStyles>
     <p:titleStyle>
@@ -2657,7 +2657,7 @@
           <p:cNvPr id="20" name="">
             <a:extLst xmlns:a="http://schemas.openxmlformats.org/drawingml/2006/main">
               <a:ext uri="{FF2B5EF4-FFF2-40B4-BE49-F238E27FC236}">
-                <a16:creationId xmlns:a16="http://schemas.microsoft.com/office/drawing/2014/main" id="{34FA401F-2B9E-403B-9616-8946F2470945}"/>
+                <a16:creationId xmlns:a16="http://schemas.microsoft.com/office/drawing/2014/main" id="{361D82DE-3D9A-4F8D-B6F1-780E21F27023}"/>
               </a:ext>
             </a:extLst>
           </p:cNvPr>
@@ -2714,7 +2714,7 @@
           <p:cNvPr id="2" name="">
             <a:extLst xmlns:a="http://schemas.openxmlformats.org/drawingml/2006/main">
               <a:ext uri="{FF2B5EF4-FFF2-40B4-BE49-F238E27FC236}">
-                <a16:creationId xmlns:a16="http://schemas.microsoft.com/office/drawing/2014/main" id="{F7339694-9562-4B36-AAAB-4CE9ADF7D0CB}"/>
+                <a16:creationId xmlns:a16="http://schemas.microsoft.com/office/drawing/2014/main" id="{371CB452-14ED-4E47-8E7A-9A465116E79E}"/>
               </a:ext>
             </a:extLst>
           </p:cNvPr>
@@ -2771,7 +2771,7 @@
           <p:cNvPr id="3" name="">
             <a:extLst xmlns:a="http://schemas.openxmlformats.org/drawingml/2006/main">
               <a:ext uri="{FF2B5EF4-FFF2-40B4-BE49-F238E27FC236}">
-                <a16:creationId xmlns:a16="http://schemas.microsoft.com/office/drawing/2014/main" id="{28F9BCCC-80AC-4E23-AE08-E6332C432D25}"/>
+                <a16:creationId xmlns:a16="http://schemas.microsoft.com/office/drawing/2014/main" id="{ADDCBF7C-057A-464E-8657-4CC2D855AB47}"/>
               </a:ext>
             </a:extLst>
           </p:cNvPr>
@@ -2801,7 +2801,7 @@
           <p:cNvPr id="4" name="">
             <a:extLst xmlns:a="http://schemas.openxmlformats.org/drawingml/2006/main">
               <a:ext uri="{FF2B5EF4-FFF2-40B4-BE49-F238E27FC236}">
-                <a16:creationId xmlns:a16="http://schemas.microsoft.com/office/drawing/2014/main" id="{F905B2A0-1D74-464C-BDFB-B3744D747AA5}"/>
+                <a16:creationId xmlns:a16="http://schemas.microsoft.com/office/drawing/2014/main" id="{456EAFB0-8206-49BE-A822-0A513EA4194F}"/>
               </a:ext>
             </a:extLst>
           </p:cNvPr>
@@ -2858,7 +2858,7 @@
           <p:cNvPr id="5" name="">
             <a:extLst xmlns:a="http://schemas.openxmlformats.org/drawingml/2006/main">
               <a:ext uri="{FF2B5EF4-FFF2-40B4-BE49-F238E27FC236}">
-                <a16:creationId xmlns:a16="http://schemas.microsoft.com/office/drawing/2014/main" id="{A898E0A0-A13E-4750-8ABB-C0483AD9D3AA}"/>
+                <a16:creationId xmlns:a16="http://schemas.microsoft.com/office/drawing/2014/main" id="{D19D42F2-51E1-4E8F-96E6-41C02DC419B9}"/>
               </a:ext>
             </a:extLst>
           </p:cNvPr>
@@ -2915,7 +2915,7 @@
           <p:cNvPr id="6" name="">
             <a:extLst xmlns:a="http://schemas.openxmlformats.org/drawingml/2006/main">
               <a:ext uri="{FF2B5EF4-FFF2-40B4-BE49-F238E27FC236}">
-                <a16:creationId xmlns:a16="http://schemas.microsoft.com/office/drawing/2014/main" id="{0868D845-344E-4244-9D45-2D05D4A2D96E}"/>
+                <a16:creationId xmlns:a16="http://schemas.microsoft.com/office/drawing/2014/main" id="{5506DD68-D98E-4DC3-A66B-2A01A2BA7085}"/>
               </a:ext>
             </a:extLst>
           </p:cNvPr>
@@ -2972,7 +2972,7 @@
           <p:cNvPr id="7" name="">
             <a:extLst xmlns:a="http://schemas.openxmlformats.org/drawingml/2006/main">
               <a:ext uri="{FF2B5EF4-FFF2-40B4-BE49-F238E27FC236}">
-                <a16:creationId xmlns:a16="http://schemas.microsoft.com/office/drawing/2014/main" id="{E2829133-68FB-499A-AD5B-8460046B260D}"/>
+                <a16:creationId xmlns:a16="http://schemas.microsoft.com/office/drawing/2014/main" id="{D80A03D7-FB8E-4BA3-89CE-27F59CFA9D0D}"/>
               </a:ext>
             </a:extLst>
           </p:cNvPr>
@@ -3029,7 +3029,7 @@
           <p:cNvPr id="8" name="">
             <a:extLst xmlns:a="http://schemas.openxmlformats.org/drawingml/2006/main">
               <a:ext uri="{FF2B5EF4-FFF2-40B4-BE49-F238E27FC236}">
-                <a16:creationId xmlns:a16="http://schemas.microsoft.com/office/drawing/2014/main" id="{97BD422D-E707-4624-B5D3-3DD56A614C52}"/>
+                <a16:creationId xmlns:a16="http://schemas.microsoft.com/office/drawing/2014/main" id="{C69A8F00-DE87-44A2-AF94-DEB0170BE9B3}"/>
               </a:ext>
             </a:extLst>
           </p:cNvPr>
@@ -3086,7 +3086,7 @@
           <p:cNvPr id="9" name="">
             <a:extLst xmlns:a="http://schemas.openxmlformats.org/drawingml/2006/main">
               <a:ext uri="{FF2B5EF4-FFF2-40B4-BE49-F238E27FC236}">
-                <a16:creationId xmlns:a16="http://schemas.microsoft.com/office/drawing/2014/main" id="{8758A78E-DAEA-4CA5-91FF-5FF789EB2AEB}"/>
+                <a16:creationId xmlns:a16="http://schemas.microsoft.com/office/drawing/2014/main" id="{812A5179-B842-4AD4-919F-E1F27234CD42}"/>
               </a:ext>
             </a:extLst>
           </p:cNvPr>
@@ -3143,7 +3143,7 @@
           <p:cNvPr id="10" name="">
             <a:extLst xmlns:a="http://schemas.openxmlformats.org/drawingml/2006/main">
               <a:ext uri="{FF2B5EF4-FFF2-40B4-BE49-F238E27FC236}">
-                <a16:creationId xmlns:a16="http://schemas.microsoft.com/office/drawing/2014/main" id="{0BA1E094-6524-4D50-BB8C-5C8BEEB75F79}"/>
+                <a16:creationId xmlns:a16="http://schemas.microsoft.com/office/drawing/2014/main" id="{8041AE54-D89E-4E69-91C9-7028CD07472C}"/>
               </a:ext>
             </a:extLst>
           </p:cNvPr>
@@ -3173,7 +3173,7 @@
           <p:cNvPr id="11" name="">
             <a:extLst xmlns:a="http://schemas.openxmlformats.org/drawingml/2006/main">
               <a:ext uri="{FF2B5EF4-FFF2-40B4-BE49-F238E27FC236}">
-                <a16:creationId xmlns:a16="http://schemas.microsoft.com/office/drawing/2014/main" id="{7FF86471-FE94-4A0E-B000-49739BE75FF3}"/>
+                <a16:creationId xmlns:a16="http://schemas.microsoft.com/office/drawing/2014/main" id="{BA8D2F8B-308F-42F9-A4A6-25B29DC21CEB}"/>
               </a:ext>
             </a:extLst>
           </p:cNvPr>
@@ -3230,7 +3230,7 @@
           <p:cNvPr id="12" name="">
             <a:extLst xmlns:a="http://schemas.openxmlformats.org/drawingml/2006/main">
               <a:ext uri="{FF2B5EF4-FFF2-40B4-BE49-F238E27FC236}">
-                <a16:creationId xmlns:a16="http://schemas.microsoft.com/office/drawing/2014/main" id="{DA3ABAA4-4850-417D-BF55-B2CBC8CA44C7}"/>
+                <a16:creationId xmlns:a16="http://schemas.microsoft.com/office/drawing/2014/main" id="{22622954-2D50-4D25-BF01-2C4AA542010A}"/>
               </a:ext>
             </a:extLst>
           </p:cNvPr>
@@ -3287,7 +3287,7 @@
           <p:cNvPr id="13" name="">
             <a:extLst xmlns:a="http://schemas.openxmlformats.org/drawingml/2006/main">
               <a:ext uri="{FF2B5EF4-FFF2-40B4-BE49-F238E27FC236}">
-                <a16:creationId xmlns:a16="http://schemas.microsoft.com/office/drawing/2014/main" id="{0DC32F46-4555-47E6-B47D-47D5CEE287A3}"/>
+                <a16:creationId xmlns:a16="http://schemas.microsoft.com/office/drawing/2014/main" id="{3B4C2C8E-38B0-40F9-B5CC-EC72D96761ED}"/>
               </a:ext>
             </a:extLst>
           </p:cNvPr>
@@ -3344,7 +3344,7 @@
           <p:cNvPr id="14" name="">
             <a:extLst xmlns:a="http://schemas.openxmlformats.org/drawingml/2006/main">
               <a:ext uri="{FF2B5EF4-FFF2-40B4-BE49-F238E27FC236}">
-                <a16:creationId xmlns:a16="http://schemas.microsoft.com/office/drawing/2014/main" id="{41CAF2C7-CBDA-496A-9503-18A545C8C33E}"/>
+                <a16:creationId xmlns:a16="http://schemas.microsoft.com/office/drawing/2014/main" id="{B958F434-F00C-4F5A-A332-66EFCF32240D}"/>
               </a:ext>
             </a:extLst>
           </p:cNvPr>
@@ -3401,7 +3401,7 @@
           <p:cNvPr id="15" name="">
             <a:extLst xmlns:a="http://schemas.openxmlformats.org/drawingml/2006/main">
               <a:ext uri="{FF2B5EF4-FFF2-40B4-BE49-F238E27FC236}">
-                <a16:creationId xmlns:a16="http://schemas.microsoft.com/office/drawing/2014/main" id="{E0F9B48B-8BB9-4687-93A3-94BB5C80CCB7}"/>
+                <a16:creationId xmlns:a16="http://schemas.microsoft.com/office/drawing/2014/main" id="{811EF5E9-85E3-4957-BCB0-3176BF5AE7E1}"/>
               </a:ext>
             </a:extLst>
           </p:cNvPr>
@@ -3458,7 +3458,7 @@
           <p:cNvPr id="16" name="">
             <a:extLst xmlns:a="http://schemas.openxmlformats.org/drawingml/2006/main">
               <a:ext uri="{FF2B5EF4-FFF2-40B4-BE49-F238E27FC236}">
-                <a16:creationId xmlns:a16="http://schemas.microsoft.com/office/drawing/2014/main" id="{4D0E41A8-151E-487D-871E-F369CABA8A96}"/>
+                <a16:creationId xmlns:a16="http://schemas.microsoft.com/office/drawing/2014/main" id="{B070192E-BC86-42C3-B77C-4D847D594255}"/>
               </a:ext>
             </a:extLst>
           </p:cNvPr>
@@ -3515,7 +3515,7 @@
           <p:cNvPr id="17" name="">
             <a:extLst xmlns:a="http://schemas.openxmlformats.org/drawingml/2006/main">
               <a:ext uri="{FF2B5EF4-FFF2-40B4-BE49-F238E27FC236}">
-                <a16:creationId xmlns:a16="http://schemas.microsoft.com/office/drawing/2014/main" id="{F0C6B944-43F4-47F1-984A-07F293C4F4B7}"/>
+                <a16:creationId xmlns:a16="http://schemas.microsoft.com/office/drawing/2014/main" id="{E1C7D81E-D07E-4B02-8470-50D7F18E6CBA}"/>
               </a:ext>
             </a:extLst>
           </p:cNvPr>
@@ -3595,7 +3595,7 @@
           <p:cNvPr id="18" name="">
             <a:extLst xmlns:a="http://schemas.openxmlformats.org/drawingml/2006/main">
               <a:ext uri="{FF2B5EF4-FFF2-40B4-BE49-F238E27FC236}">
-                <a16:creationId xmlns:a16="http://schemas.microsoft.com/office/drawing/2014/main" id="{A8D38A4A-72CA-4580-9E44-868137CCE4D1}"/>
+                <a16:creationId xmlns:a16="http://schemas.microsoft.com/office/drawing/2014/main" id="{8A43393D-4F13-4788-B1F1-78D49F40EE02}"/>
               </a:ext>
             </a:extLst>
           </p:cNvPr>
@@ -3675,7 +3675,7 @@
           <p:cNvPr id="19" name="">
             <a:extLst xmlns:a="http://schemas.openxmlformats.org/drawingml/2006/main">
               <a:ext uri="{FF2B5EF4-FFF2-40B4-BE49-F238E27FC236}">
-                <a16:creationId xmlns:a16="http://schemas.microsoft.com/office/drawing/2014/main" id="{06B6D59A-4EEE-40FE-B3D0-8A61361AB261}"/>
+                <a16:creationId xmlns:a16="http://schemas.microsoft.com/office/drawing/2014/main" id="{07C93385-B592-40AE-B57C-3A0862F9EFF3}"/>
               </a:ext>
             </a:extLst>
           </p:cNvPr>
@@ -3730,7 +3730,7 @@
     </p:spTree>
     <p:extLst>
       <p:ext uri="{BB962C8B-B14F-4D97-AF65-F5344CB8AC3E}">
-        <p14:creationId xmlns:p14="http://schemas.microsoft.com/office/powerpoint/2010/main" val="1585824903"/>
+        <p14:creationId xmlns:p14="http://schemas.microsoft.com/office/powerpoint/2010/main" val="1953755326"/>
       </p:ext>
     </p:extLst>
   </p:cSld>
@@ -3761,7 +3761,7 @@
           <p:cNvPr id="22" name="">
             <a:extLst xmlns:a="http://schemas.openxmlformats.org/drawingml/2006/main">
               <a:ext uri="{FF2B5EF4-FFF2-40B4-BE49-F238E27FC236}">
-                <a16:creationId xmlns:a16="http://schemas.microsoft.com/office/drawing/2014/main" id="{934478F1-6867-4B7D-9C9A-9627B4CF092A}"/>
+                <a16:creationId xmlns:a16="http://schemas.microsoft.com/office/drawing/2014/main" id="{56687089-AF0D-44F0-8718-951DBE98486D}"/>
               </a:ext>
             </a:extLst>
           </p:cNvPr>
@@ -3818,7 +3818,7 @@
           <p:cNvPr id="2" name="">
             <a:extLst xmlns:a="http://schemas.openxmlformats.org/drawingml/2006/main">
               <a:ext uri="{FF2B5EF4-FFF2-40B4-BE49-F238E27FC236}">
-                <a16:creationId xmlns:a16="http://schemas.microsoft.com/office/drawing/2014/main" id="{6513C0A7-64E2-4A2E-B43A-1BA806863063}"/>
+                <a16:creationId xmlns:a16="http://schemas.microsoft.com/office/drawing/2014/main" id="{3239B520-6F3A-4449-A3FF-9CA9B81A59C0}"/>
               </a:ext>
             </a:extLst>
           </p:cNvPr>
@@ -3875,7 +3875,7 @@
           <p:cNvPr id="3" name="">
             <a:extLst xmlns:a="http://schemas.openxmlformats.org/drawingml/2006/main">
               <a:ext uri="{FF2B5EF4-FFF2-40B4-BE49-F238E27FC236}">
-                <a16:creationId xmlns:a16="http://schemas.microsoft.com/office/drawing/2014/main" id="{264BCDD1-3DBF-4218-B817-768C7CC74C10}"/>
+                <a16:creationId xmlns:a16="http://schemas.microsoft.com/office/drawing/2014/main" id="{A1F23AA2-BF4E-416C-9F9D-D755A01966A2}"/>
               </a:ext>
             </a:extLst>
           </p:cNvPr>
@@ -3932,7 +3932,7 @@
           <p:cNvPr id="4" name="">
             <a:extLst xmlns:a="http://schemas.openxmlformats.org/drawingml/2006/main">
               <a:ext uri="{FF2B5EF4-FFF2-40B4-BE49-F238E27FC236}">
-                <a16:creationId xmlns:a16="http://schemas.microsoft.com/office/drawing/2014/main" id="{DC39161B-E70E-4571-A286-26672DB86F46}"/>
+                <a16:creationId xmlns:a16="http://schemas.microsoft.com/office/drawing/2014/main" id="{B5931818-24C5-458C-9AD9-E63D1BBE5C01}"/>
               </a:ext>
             </a:extLst>
           </p:cNvPr>
@@ -3962,7 +3962,7 @@
           <p:cNvPr id="5" name="">
             <a:extLst xmlns:a="http://schemas.openxmlformats.org/drawingml/2006/main">
               <a:ext uri="{FF2B5EF4-FFF2-40B4-BE49-F238E27FC236}">
-                <a16:creationId xmlns:a16="http://schemas.microsoft.com/office/drawing/2014/main" id="{3776068B-9762-464B-81EF-478095C34A22}"/>
+                <a16:creationId xmlns:a16="http://schemas.microsoft.com/office/drawing/2014/main" id="{AB3FFB61-22D9-4F90-8E13-940258C38D71}"/>
               </a:ext>
             </a:extLst>
           </p:cNvPr>
@@ -4019,7 +4019,7 @@
           <p:cNvPr id="6" name="">
             <a:extLst xmlns:a="http://schemas.openxmlformats.org/drawingml/2006/main">
               <a:ext uri="{FF2B5EF4-FFF2-40B4-BE49-F238E27FC236}">
-                <a16:creationId xmlns:a16="http://schemas.microsoft.com/office/drawing/2014/main" id="{1E5A20F7-536E-4A39-BACC-D76EF0BF26CB}"/>
+                <a16:creationId xmlns:a16="http://schemas.microsoft.com/office/drawing/2014/main" id="{8956E2D6-33AF-4619-8F06-FF61EC6DD984}"/>
               </a:ext>
             </a:extLst>
           </p:cNvPr>
@@ -4076,7 +4076,7 @@
           <p:cNvPr id="7" name="">
             <a:extLst xmlns:a="http://schemas.openxmlformats.org/drawingml/2006/main">
               <a:ext uri="{FF2B5EF4-FFF2-40B4-BE49-F238E27FC236}">
-                <a16:creationId xmlns:a16="http://schemas.microsoft.com/office/drawing/2014/main" id="{CB08C5AA-37A9-4BE1-BCD8-0217F998C117}"/>
+                <a16:creationId xmlns:a16="http://schemas.microsoft.com/office/drawing/2014/main" id="{66CD3175-9CBE-4124-AFCE-FC6B46A4A942}"/>
               </a:ext>
             </a:extLst>
           </p:cNvPr>
@@ -4179,7 +4179,7 @@
           <p:cNvPr id="8" name="">
             <a:extLst xmlns:a="http://schemas.openxmlformats.org/drawingml/2006/main">
               <a:ext uri="{FF2B5EF4-FFF2-40B4-BE49-F238E27FC236}">
-                <a16:creationId xmlns:a16="http://schemas.microsoft.com/office/drawing/2014/main" id="{02E1A055-27BD-4355-B7F3-E8FA41BB1A7F}"/>
+                <a16:creationId xmlns:a16="http://schemas.microsoft.com/office/drawing/2014/main" id="{FB141FA4-740D-405A-BEAB-CFDC052E7515}"/>
               </a:ext>
             </a:extLst>
           </p:cNvPr>
@@ -4236,7 +4236,7 @@
           <p:cNvPr id="9" name="">
             <a:extLst xmlns:a="http://schemas.openxmlformats.org/drawingml/2006/main">
               <a:ext uri="{FF2B5EF4-FFF2-40B4-BE49-F238E27FC236}">
-                <a16:creationId xmlns:a16="http://schemas.microsoft.com/office/drawing/2014/main" id="{D004C397-7594-4D2A-A7BA-32183FA48826}"/>
+                <a16:creationId xmlns:a16="http://schemas.microsoft.com/office/drawing/2014/main" id="{0D187729-54F5-4F44-A5A0-303B85310D79}"/>
               </a:ext>
             </a:extLst>
           </p:cNvPr>
@@ -4316,7 +4316,7 @@
           <p:cNvPr id="10" name="">
             <a:extLst xmlns:a="http://schemas.openxmlformats.org/drawingml/2006/main">
               <a:ext uri="{FF2B5EF4-FFF2-40B4-BE49-F238E27FC236}">
-                <a16:creationId xmlns:a16="http://schemas.microsoft.com/office/drawing/2014/main" id="{018D71D4-0C9C-47C6-95B4-82CCB2CEB9D5}"/>
+                <a16:creationId xmlns:a16="http://schemas.microsoft.com/office/drawing/2014/main" id="{95E5C9E1-F3B2-4C0D-941F-F000823E4DEF}"/>
               </a:ext>
             </a:extLst>
           </p:cNvPr>
@@ -4373,7 +4373,7 @@
           <p:cNvPr id="11" name="">
             <a:extLst xmlns:a="http://schemas.openxmlformats.org/drawingml/2006/main">
               <a:ext uri="{FF2B5EF4-FFF2-40B4-BE49-F238E27FC236}">
-                <a16:creationId xmlns:a16="http://schemas.microsoft.com/office/drawing/2014/main" id="{A6C65963-C8DC-4583-B5DF-AB3B7C813AE3}"/>
+                <a16:creationId xmlns:a16="http://schemas.microsoft.com/office/drawing/2014/main" id="{8333888C-B754-497A-B5F5-2947D3E7F64B}"/>
               </a:ext>
             </a:extLst>
           </p:cNvPr>
@@ -4430,7 +4430,7 @@
           <p:cNvPr id="12" name="">
             <a:extLst xmlns:a="http://schemas.openxmlformats.org/drawingml/2006/main">
               <a:ext uri="{FF2B5EF4-FFF2-40B4-BE49-F238E27FC236}">
-                <a16:creationId xmlns:a16="http://schemas.microsoft.com/office/drawing/2014/main" id="{FB00AC4B-E097-45AF-997E-F9B01A673467}"/>
+                <a16:creationId xmlns:a16="http://schemas.microsoft.com/office/drawing/2014/main" id="{35DBF2C7-CB85-44B8-902D-D936A8D29608}"/>
               </a:ext>
             </a:extLst>
           </p:cNvPr>
@@ -4460,7 +4460,7 @@
           <p:cNvPr id="13" name="">
             <a:extLst xmlns:a="http://schemas.openxmlformats.org/drawingml/2006/main">
               <a:ext uri="{FF2B5EF4-FFF2-40B4-BE49-F238E27FC236}">
-                <a16:creationId xmlns:a16="http://schemas.microsoft.com/office/drawing/2014/main" id="{4EB2657B-3DB8-4362-AFF9-D1FFB3345D03}"/>
+                <a16:creationId xmlns:a16="http://schemas.microsoft.com/office/drawing/2014/main" id="{915FAFA9-CE74-4D4E-932A-5F579402B1C3}"/>
               </a:ext>
             </a:extLst>
           </p:cNvPr>
@@ -4517,7 +4517,7 @@
           <p:cNvPr id="14" name="">
             <a:extLst xmlns:a="http://schemas.openxmlformats.org/drawingml/2006/main">
               <a:ext uri="{FF2B5EF4-FFF2-40B4-BE49-F238E27FC236}">
-                <a16:creationId xmlns:a16="http://schemas.microsoft.com/office/drawing/2014/main" id="{BE08FC1F-C7E9-4598-A846-268A7B2335D0}"/>
+                <a16:creationId xmlns:a16="http://schemas.microsoft.com/office/drawing/2014/main" id="{5A4B0D4C-1013-4E92-BD1A-181AD8E08935}"/>
               </a:ext>
             </a:extLst>
           </p:cNvPr>
@@ -4574,7 +4574,7 @@
           <p:cNvPr id="15" name="">
             <a:extLst xmlns:a="http://schemas.openxmlformats.org/drawingml/2006/main">
               <a:ext uri="{FF2B5EF4-FFF2-40B4-BE49-F238E27FC236}">
-                <a16:creationId xmlns:a16="http://schemas.microsoft.com/office/drawing/2014/main" id="{1436CA04-6133-4B35-9BB3-0192E311260C}"/>
+                <a16:creationId xmlns:a16="http://schemas.microsoft.com/office/drawing/2014/main" id="{E4D55EB8-3124-44F8-95A8-E30FF13DD755}"/>
               </a:ext>
             </a:extLst>
           </p:cNvPr>
@@ -4604,7 +4604,7 @@
           <p:cNvPr id="16" name="">
             <a:extLst xmlns:a="http://schemas.openxmlformats.org/drawingml/2006/main">
               <a:ext uri="{FF2B5EF4-FFF2-40B4-BE49-F238E27FC236}">
-                <a16:creationId xmlns:a16="http://schemas.microsoft.com/office/drawing/2014/main" id="{C4AFF4FD-C59C-4075-B8C3-8830C943F8C9}"/>
+                <a16:creationId xmlns:a16="http://schemas.microsoft.com/office/drawing/2014/main" id="{80E23D7A-6905-4E7F-9B0F-B88C754732C7}"/>
               </a:ext>
             </a:extLst>
           </p:cNvPr>
@@ -4661,7 +4661,7 @@
           <p:cNvPr id="17" name="">
             <a:extLst xmlns:a="http://schemas.openxmlformats.org/drawingml/2006/main">
               <a:ext uri="{FF2B5EF4-FFF2-40B4-BE49-F238E27FC236}">
-                <a16:creationId xmlns:a16="http://schemas.microsoft.com/office/drawing/2014/main" id="{91EDD5DE-B392-45DA-88DE-6A53C0AEB2F0}"/>
+                <a16:creationId xmlns:a16="http://schemas.microsoft.com/office/drawing/2014/main" id="{AA12B2D5-896C-49FF-B339-B0101EDF6267}"/>
               </a:ext>
             </a:extLst>
           </p:cNvPr>
@@ -4718,7 +4718,7 @@
           <p:cNvPr id="18" name="">
             <a:extLst xmlns:a="http://schemas.openxmlformats.org/drawingml/2006/main">
               <a:ext uri="{FF2B5EF4-FFF2-40B4-BE49-F238E27FC236}">
-                <a16:creationId xmlns:a16="http://schemas.microsoft.com/office/drawing/2014/main" id="{22B75A1B-713F-4282-820B-D971229726F2}"/>
+                <a16:creationId xmlns:a16="http://schemas.microsoft.com/office/drawing/2014/main" id="{4F3781C6-7ABC-45EE-8DE4-614148578549}"/>
               </a:ext>
             </a:extLst>
           </p:cNvPr>
@@ -4748,7 +4748,7 @@
           <p:cNvPr id="19" name="">
             <a:extLst xmlns:a="http://schemas.openxmlformats.org/drawingml/2006/main">
               <a:ext uri="{FF2B5EF4-FFF2-40B4-BE49-F238E27FC236}">
-                <a16:creationId xmlns:a16="http://schemas.microsoft.com/office/drawing/2014/main" id="{44F8B7CF-D0A3-4FB8-A901-C616B797D69A}"/>
+                <a16:creationId xmlns:a16="http://schemas.microsoft.com/office/drawing/2014/main" id="{46672A2C-BECC-4F0F-B211-7A50AE6808BE}"/>
               </a:ext>
             </a:extLst>
           </p:cNvPr>
@@ -4805,7 +4805,7 @@
           <p:cNvPr id="20" name="">
             <a:extLst xmlns:a="http://schemas.openxmlformats.org/drawingml/2006/main">
               <a:ext uri="{FF2B5EF4-FFF2-40B4-BE49-F238E27FC236}">
-                <a16:creationId xmlns:a16="http://schemas.microsoft.com/office/drawing/2014/main" id="{B74F643E-3617-4B38-8516-1A4EA3650870}"/>
+                <a16:creationId xmlns:a16="http://schemas.microsoft.com/office/drawing/2014/main" id="{887EC5C4-0F9C-4AB0-9018-F3B0E2D90203}"/>
               </a:ext>
             </a:extLst>
           </p:cNvPr>
@@ -4862,7 +4862,7 @@
           <p:cNvPr id="21" name="">
             <a:extLst xmlns:a="http://schemas.openxmlformats.org/drawingml/2006/main">
               <a:ext uri="{FF2B5EF4-FFF2-40B4-BE49-F238E27FC236}">
-                <a16:creationId xmlns:a16="http://schemas.microsoft.com/office/drawing/2014/main" id="{1C59FAB2-2670-416B-90A5-ABE91EC2A77E}"/>
+                <a16:creationId xmlns:a16="http://schemas.microsoft.com/office/drawing/2014/main" id="{4D15C2D2-4BC5-4011-9B71-E308174DAF9B}"/>
               </a:ext>
             </a:extLst>
           </p:cNvPr>
@@ -4917,7 +4917,7 @@
     </p:spTree>
     <p:extLst>
       <p:ext uri="{BB962C8B-B14F-4D97-AF65-F5344CB8AC3E}">
-        <p14:creationId xmlns:p14="http://schemas.microsoft.com/office/powerpoint/2010/main" val="1910021713"/>
+        <p14:creationId xmlns:p14="http://schemas.microsoft.com/office/powerpoint/2010/main" val="150459884"/>
       </p:ext>
     </p:extLst>
   </p:cSld>
@@ -4948,7 +4948,7 @@
           <p:cNvPr id="15" name="">
             <a:extLst xmlns:a="http://schemas.openxmlformats.org/drawingml/2006/main">
               <a:ext uri="{FF2B5EF4-FFF2-40B4-BE49-F238E27FC236}">
-                <a16:creationId xmlns:a16="http://schemas.microsoft.com/office/drawing/2014/main" id="{5D895E48-AFFC-4E67-84B4-54D8A1AD92E1}"/>
+                <a16:creationId xmlns:a16="http://schemas.microsoft.com/office/drawing/2014/main" id="{09AC591C-7D50-4681-A7C3-19A57F389766}"/>
               </a:ext>
             </a:extLst>
           </p:cNvPr>
@@ -5005,7 +5005,7 @@
           <p:cNvPr id="2" name="">
             <a:extLst xmlns:a="http://schemas.openxmlformats.org/drawingml/2006/main">
               <a:ext uri="{FF2B5EF4-FFF2-40B4-BE49-F238E27FC236}">
-                <a16:creationId xmlns:a16="http://schemas.microsoft.com/office/drawing/2014/main" id="{C39F9978-2366-4D80-9D27-BCC5D700BBE0}"/>
+                <a16:creationId xmlns:a16="http://schemas.microsoft.com/office/drawing/2014/main" id="{09BF641F-8CB4-4AD2-BDAE-073842358756}"/>
               </a:ext>
             </a:extLst>
           </p:cNvPr>
@@ -5062,7 +5062,7 @@
           <p:cNvPr id="3" name="">
             <a:extLst xmlns:a="http://schemas.openxmlformats.org/drawingml/2006/main">
               <a:ext uri="{FF2B5EF4-FFF2-40B4-BE49-F238E27FC236}">
-                <a16:creationId xmlns:a16="http://schemas.microsoft.com/office/drawing/2014/main" id="{087FE349-3BA4-4A50-BE14-B5F4637904AB}"/>
+                <a16:creationId xmlns:a16="http://schemas.microsoft.com/office/drawing/2014/main" id="{D5EDD4D9-D058-45FB-B913-A66BC7B811C5}"/>
               </a:ext>
             </a:extLst>
           </p:cNvPr>
@@ -5119,7 +5119,7 @@
           <p:cNvPr id="4" name="">
             <a:extLst xmlns:a="http://schemas.openxmlformats.org/drawingml/2006/main">
               <a:ext uri="{FF2B5EF4-FFF2-40B4-BE49-F238E27FC236}">
-                <a16:creationId xmlns:a16="http://schemas.microsoft.com/office/drawing/2014/main" id="{0115274C-ABE3-4B95-844F-D8D2448F6D45}"/>
+                <a16:creationId xmlns:a16="http://schemas.microsoft.com/office/drawing/2014/main" id="{A7C2D3D5-DA2D-4405-8464-99F9D8DA9B7F}"/>
               </a:ext>
             </a:extLst>
           </p:cNvPr>
@@ -5149,7 +5149,7 @@
           <p:cNvPr id="5" name="">
             <a:extLst xmlns:a="http://schemas.openxmlformats.org/drawingml/2006/main">
               <a:ext uri="{FF2B5EF4-FFF2-40B4-BE49-F238E27FC236}">
-                <a16:creationId xmlns:a16="http://schemas.microsoft.com/office/drawing/2014/main" id="{1ADB5F6F-C731-4193-B77F-FD969E1065DE}"/>
+                <a16:creationId xmlns:a16="http://schemas.microsoft.com/office/drawing/2014/main" id="{5F745176-DB7E-42C3-99B6-C83B003D3156}"/>
               </a:ext>
             </a:extLst>
           </p:cNvPr>
@@ -5206,7 +5206,7 @@
           <p:cNvPr id="6" name="">
             <a:extLst xmlns:a="http://schemas.openxmlformats.org/drawingml/2006/main">
               <a:ext uri="{FF2B5EF4-FFF2-40B4-BE49-F238E27FC236}">
-                <a16:creationId xmlns:a16="http://schemas.microsoft.com/office/drawing/2014/main" id="{CE1FBE0B-2B38-4C03-8B64-5D32491763D5}"/>
+                <a16:creationId xmlns:a16="http://schemas.microsoft.com/office/drawing/2014/main" id="{68926394-56B6-4AA5-AEF1-BA20187A04B1}"/>
               </a:ext>
             </a:extLst>
           </p:cNvPr>
@@ -5270,7 +5270,7 @@
         </p:xfrm>
         <a:graphic xmlns:a="http://schemas.openxmlformats.org/drawingml/2006/main">
           <a:graphicData uri="http://schemas.openxmlformats.org/drawingml/2006/chart">
-            <c:chart xmlns:r="http://schemas.openxmlformats.org/officeDocument/2006/relationships" xmlns:c="http://schemas.openxmlformats.org/drawingml/2006/chart" r:id="R23fa2bfdb05c4c2f"/>
+            <c:chart xmlns:r="http://schemas.openxmlformats.org/officeDocument/2006/relationships" xmlns:c="http://schemas.openxmlformats.org/drawingml/2006/chart" r:id="R06521382a21c4409"/>
           </a:graphicData>
         </a:graphic>
       </p:graphicFrame>
@@ -5279,7 +5279,7 @@
           <p:cNvPr id="8" name="">
             <a:extLst xmlns:a="http://schemas.openxmlformats.org/drawingml/2006/main">
               <a:ext uri="{FF2B5EF4-FFF2-40B4-BE49-F238E27FC236}">
-                <a16:creationId xmlns:a16="http://schemas.microsoft.com/office/drawing/2014/main" id="{B419BC49-CBF3-40AB-9C67-CE95DF218405}"/>
+                <a16:creationId xmlns:a16="http://schemas.microsoft.com/office/drawing/2014/main" id="{555A7EB8-E71D-4716-A1EA-DE40C61A043B}"/>
               </a:ext>
             </a:extLst>
           </p:cNvPr>
@@ -5336,7 +5336,7 @@
           <p:cNvPr id="9" name="">
             <a:extLst xmlns:a="http://schemas.openxmlformats.org/drawingml/2006/main">
               <a:ext uri="{FF2B5EF4-FFF2-40B4-BE49-F238E27FC236}">
-                <a16:creationId xmlns:a16="http://schemas.microsoft.com/office/drawing/2014/main" id="{11C5D355-1082-47FE-959A-C871CBECF40F}"/>
+                <a16:creationId xmlns:a16="http://schemas.microsoft.com/office/drawing/2014/main" id="{32F761F3-9016-4FC4-8B03-75CA262661C5}"/>
               </a:ext>
             </a:extLst>
           </p:cNvPr>
@@ -5416,7 +5416,7 @@
           <p:cNvPr id="10" name="">
             <a:extLst xmlns:a="http://schemas.openxmlformats.org/drawingml/2006/main">
               <a:ext uri="{FF2B5EF4-FFF2-40B4-BE49-F238E27FC236}">
-                <a16:creationId xmlns:a16="http://schemas.microsoft.com/office/drawing/2014/main" id="{C5556B88-392A-4B64-8AF8-13AC57ADCDAE}"/>
+                <a16:creationId xmlns:a16="http://schemas.microsoft.com/office/drawing/2014/main" id="{E90E8A0A-74F3-4ECE-9CCE-8AF3FE9D67C2}"/>
               </a:ext>
             </a:extLst>
           </p:cNvPr>
@@ -5473,7 +5473,7 @@
           <p:cNvPr id="11" name="">
             <a:extLst xmlns:a="http://schemas.openxmlformats.org/drawingml/2006/main">
               <a:ext uri="{FF2B5EF4-FFF2-40B4-BE49-F238E27FC236}">
-                <a16:creationId xmlns:a16="http://schemas.microsoft.com/office/drawing/2014/main" id="{E03E3E9B-14AE-4629-A312-B7DF4B2B58AE}"/>
+                <a16:creationId xmlns:a16="http://schemas.microsoft.com/office/drawing/2014/main" id="{8FCAE693-EA4C-49F2-9895-464B9F715E43}"/>
               </a:ext>
             </a:extLst>
           </p:cNvPr>
@@ -5530,7 +5530,7 @@
           <p:cNvPr id="12" name="">
             <a:extLst xmlns:a="http://schemas.openxmlformats.org/drawingml/2006/main">
               <a:ext uri="{FF2B5EF4-FFF2-40B4-BE49-F238E27FC236}">
-                <a16:creationId xmlns:a16="http://schemas.microsoft.com/office/drawing/2014/main" id="{9604DD80-F76C-41CA-A1DB-4D338A29D68C}"/>
+                <a16:creationId xmlns:a16="http://schemas.microsoft.com/office/drawing/2014/main" id="{9C53A88A-EBBF-4F24-8D8E-DEA523EE2098}"/>
               </a:ext>
             </a:extLst>
           </p:cNvPr>
@@ -5587,7 +5587,7 @@
           <p:cNvPr id="13" name="">
             <a:extLst xmlns:a="http://schemas.openxmlformats.org/drawingml/2006/main">
               <a:ext uri="{FF2B5EF4-FFF2-40B4-BE49-F238E27FC236}">
-                <a16:creationId xmlns:a16="http://schemas.microsoft.com/office/drawing/2014/main" id="{A7935070-592E-4D59-813B-46CC0BA5BBD6}"/>
+                <a16:creationId xmlns:a16="http://schemas.microsoft.com/office/drawing/2014/main" id="{C4C21192-284D-4761-821F-F95BA3ABA731}"/>
               </a:ext>
             </a:extLst>
           </p:cNvPr>
@@ -5644,7 +5644,7 @@
           <p:cNvPr id="14" name="">
             <a:extLst xmlns:a="http://schemas.openxmlformats.org/drawingml/2006/main">
               <a:ext uri="{FF2B5EF4-FFF2-40B4-BE49-F238E27FC236}">
-                <a16:creationId xmlns:a16="http://schemas.microsoft.com/office/drawing/2014/main" id="{01C5974F-1D2E-49F2-BA1D-62BB39F752AF}"/>
+                <a16:creationId xmlns:a16="http://schemas.microsoft.com/office/drawing/2014/main" id="{6356615F-653F-42D3-A6F2-2DAB6F338479}"/>
               </a:ext>
             </a:extLst>
           </p:cNvPr>
@@ -5699,7 +5699,7 @@
     </p:spTree>
     <p:extLst>
       <p:ext uri="{BB962C8B-B14F-4D97-AF65-F5344CB8AC3E}">
-        <p14:creationId xmlns:p14="http://schemas.microsoft.com/office/powerpoint/2010/main" val="1045825569"/>
+        <p14:creationId xmlns:p14="http://schemas.microsoft.com/office/powerpoint/2010/main" val="1231881067"/>
       </p:ext>
     </p:extLst>
   </p:cSld>
@@ -5730,7 +5730,7 @@
           <p:cNvPr id="16" name="">
             <a:extLst xmlns:a="http://schemas.openxmlformats.org/drawingml/2006/main">
               <a:ext uri="{FF2B5EF4-FFF2-40B4-BE49-F238E27FC236}">
-                <a16:creationId xmlns:a16="http://schemas.microsoft.com/office/drawing/2014/main" id="{6F3DF76A-6545-418D-BD97-6BC6FF3707C9}"/>
+                <a16:creationId xmlns:a16="http://schemas.microsoft.com/office/drawing/2014/main" id="{19AA9F0A-8409-451E-8876-664EFF17AFE5}"/>
               </a:ext>
             </a:extLst>
           </p:cNvPr>
@@ -5787,7 +5787,7 @@
           <p:cNvPr id="2" name="">
             <a:extLst xmlns:a="http://schemas.openxmlformats.org/drawingml/2006/main">
               <a:ext uri="{FF2B5EF4-FFF2-40B4-BE49-F238E27FC236}">
-                <a16:creationId xmlns:a16="http://schemas.microsoft.com/office/drawing/2014/main" id="{1AAB3DBF-91D1-40FD-89F1-654B89321BB1}"/>
+                <a16:creationId xmlns:a16="http://schemas.microsoft.com/office/drawing/2014/main" id="{C54B8EE9-166D-45CA-B03E-5196976F7FD2}"/>
               </a:ext>
             </a:extLst>
           </p:cNvPr>
@@ -5844,7 +5844,7 @@
           <p:cNvPr id="3" name="">
             <a:extLst xmlns:a="http://schemas.openxmlformats.org/drawingml/2006/main">
               <a:ext uri="{FF2B5EF4-FFF2-40B4-BE49-F238E27FC236}">
-                <a16:creationId xmlns:a16="http://schemas.microsoft.com/office/drawing/2014/main" id="{480826EC-00E9-465B-89BC-2FA4B1CAD8B6}"/>
+                <a16:creationId xmlns:a16="http://schemas.microsoft.com/office/drawing/2014/main" id="{5913D00C-94CD-4ED0-B5B2-58D905419F3D}"/>
               </a:ext>
             </a:extLst>
           </p:cNvPr>
@@ -5901,7 +5901,7 @@
           <p:cNvPr id="4" name="">
             <a:extLst xmlns:a="http://schemas.openxmlformats.org/drawingml/2006/main">
               <a:ext uri="{FF2B5EF4-FFF2-40B4-BE49-F238E27FC236}">
-                <a16:creationId xmlns:a16="http://schemas.microsoft.com/office/drawing/2014/main" id="{161B9892-5E18-49C8-8540-0D71DCED3DB1}"/>
+                <a16:creationId xmlns:a16="http://schemas.microsoft.com/office/drawing/2014/main" id="{FCDE3481-8B6E-4E05-ADD4-65D4DDACFA24}"/>
               </a:ext>
             </a:extLst>
           </p:cNvPr>
@@ -5931,7 +5931,7 @@
           <p:cNvPr id="5" name="">
             <a:extLst xmlns:a="http://schemas.openxmlformats.org/drawingml/2006/main">
               <a:ext uri="{FF2B5EF4-FFF2-40B4-BE49-F238E27FC236}">
-                <a16:creationId xmlns:a16="http://schemas.microsoft.com/office/drawing/2014/main" id="{C60C2A35-56F7-460A-B3D3-491272F322E6}"/>
+                <a16:creationId xmlns:a16="http://schemas.microsoft.com/office/drawing/2014/main" id="{97175FCE-8F7F-4FB2-B2A0-EB75E8CF86FB}"/>
               </a:ext>
             </a:extLst>
           </p:cNvPr>
@@ -5988,7 +5988,7 @@
           <p:cNvPr id="6" name="">
             <a:extLst xmlns:a="http://schemas.openxmlformats.org/drawingml/2006/main">
               <a:ext uri="{FF2B5EF4-FFF2-40B4-BE49-F238E27FC236}">
-                <a16:creationId xmlns:a16="http://schemas.microsoft.com/office/drawing/2014/main" id="{181DC6EC-2267-4712-B275-3F76FE76DC78}"/>
+                <a16:creationId xmlns:a16="http://schemas.microsoft.com/office/drawing/2014/main" id="{0D4DB372-6C2E-42B5-A217-EEC0BF104EFD}"/>
               </a:ext>
             </a:extLst>
           </p:cNvPr>
@@ -6052,7 +6052,7 @@
         </p:xfrm>
         <a:graphic xmlns:a="http://schemas.openxmlformats.org/drawingml/2006/main">
           <a:graphicData uri="http://schemas.openxmlformats.org/drawingml/2006/chart">
-            <c:chart xmlns:r="http://schemas.openxmlformats.org/officeDocument/2006/relationships" xmlns:c="http://schemas.openxmlformats.org/drawingml/2006/chart" r:id="R66cd13e96b11477d"/>
+            <c:chart xmlns:r="http://schemas.openxmlformats.org/officeDocument/2006/relationships" xmlns:c="http://schemas.openxmlformats.org/drawingml/2006/chart" r:id="Rff441aa545024ff4"/>
           </a:graphicData>
         </a:graphic>
       </p:graphicFrame>
@@ -6061,7 +6061,7 @@
           <p:cNvPr id="8" name="">
             <a:extLst xmlns:a="http://schemas.openxmlformats.org/drawingml/2006/main">
               <a:ext uri="{FF2B5EF4-FFF2-40B4-BE49-F238E27FC236}">
-                <a16:creationId xmlns:a16="http://schemas.microsoft.com/office/drawing/2014/main" id="{36E87E3C-07F8-47E1-B279-6263F6F602BD}"/>
+                <a16:creationId xmlns:a16="http://schemas.microsoft.com/office/drawing/2014/main" id="{93DB6CC6-6105-4CF3-B40E-B313028244E9}"/>
               </a:ext>
             </a:extLst>
           </p:cNvPr>
@@ -6118,7 +6118,7 @@
           <p:cNvPr id="9" name="">
             <a:extLst xmlns:a="http://schemas.openxmlformats.org/drawingml/2006/main">
               <a:ext uri="{FF2B5EF4-FFF2-40B4-BE49-F238E27FC236}">
-                <a16:creationId xmlns:a16="http://schemas.microsoft.com/office/drawing/2014/main" id="{5E33EE6A-48CE-43B2-9358-E729DDD16400}"/>
+                <a16:creationId xmlns:a16="http://schemas.microsoft.com/office/drawing/2014/main" id="{C6E80BC0-C0EB-4206-9F5F-141B2BCA4958}"/>
               </a:ext>
             </a:extLst>
           </p:cNvPr>
@@ -6198,7 +6198,7 @@
           <p:cNvPr id="10" name="">
             <a:extLst xmlns:a="http://schemas.openxmlformats.org/drawingml/2006/main">
               <a:ext uri="{FF2B5EF4-FFF2-40B4-BE49-F238E27FC236}">
-                <a16:creationId xmlns:a16="http://schemas.microsoft.com/office/drawing/2014/main" id="{C1E324D8-9C6C-44BE-A525-6AB29BCE0933}"/>
+                <a16:creationId xmlns:a16="http://schemas.microsoft.com/office/drawing/2014/main" id="{B725BA96-303D-466E-B9BF-B69C5D483EFB}"/>
               </a:ext>
             </a:extLst>
           </p:cNvPr>
@@ -6301,7 +6301,7 @@
           <p:cNvPr id="11" name="">
             <a:extLst xmlns:a="http://schemas.openxmlformats.org/drawingml/2006/main">
               <a:ext uri="{FF2B5EF4-FFF2-40B4-BE49-F238E27FC236}">
-                <a16:creationId xmlns:a16="http://schemas.microsoft.com/office/drawing/2014/main" id="{C83F6D5F-95ED-4F6A-B42A-0A61997C71F9}"/>
+                <a16:creationId xmlns:a16="http://schemas.microsoft.com/office/drawing/2014/main" id="{DA6A28F5-DEAB-4EF6-BC12-CEBD6EBC877B}"/>
               </a:ext>
             </a:extLst>
           </p:cNvPr>
@@ -6381,7 +6381,7 @@
           <p:cNvPr id="12" name="">
             <a:extLst xmlns:a="http://schemas.openxmlformats.org/drawingml/2006/main">
               <a:ext uri="{FF2B5EF4-FFF2-40B4-BE49-F238E27FC236}">
-                <a16:creationId xmlns:a16="http://schemas.microsoft.com/office/drawing/2014/main" id="{71D25AC4-2F47-44A0-8CDF-44DA64EAF31A}"/>
+                <a16:creationId xmlns:a16="http://schemas.microsoft.com/office/drawing/2014/main" id="{221F194F-6FAB-4B16-BB8C-546C3C810735}"/>
               </a:ext>
             </a:extLst>
           </p:cNvPr>
@@ -6438,7 +6438,7 @@
           <p:cNvPr id="13" name="">
             <a:extLst xmlns:a="http://schemas.openxmlformats.org/drawingml/2006/main">
               <a:ext uri="{FF2B5EF4-FFF2-40B4-BE49-F238E27FC236}">
-                <a16:creationId xmlns:a16="http://schemas.microsoft.com/office/drawing/2014/main" id="{922A131B-7768-4D19-93FE-505D2C2150BF}"/>
+                <a16:creationId xmlns:a16="http://schemas.microsoft.com/office/drawing/2014/main" id="{0FC73E88-3F76-40FE-8272-DB65C7B3FEEB}"/>
               </a:ext>
             </a:extLst>
           </p:cNvPr>
@@ -6495,7 +6495,7 @@
           <p:cNvPr id="14" name="">
             <a:extLst xmlns:a="http://schemas.openxmlformats.org/drawingml/2006/main">
               <a:ext uri="{FF2B5EF4-FFF2-40B4-BE49-F238E27FC236}">
-                <a16:creationId xmlns:a16="http://schemas.microsoft.com/office/drawing/2014/main" id="{2336C653-A4B0-4A89-81BB-3FA4A7DE5EDA}"/>
+                <a16:creationId xmlns:a16="http://schemas.microsoft.com/office/drawing/2014/main" id="{F650B96E-AF16-40D9-A0AF-F8534B88A840}"/>
               </a:ext>
             </a:extLst>
           </p:cNvPr>
@@ -6552,7 +6552,7 @@
           <p:cNvPr id="15" name="">
             <a:extLst xmlns:a="http://schemas.openxmlformats.org/drawingml/2006/main">
               <a:ext uri="{FF2B5EF4-FFF2-40B4-BE49-F238E27FC236}">
-                <a16:creationId xmlns:a16="http://schemas.microsoft.com/office/drawing/2014/main" id="{0B4757D4-6D3F-4814-AC9D-A4EA633AC380}"/>
+                <a16:creationId xmlns:a16="http://schemas.microsoft.com/office/drawing/2014/main" id="{1C9E4E59-0DF0-4B47-B5D1-07493E13EA97}"/>
               </a:ext>
             </a:extLst>
           </p:cNvPr>
@@ -6607,7 +6607,7 @@
     </p:spTree>
     <p:extLst>
       <p:ext uri="{BB962C8B-B14F-4D97-AF65-F5344CB8AC3E}">
-        <p14:creationId xmlns:p14="http://schemas.microsoft.com/office/powerpoint/2010/main" val="1893334653"/>
+        <p14:creationId xmlns:p14="http://schemas.microsoft.com/office/powerpoint/2010/main" val="1975641703"/>
       </p:ext>
     </p:extLst>
   </p:cSld>
@@ -6635,10 +6635,10 @@
       </p:grpSpPr>
       <p:sp>
         <p:nvSpPr>
-          <p:cNvPr id="18" name="">
-            <a:extLst xmlns:a="http://schemas.openxmlformats.org/drawingml/2006/main">
-              <a:ext uri="{FF2B5EF4-FFF2-40B4-BE49-F238E27FC236}">
-                <a16:creationId xmlns:a16="http://schemas.microsoft.com/office/drawing/2014/main" id="{7187A20D-2CD9-43D1-B10D-E7419CC840C4}"/>
+          <p:cNvPr id="24" name="">
+            <a:extLst xmlns:a="http://schemas.openxmlformats.org/drawingml/2006/main">
+              <a:ext uri="{FF2B5EF4-FFF2-40B4-BE49-F238E27FC236}">
+                <a16:creationId xmlns:a16="http://schemas.microsoft.com/office/drawing/2014/main" id="{2E1AE695-909B-4FA8-A74A-D2202279244F}"/>
               </a:ext>
             </a:extLst>
           </p:cNvPr>
@@ -6695,7 +6695,7 @@
           <p:cNvPr id="2" name="">
             <a:extLst xmlns:a="http://schemas.openxmlformats.org/drawingml/2006/main">
               <a:ext uri="{FF2B5EF4-FFF2-40B4-BE49-F238E27FC236}">
-                <a16:creationId xmlns:a16="http://schemas.microsoft.com/office/drawing/2014/main" id="{75859454-13FF-44D6-9485-A3F5D9E1CC27}"/>
+                <a16:creationId xmlns:a16="http://schemas.microsoft.com/office/drawing/2014/main" id="{34C9201F-D9C7-4D87-9D50-6FDB7D237D1B}"/>
               </a:ext>
             </a:extLst>
           </p:cNvPr>
@@ -6752,7 +6752,7 @@
           <p:cNvPr id="3" name="">
             <a:extLst xmlns:a="http://schemas.openxmlformats.org/drawingml/2006/main">
               <a:ext uri="{FF2B5EF4-FFF2-40B4-BE49-F238E27FC236}">
-                <a16:creationId xmlns:a16="http://schemas.microsoft.com/office/drawing/2014/main" id="{18B3CCDC-C9DA-4E7B-A49A-3B409C8406B6}"/>
+                <a16:creationId xmlns:a16="http://schemas.microsoft.com/office/drawing/2014/main" id="{FEF8E7E0-11F6-48FD-A44D-E97B8BB5EB85}"/>
               </a:ext>
             </a:extLst>
           </p:cNvPr>
@@ -6799,7 +6799,7 @@
                 <a:ea typeface="Arial"/>
                 <a:cs typeface="Arial"/>
               </a:rPr>
-              <a:t>Demonstração da aplicação</a:t>
+              <a:t>Demonstração em quatro telas</a:t>
             </a:r>
           </a:p>
         </p:txBody>
@@ -6809,7 +6809,7 @@
           <p:cNvPr id="4" name="">
             <a:extLst xmlns:a="http://schemas.openxmlformats.org/drawingml/2006/main">
               <a:ext uri="{FF2B5EF4-FFF2-40B4-BE49-F238E27FC236}">
-                <a16:creationId xmlns:a16="http://schemas.microsoft.com/office/drawing/2014/main" id="{89412390-9834-416D-A6BF-108B949256D9}"/>
+                <a16:creationId xmlns:a16="http://schemas.microsoft.com/office/drawing/2014/main" id="{67CA9540-B1F2-4352-B53E-1DEA20864E1B}"/>
               </a:ext>
             </a:extLst>
           </p:cNvPr>
@@ -6839,7 +6839,7 @@
           <p:cNvPr id="5" name="">
             <a:extLst xmlns:a="http://schemas.openxmlformats.org/drawingml/2006/main">
               <a:ext uri="{FF2B5EF4-FFF2-40B4-BE49-F238E27FC236}">
-                <a16:creationId xmlns:a16="http://schemas.microsoft.com/office/drawing/2014/main" id="{BA3566DF-1E3F-4B98-8EF7-6031B82F68E7}"/>
+                <a16:creationId xmlns:a16="http://schemas.microsoft.com/office/drawing/2014/main" id="{ACB50659-D74E-4FD4-A97A-907247D6D375}"/>
               </a:ext>
             </a:extLst>
           </p:cNvPr>
@@ -6896,7 +6896,7 @@
           <p:cNvPr id="6" name="">
             <a:extLst xmlns:a="http://schemas.openxmlformats.org/drawingml/2006/main">
               <a:ext uri="{FF2B5EF4-FFF2-40B4-BE49-F238E27FC236}">
-                <a16:creationId xmlns:a16="http://schemas.microsoft.com/office/drawing/2014/main" id="{54CBDD3C-508A-45D9-B783-CAF307DFAED8}"/>
+                <a16:creationId xmlns:a16="http://schemas.microsoft.com/office/drawing/2014/main" id="{58B8CDC2-3AA3-4BA5-9A26-D75F8C6377DF}"/>
               </a:ext>
             </a:extLst>
           </p:cNvPr>
@@ -6943,68 +6943,592 @@
                 <a:ea typeface="Arial"/>
                 <a:cs typeface="Arial"/>
               </a:rPr>
-              <a:t>Demonstração ao vivo</a:t>
-            </a:r>
-          </a:p>
-        </p:txBody>
-      </p:sp>
-      <p:pic>
-        <p:nvPicPr>
-          <p:cNvPr id="24" name=""/>
-          <p:cNvPicPr>
-            <a:picLocks xmlns:a="http://schemas.openxmlformats.org/drawingml/2006/main" noChangeAspect="1"/>
-          </p:cNvPicPr>
-          <p:nvPr/>
-        </p:nvPicPr>
-        <p:blipFill>
-          <a:blip xmlns:r="http://schemas.openxmlformats.org/officeDocument/2006/relationships" xmlns:a="http://schemas.openxmlformats.org/drawingml/2006/main" r:embed="R5a99795b3bd9474a"/>
-          <a:stretch xmlns:a="http://schemas.openxmlformats.org/drawingml/2006/main"/>
-        </p:blipFill>
-        <p:spPr>
-          <a:xfrm xmlns:a="http://schemas.openxmlformats.org/drawingml/2006/main">
-            <a:off x="800251" y="1914525"/>
-            <a:ext cx="7476824" cy="4200525"/>
-          </a:xfrm>
-          <a:prstGeom xmlns:a="http://schemas.openxmlformats.org/drawingml/2006/main" prst="rect">
-            <a:avLst/>
-          </a:prstGeom>
-        </p:spPr>
-      </p:pic>
+              <a:t>Um mesmo recorte, da visão geral à origem do registro</a:t>
+            </a:r>
+          </a:p>
+        </p:txBody>
+      </p:sp>
+      <p:sp>
+        <p:nvSpPr>
+          <p:cNvPr id="7" name="">
+            <a:extLst xmlns:a="http://schemas.openxmlformats.org/drawingml/2006/main">
+              <a:ext uri="{FF2B5EF4-FFF2-40B4-BE49-F238E27FC236}">
+                <a16:creationId xmlns:a16="http://schemas.microsoft.com/office/drawing/2014/main" id="{D84D527C-EBFC-4475-9DD9-787187CB83ED}"/>
+              </a:ext>
+            </a:extLst>
+          </p:cNvPr>
+          <p:cNvSpPr>
+            <a:spLocks xmlns:a="http://schemas.openxmlformats.org/drawingml/2006/main" noGrp="1"/>
+          </p:cNvSpPr>
+          <p:nvPr/>
+        </p:nvSpPr>
+        <p:spPr>
+          <a:xfrm xmlns:a="http://schemas.openxmlformats.org/drawingml/2006/main">
+            <a:off x="609600" y="1952625"/>
+            <a:ext cx="6715125" cy="352425"/>
+          </a:xfrm>
+          <a:prstGeom xmlns:a="http://schemas.openxmlformats.org/drawingml/2006/main" prst="rect">
+            <a:avLst/>
+          </a:prstGeom>
+          <a:noFill xmlns:a="http://schemas.openxmlformats.org/drawingml/2006/main"/>
+          <a:ln xmlns:a="http://schemas.openxmlformats.org/drawingml/2006/main" w="0">
+            <a:noFill/>
+          </a:ln>
+        </p:spPr>
+        <p:txBody>
+          <a:bodyPr xmlns:a="http://schemas.openxmlformats.org/drawingml/2006/main" wrap="square" lIns="0" tIns="0" rIns="0" bIns="0">
+            <a:noAutofit/>
+          </a:bodyPr>
+          <a:lstStyle xmlns:a="http://schemas.openxmlformats.org/drawingml/2006/main"/>
+          <a:p xmlns:a="http://schemas.openxmlformats.org/drawingml/2006/main">
+            <a:pPr>
+              <a:defRPr sz="2025" b="1">
+                <a:solidFill>
+                  <a:srgbClr val="14283F"/>
+                </a:solidFill>
+                <a:latin typeface="Arial"/>
+                <a:ea typeface="Arial"/>
+                <a:cs typeface="Arial"/>
+              </a:defRPr>
+            </a:pPr>
+            <a:r>
+              <a:rPr sz="2025" b="1">
+                <a:solidFill>
+                  <a:srgbClr val="14283F"/>
+                </a:solidFill>
+                <a:latin typeface="Arial"/>
+                <a:ea typeface="Arial"/>
+                <a:cs typeface="Arial"/>
+              </a:rPr>
+              <a:t>01  Visão geral</a:t>
+            </a:r>
+          </a:p>
+        </p:txBody>
+      </p:sp>
       <p:sp>
         <p:nvSpPr>
           <p:cNvPr id="8" name="">
             <a:extLst xmlns:a="http://schemas.openxmlformats.org/drawingml/2006/main">
               <a:ext uri="{FF2B5EF4-FFF2-40B4-BE49-F238E27FC236}">
-                <a16:creationId xmlns:a16="http://schemas.microsoft.com/office/drawing/2014/main" id="{FAECF6B6-0D3A-40E1-AF01-64D5A7A6E16D}"/>
-              </a:ext>
-            </a:extLst>
-          </p:cNvPr>
-          <p:cNvSpPr>
-            <a:spLocks xmlns:a="http://schemas.openxmlformats.org/drawingml/2006/main" noGrp="1"/>
-          </p:cNvSpPr>
-          <p:nvPr/>
-        </p:nvSpPr>
-        <p:spPr>
-          <a:xfrm xmlns:a="http://schemas.openxmlformats.org/drawingml/2006/main">
-            <a:off x="8858250" y="1990725"/>
-            <a:ext cx="619125" cy="342900"/>
-          </a:xfrm>
-          <a:prstGeom xmlns:a="http://schemas.openxmlformats.org/drawingml/2006/main" prst="rect">
-            <a:avLst/>
-          </a:prstGeom>
-          <a:noFill xmlns:a="http://schemas.openxmlformats.org/drawingml/2006/main"/>
-          <a:ln xmlns:a="http://schemas.openxmlformats.org/drawingml/2006/main" w="0">
-            <a:noFill/>
-          </a:ln>
-        </p:spPr>
-        <p:txBody>
-          <a:bodyPr xmlns:a="http://schemas.openxmlformats.org/drawingml/2006/main" wrap="square" lIns="0" tIns="0" rIns="0" bIns="0">
-            <a:noAutofit/>
-          </a:bodyPr>
-          <a:lstStyle xmlns:a="http://schemas.openxmlformats.org/drawingml/2006/main"/>
-          <a:p xmlns:a="http://schemas.openxmlformats.org/drawingml/2006/main">
-            <a:pPr>
-              <a:defRPr sz="1800" b="1">
+                <a16:creationId xmlns:a16="http://schemas.microsoft.com/office/drawing/2014/main" id="{9E9B21E2-6FF6-48C2-82D9-33B42C9F5987}"/>
+              </a:ext>
+            </a:extLst>
+          </p:cNvPr>
+          <p:cNvSpPr>
+            <a:spLocks xmlns:a="http://schemas.openxmlformats.org/drawingml/2006/main" noGrp="1"/>
+          </p:cNvSpPr>
+          <p:nvPr/>
+        </p:nvSpPr>
+        <p:spPr>
+          <a:xfrm xmlns:a="http://schemas.openxmlformats.org/drawingml/2006/main">
+            <a:off x="609600" y="2352675"/>
+            <a:ext cx="6715125" cy="409575"/>
+          </a:xfrm>
+          <a:prstGeom xmlns:a="http://schemas.openxmlformats.org/drawingml/2006/main" prst="rect">
+            <a:avLst/>
+          </a:prstGeom>
+          <a:noFill xmlns:a="http://schemas.openxmlformats.org/drawingml/2006/main"/>
+          <a:ln xmlns:a="http://schemas.openxmlformats.org/drawingml/2006/main" w="0">
+            <a:noFill/>
+          </a:ln>
+        </p:spPr>
+        <p:txBody>
+          <a:bodyPr xmlns:a="http://schemas.openxmlformats.org/drawingml/2006/main" wrap="square" lIns="0" tIns="0" rIns="0" bIns="0">
+            <a:noAutofit/>
+          </a:bodyPr>
+          <a:lstStyle xmlns:a="http://schemas.openxmlformats.org/drawingml/2006/main"/>
+          <a:p xmlns:a="http://schemas.openxmlformats.org/drawingml/2006/main">
+            <a:pPr>
+              <a:defRPr sz="1800" b="0">
+                <a:solidFill>
+                  <a:srgbClr val="5D6D82"/>
+                </a:solidFill>
+                <a:latin typeface="Arial"/>
+                <a:ea typeface="Arial"/>
+                <a:cs typeface="Arial"/>
+              </a:defRPr>
+            </a:pPr>
+            <a:r>
+              <a:rPr sz="1800" b="0">
+                <a:solidFill>
+                  <a:srgbClr val="5D6D82"/>
+                </a:solidFill>
+                <a:latin typeface="Arial"/>
+                <a:ea typeface="Arial"/>
+                <a:cs typeface="Arial"/>
+              </a:rPr>
+              <a:t>Indicadores e destaques do recorte.</a:t>
+            </a:r>
+          </a:p>
+        </p:txBody>
+      </p:sp>
+      <p:sp>
+        <p:nvSpPr>
+          <p:cNvPr id="9" name="">
+            <a:extLst xmlns:a="http://schemas.openxmlformats.org/drawingml/2006/main">
+              <a:ext uri="{FF2B5EF4-FFF2-40B4-BE49-F238E27FC236}">
+                <a16:creationId xmlns:a16="http://schemas.microsoft.com/office/drawing/2014/main" id="{F03B32C5-0BE4-4B60-A4D7-F9473D331FFD}"/>
+              </a:ext>
+            </a:extLst>
+          </p:cNvPr>
+          <p:cNvSpPr>
+            <a:spLocks xmlns:a="http://schemas.openxmlformats.org/drawingml/2006/main" noGrp="1"/>
+          </p:cNvSpPr>
+          <p:nvPr/>
+        </p:nvSpPr>
+        <p:spPr>
+          <a:xfrm xmlns:a="http://schemas.openxmlformats.org/drawingml/2006/main">
+            <a:off x="609600" y="2771775"/>
+            <a:ext cx="6715125" cy="0"/>
+          </a:xfrm>
+          <a:prstGeom xmlns:a="http://schemas.openxmlformats.org/drawingml/2006/main" prst="line">
+            <a:avLst/>
+          </a:prstGeom>
+          <a:noFill xmlns:a="http://schemas.openxmlformats.org/drawingml/2006/main"/>
+          <a:ln xmlns:a="http://schemas.openxmlformats.org/drawingml/2006/main" w="9525">
+            <a:solidFill>
+              <a:srgbClr val="DCE3EC"/>
+            </a:solidFill>
+          </a:ln>
+        </p:spPr>
+      </p:sp>
+      <p:sp>
+        <p:nvSpPr>
+          <p:cNvPr id="10" name="">
+            <a:extLst xmlns:a="http://schemas.openxmlformats.org/drawingml/2006/main">
+              <a:ext uri="{FF2B5EF4-FFF2-40B4-BE49-F238E27FC236}">
+                <a16:creationId xmlns:a16="http://schemas.microsoft.com/office/drawing/2014/main" id="{00756EBF-22F5-47B5-9B11-8D75BB7269E2}"/>
+              </a:ext>
+            </a:extLst>
+          </p:cNvPr>
+          <p:cNvSpPr>
+            <a:spLocks xmlns:a="http://schemas.openxmlformats.org/drawingml/2006/main" noGrp="1"/>
+          </p:cNvSpPr>
+          <p:nvPr/>
+        </p:nvSpPr>
+        <p:spPr>
+          <a:xfrm xmlns:a="http://schemas.openxmlformats.org/drawingml/2006/main">
+            <a:off x="609600" y="2895600"/>
+            <a:ext cx="6715125" cy="352425"/>
+          </a:xfrm>
+          <a:prstGeom xmlns:a="http://schemas.openxmlformats.org/drawingml/2006/main" prst="rect">
+            <a:avLst/>
+          </a:prstGeom>
+          <a:noFill xmlns:a="http://schemas.openxmlformats.org/drawingml/2006/main"/>
+          <a:ln xmlns:a="http://schemas.openxmlformats.org/drawingml/2006/main" w="0">
+            <a:noFill/>
+          </a:ln>
+        </p:spPr>
+        <p:txBody>
+          <a:bodyPr xmlns:a="http://schemas.openxmlformats.org/drawingml/2006/main" wrap="square" lIns="0" tIns="0" rIns="0" bIns="0">
+            <a:noAutofit/>
+          </a:bodyPr>
+          <a:lstStyle xmlns:a="http://schemas.openxmlformats.org/drawingml/2006/main"/>
+          <a:p xmlns:a="http://schemas.openxmlformats.org/drawingml/2006/main">
+            <a:pPr>
+              <a:defRPr sz="2025" b="1">
+                <a:solidFill>
+                  <a:srgbClr val="14283F"/>
+                </a:solidFill>
+                <a:latin typeface="Arial"/>
+                <a:ea typeface="Arial"/>
+                <a:cs typeface="Arial"/>
+              </a:defRPr>
+            </a:pPr>
+            <a:r>
+              <a:rPr sz="2025" b="1">
+                <a:solidFill>
+                  <a:srgbClr val="14283F"/>
+                </a:solidFill>
+                <a:latin typeface="Arial"/>
+                <a:ea typeface="Arial"/>
+                <a:cs typeface="Arial"/>
+              </a:rPr>
+              <a:t>02  Distribuição</a:t>
+            </a:r>
+          </a:p>
+        </p:txBody>
+      </p:sp>
+      <p:sp>
+        <p:nvSpPr>
+          <p:cNvPr id="11" name="">
+            <a:extLst xmlns:a="http://schemas.openxmlformats.org/drawingml/2006/main">
+              <a:ext uri="{FF2B5EF4-FFF2-40B4-BE49-F238E27FC236}">
+                <a16:creationId xmlns:a16="http://schemas.microsoft.com/office/drawing/2014/main" id="{883E85D1-753A-41B1-A536-BA5CC414D279}"/>
+              </a:ext>
+            </a:extLst>
+          </p:cNvPr>
+          <p:cNvSpPr>
+            <a:spLocks xmlns:a="http://schemas.openxmlformats.org/drawingml/2006/main" noGrp="1"/>
+          </p:cNvSpPr>
+          <p:nvPr/>
+        </p:nvSpPr>
+        <p:spPr>
+          <a:xfrm xmlns:a="http://schemas.openxmlformats.org/drawingml/2006/main">
+            <a:off x="609600" y="3295650"/>
+            <a:ext cx="6715125" cy="409575"/>
+          </a:xfrm>
+          <a:prstGeom xmlns:a="http://schemas.openxmlformats.org/drawingml/2006/main" prst="rect">
+            <a:avLst/>
+          </a:prstGeom>
+          <a:noFill xmlns:a="http://schemas.openxmlformats.org/drawingml/2006/main"/>
+          <a:ln xmlns:a="http://schemas.openxmlformats.org/drawingml/2006/main" w="0">
+            <a:noFill/>
+          </a:ln>
+        </p:spPr>
+        <p:txBody>
+          <a:bodyPr xmlns:a="http://schemas.openxmlformats.org/drawingml/2006/main" wrap="square" lIns="0" tIns="0" rIns="0" bIns="0">
+            <a:noAutofit/>
+          </a:bodyPr>
+          <a:lstStyle xmlns:a="http://schemas.openxmlformats.org/drawingml/2006/main"/>
+          <a:p xmlns:a="http://schemas.openxmlformats.org/drawingml/2006/main">
+            <a:pPr>
+              <a:defRPr sz="1800" b="0">
+                <a:solidFill>
+                  <a:srgbClr val="5D6D82"/>
+                </a:solidFill>
+                <a:latin typeface="Arial"/>
+                <a:ea typeface="Arial"/>
+                <a:cs typeface="Arial"/>
+              </a:defRPr>
+            </a:pPr>
+            <a:r>
+              <a:rPr sz="1800" b="0">
+                <a:solidFill>
+                  <a:srgbClr val="5D6D82"/>
+                </a:solidFill>
+                <a:latin typeface="Arial"/>
+                <a:ea typeface="Arial"/>
+                <a:cs typeface="Arial"/>
+              </a:rPr>
+              <a:t>Ranking e evolução mensal.</a:t>
+            </a:r>
+          </a:p>
+        </p:txBody>
+      </p:sp>
+      <p:sp>
+        <p:nvSpPr>
+          <p:cNvPr id="12" name="">
+            <a:extLst xmlns:a="http://schemas.openxmlformats.org/drawingml/2006/main">
+              <a:ext uri="{FF2B5EF4-FFF2-40B4-BE49-F238E27FC236}">
+                <a16:creationId xmlns:a16="http://schemas.microsoft.com/office/drawing/2014/main" id="{38B95E8B-81D4-464A-992F-EEC73AFA09BB}"/>
+              </a:ext>
+            </a:extLst>
+          </p:cNvPr>
+          <p:cNvSpPr>
+            <a:spLocks xmlns:a="http://schemas.openxmlformats.org/drawingml/2006/main" noGrp="1"/>
+          </p:cNvSpPr>
+          <p:nvPr/>
+        </p:nvSpPr>
+        <p:spPr>
+          <a:xfrm xmlns:a="http://schemas.openxmlformats.org/drawingml/2006/main">
+            <a:off x="609600" y="3714750"/>
+            <a:ext cx="6715125" cy="0"/>
+          </a:xfrm>
+          <a:prstGeom xmlns:a="http://schemas.openxmlformats.org/drawingml/2006/main" prst="line">
+            <a:avLst/>
+          </a:prstGeom>
+          <a:noFill xmlns:a="http://schemas.openxmlformats.org/drawingml/2006/main"/>
+          <a:ln xmlns:a="http://schemas.openxmlformats.org/drawingml/2006/main" w="9525">
+            <a:solidFill>
+              <a:srgbClr val="DCE3EC"/>
+            </a:solidFill>
+          </a:ln>
+        </p:spPr>
+      </p:sp>
+      <p:sp>
+        <p:nvSpPr>
+          <p:cNvPr id="13" name="">
+            <a:extLst xmlns:a="http://schemas.openxmlformats.org/drawingml/2006/main">
+              <a:ext uri="{FF2B5EF4-FFF2-40B4-BE49-F238E27FC236}">
+                <a16:creationId xmlns:a16="http://schemas.microsoft.com/office/drawing/2014/main" id="{7B587BDC-7296-412F-8964-BD72632FEF28}"/>
+              </a:ext>
+            </a:extLst>
+          </p:cNvPr>
+          <p:cNvSpPr>
+            <a:spLocks xmlns:a="http://schemas.openxmlformats.org/drawingml/2006/main" noGrp="1"/>
+          </p:cNvSpPr>
+          <p:nvPr/>
+        </p:nvSpPr>
+        <p:spPr>
+          <a:xfrm xmlns:a="http://schemas.openxmlformats.org/drawingml/2006/main">
+            <a:off x="609600" y="3838575"/>
+            <a:ext cx="6715125" cy="352425"/>
+          </a:xfrm>
+          <a:prstGeom xmlns:a="http://schemas.openxmlformats.org/drawingml/2006/main" prst="rect">
+            <a:avLst/>
+          </a:prstGeom>
+          <a:noFill xmlns:a="http://schemas.openxmlformats.org/drawingml/2006/main"/>
+          <a:ln xmlns:a="http://schemas.openxmlformats.org/drawingml/2006/main" w="0">
+            <a:noFill/>
+          </a:ln>
+        </p:spPr>
+        <p:txBody>
+          <a:bodyPr xmlns:a="http://schemas.openxmlformats.org/drawingml/2006/main" wrap="square" lIns="0" tIns="0" rIns="0" bIns="0">
+            <a:noAutofit/>
+          </a:bodyPr>
+          <a:lstStyle xmlns:a="http://schemas.openxmlformats.org/drawingml/2006/main"/>
+          <a:p xmlns:a="http://schemas.openxmlformats.org/drawingml/2006/main">
+            <a:pPr>
+              <a:defRPr sz="2025" b="1">
+                <a:solidFill>
+                  <a:srgbClr val="14283F"/>
+                </a:solidFill>
+                <a:latin typeface="Arial"/>
+                <a:ea typeface="Arial"/>
+                <a:cs typeface="Arial"/>
+              </a:defRPr>
+            </a:pPr>
+            <a:r>
+              <a:rPr sz="2025" b="1">
+                <a:solidFill>
+                  <a:srgbClr val="14283F"/>
+                </a:solidFill>
+                <a:latin typeface="Arial"/>
+                <a:ea typeface="Arial"/>
+                <a:cs typeface="Arial"/>
+              </a:rPr>
+              <a:t>03  Registros</a:t>
+            </a:r>
+          </a:p>
+        </p:txBody>
+      </p:sp>
+      <p:sp>
+        <p:nvSpPr>
+          <p:cNvPr id="14" name="">
+            <a:extLst xmlns:a="http://schemas.openxmlformats.org/drawingml/2006/main">
+              <a:ext uri="{FF2B5EF4-FFF2-40B4-BE49-F238E27FC236}">
+                <a16:creationId xmlns:a16="http://schemas.microsoft.com/office/drawing/2014/main" id="{0BE23145-8FE2-4CF4-B793-905127755183}"/>
+              </a:ext>
+            </a:extLst>
+          </p:cNvPr>
+          <p:cNvSpPr>
+            <a:spLocks xmlns:a="http://schemas.openxmlformats.org/drawingml/2006/main" noGrp="1"/>
+          </p:cNvSpPr>
+          <p:nvPr/>
+        </p:nvSpPr>
+        <p:spPr>
+          <a:xfrm xmlns:a="http://schemas.openxmlformats.org/drawingml/2006/main">
+            <a:off x="609600" y="4238625"/>
+            <a:ext cx="6715125" cy="409575"/>
+          </a:xfrm>
+          <a:prstGeom xmlns:a="http://schemas.openxmlformats.org/drawingml/2006/main" prst="rect">
+            <a:avLst/>
+          </a:prstGeom>
+          <a:noFill xmlns:a="http://schemas.openxmlformats.org/drawingml/2006/main"/>
+          <a:ln xmlns:a="http://schemas.openxmlformats.org/drawingml/2006/main" w="0">
+            <a:noFill/>
+          </a:ln>
+        </p:spPr>
+        <p:txBody>
+          <a:bodyPr xmlns:a="http://schemas.openxmlformats.org/drawingml/2006/main" wrap="square" lIns="0" tIns="0" rIns="0" bIns="0">
+            <a:noAutofit/>
+          </a:bodyPr>
+          <a:lstStyle xmlns:a="http://schemas.openxmlformats.org/drawingml/2006/main"/>
+          <a:p xmlns:a="http://schemas.openxmlformats.org/drawingml/2006/main">
+            <a:pPr>
+              <a:defRPr sz="1800" b="0">
+                <a:solidFill>
+                  <a:srgbClr val="5D6D82"/>
+                </a:solidFill>
+                <a:latin typeface="Arial"/>
+                <a:ea typeface="Arial"/>
+                <a:cs typeface="Arial"/>
+              </a:defRPr>
+            </a:pPr>
+            <a:r>
+              <a:rPr sz="1800" b="0">
+                <a:solidFill>
+                  <a:srgbClr val="5D6D82"/>
+                </a:solidFill>
+                <a:latin typeface="Arial"/>
+                <a:ea typeface="Arial"/>
+                <a:cs typeface="Arial"/>
+              </a:rPr>
+              <a:t>Arquivo e linha de origem, paginação e CSV.</a:t>
+            </a:r>
+          </a:p>
+        </p:txBody>
+      </p:sp>
+      <p:sp>
+        <p:nvSpPr>
+          <p:cNvPr id="15" name="">
+            <a:extLst xmlns:a="http://schemas.openxmlformats.org/drawingml/2006/main">
+              <a:ext uri="{FF2B5EF4-FFF2-40B4-BE49-F238E27FC236}">
+                <a16:creationId xmlns:a16="http://schemas.microsoft.com/office/drawing/2014/main" id="{A9F4C912-FF5E-435C-ABE3-4985FFFA3D1F}"/>
+              </a:ext>
+            </a:extLst>
+          </p:cNvPr>
+          <p:cNvSpPr>
+            <a:spLocks xmlns:a="http://schemas.openxmlformats.org/drawingml/2006/main" noGrp="1"/>
+          </p:cNvSpPr>
+          <p:nvPr/>
+        </p:nvSpPr>
+        <p:spPr>
+          <a:xfrm xmlns:a="http://schemas.openxmlformats.org/drawingml/2006/main">
+            <a:off x="609600" y="4657725"/>
+            <a:ext cx="6715125" cy="0"/>
+          </a:xfrm>
+          <a:prstGeom xmlns:a="http://schemas.openxmlformats.org/drawingml/2006/main" prst="line">
+            <a:avLst/>
+          </a:prstGeom>
+          <a:noFill xmlns:a="http://schemas.openxmlformats.org/drawingml/2006/main"/>
+          <a:ln xmlns:a="http://schemas.openxmlformats.org/drawingml/2006/main" w="9525">
+            <a:solidFill>
+              <a:srgbClr val="DCE3EC"/>
+            </a:solidFill>
+          </a:ln>
+        </p:spPr>
+      </p:sp>
+      <p:sp>
+        <p:nvSpPr>
+          <p:cNvPr id="16" name="">
+            <a:extLst xmlns:a="http://schemas.openxmlformats.org/drawingml/2006/main">
+              <a:ext uri="{FF2B5EF4-FFF2-40B4-BE49-F238E27FC236}">
+                <a16:creationId xmlns:a16="http://schemas.microsoft.com/office/drawing/2014/main" id="{44533AA6-22EB-467C-B16A-906701DADF88}"/>
+              </a:ext>
+            </a:extLst>
+          </p:cNvPr>
+          <p:cNvSpPr>
+            <a:spLocks xmlns:a="http://schemas.openxmlformats.org/drawingml/2006/main" noGrp="1"/>
+          </p:cNvSpPr>
+          <p:nvPr/>
+        </p:nvSpPr>
+        <p:spPr>
+          <a:xfrm xmlns:a="http://schemas.openxmlformats.org/drawingml/2006/main">
+            <a:off x="609600" y="4781550"/>
+            <a:ext cx="6715125" cy="352425"/>
+          </a:xfrm>
+          <a:prstGeom xmlns:a="http://schemas.openxmlformats.org/drawingml/2006/main" prst="rect">
+            <a:avLst/>
+          </a:prstGeom>
+          <a:noFill xmlns:a="http://schemas.openxmlformats.org/drawingml/2006/main"/>
+          <a:ln xmlns:a="http://schemas.openxmlformats.org/drawingml/2006/main" w="0">
+            <a:noFill/>
+          </a:ln>
+        </p:spPr>
+        <p:txBody>
+          <a:bodyPr xmlns:a="http://schemas.openxmlformats.org/drawingml/2006/main" wrap="square" lIns="0" tIns="0" rIns="0" bIns="0">
+            <a:noAutofit/>
+          </a:bodyPr>
+          <a:lstStyle xmlns:a="http://schemas.openxmlformats.org/drawingml/2006/main"/>
+          <a:p xmlns:a="http://schemas.openxmlformats.org/drawingml/2006/main">
+            <a:pPr>
+              <a:defRPr sz="2025" b="1">
+                <a:solidFill>
+                  <a:srgbClr val="14283F"/>
+                </a:solidFill>
+                <a:latin typeface="Arial"/>
+                <a:ea typeface="Arial"/>
+                <a:cs typeface="Arial"/>
+              </a:defRPr>
+            </a:pPr>
+            <a:r>
+              <a:rPr sz="2025" b="1">
+                <a:solidFill>
+                  <a:srgbClr val="14283F"/>
+                </a:solidFill>
+                <a:latin typeface="Arial"/>
+                <a:ea typeface="Arial"/>
+                <a:cs typeface="Arial"/>
+              </a:rPr>
+              <a:t>04  Metodologia</a:t>
+            </a:r>
+          </a:p>
+        </p:txBody>
+      </p:sp>
+      <p:sp>
+        <p:nvSpPr>
+          <p:cNvPr id="17" name="">
+            <a:extLst xmlns:a="http://schemas.openxmlformats.org/drawingml/2006/main">
+              <a:ext uri="{FF2B5EF4-FFF2-40B4-BE49-F238E27FC236}">
+                <a16:creationId xmlns:a16="http://schemas.microsoft.com/office/drawing/2014/main" id="{54381058-50D5-49F7-AE7A-2666B965AD55}"/>
+              </a:ext>
+            </a:extLst>
+          </p:cNvPr>
+          <p:cNvSpPr>
+            <a:spLocks xmlns:a="http://schemas.openxmlformats.org/drawingml/2006/main" noGrp="1"/>
+          </p:cNvSpPr>
+          <p:nvPr/>
+        </p:nvSpPr>
+        <p:spPr>
+          <a:xfrm xmlns:a="http://schemas.openxmlformats.org/drawingml/2006/main">
+            <a:off x="609600" y="5181600"/>
+            <a:ext cx="6715125" cy="409575"/>
+          </a:xfrm>
+          <a:prstGeom xmlns:a="http://schemas.openxmlformats.org/drawingml/2006/main" prst="rect">
+            <a:avLst/>
+          </a:prstGeom>
+          <a:noFill xmlns:a="http://schemas.openxmlformats.org/drawingml/2006/main"/>
+          <a:ln xmlns:a="http://schemas.openxmlformats.org/drawingml/2006/main" w="0">
+            <a:noFill/>
+          </a:ln>
+        </p:spPr>
+        <p:txBody>
+          <a:bodyPr xmlns:a="http://schemas.openxmlformats.org/drawingml/2006/main" wrap="square" lIns="0" tIns="0" rIns="0" bIns="0">
+            <a:noAutofit/>
+          </a:bodyPr>
+          <a:lstStyle xmlns:a="http://schemas.openxmlformats.org/drawingml/2006/main"/>
+          <a:p xmlns:a="http://schemas.openxmlformats.org/drawingml/2006/main">
+            <a:pPr>
+              <a:defRPr sz="1800" b="0">
+                <a:solidFill>
+                  <a:srgbClr val="5D6D82"/>
+                </a:solidFill>
+                <a:latin typeface="Arial"/>
+                <a:ea typeface="Arial"/>
+                <a:cs typeface="Arial"/>
+              </a:defRPr>
+            </a:pPr>
+            <a:r>
+              <a:rPr sz="1800" b="0">
+                <a:solidFill>
+                  <a:srgbClr val="5D6D82"/>
+                </a:solidFill>
+                <a:latin typeface="Arial"/>
+                <a:ea typeface="Arial"/>
+                <a:cs typeface="Arial"/>
+              </a:rPr>
+              <a:t>Definições e limites da análise.</a:t>
+            </a:r>
+          </a:p>
+        </p:txBody>
+      </p:sp>
+      <p:sp>
+        <p:nvSpPr>
+          <p:cNvPr id="18" name="">
+            <a:extLst xmlns:a="http://schemas.openxmlformats.org/drawingml/2006/main">
+              <a:ext uri="{FF2B5EF4-FFF2-40B4-BE49-F238E27FC236}">
+                <a16:creationId xmlns:a16="http://schemas.microsoft.com/office/drawing/2014/main" id="{6B3108F7-5FEB-40F5-A75D-F4DAF3165C72}"/>
+              </a:ext>
+            </a:extLst>
+          </p:cNvPr>
+          <p:cNvSpPr>
+            <a:spLocks xmlns:a="http://schemas.openxmlformats.org/drawingml/2006/main" noGrp="1"/>
+          </p:cNvSpPr>
+          <p:nvPr/>
+        </p:nvSpPr>
+        <p:spPr>
+          <a:xfrm xmlns:a="http://schemas.openxmlformats.org/drawingml/2006/main">
+            <a:off x="8020050" y="1952625"/>
+            <a:ext cx="3524250" cy="428625"/>
+          </a:xfrm>
+          <a:prstGeom xmlns:a="http://schemas.openxmlformats.org/drawingml/2006/main" prst="rect">
+            <a:avLst/>
+          </a:prstGeom>
+          <a:noFill xmlns:a="http://schemas.openxmlformats.org/drawingml/2006/main"/>
+          <a:ln xmlns:a="http://schemas.openxmlformats.org/drawingml/2006/main" w="0">
+            <a:noFill/>
+          </a:ln>
+        </p:spPr>
+        <p:txBody>
+          <a:bodyPr xmlns:a="http://schemas.openxmlformats.org/drawingml/2006/main" wrap="square" lIns="0" tIns="0" rIns="0" bIns="0">
+            <a:noAutofit/>
+          </a:bodyPr>
+          <a:lstStyle xmlns:a="http://schemas.openxmlformats.org/drawingml/2006/main"/>
+          <a:p xmlns:a="http://schemas.openxmlformats.org/drawingml/2006/main">
+            <a:pPr>
+              <a:defRPr sz="2100" b="1">
                 <a:solidFill>
                   <a:srgbClr val="2563EB"/>
                 </a:solidFill>
@@ -7014,7 +7538,7 @@
               </a:defRPr>
             </a:pPr>
             <a:r>
-              <a:rPr sz="1800" b="1">
+              <a:rPr sz="2100" b="1">
                 <a:solidFill>
                   <a:srgbClr val="2563EB"/>
                 </a:solidFill>
@@ -7022,29 +7546,200 @@
                 <a:ea typeface="Arial"/>
                 <a:cs typeface="Arial"/>
               </a:rPr>
-              <a:t>01</a:t>
-            </a:r>
-          </a:p>
-        </p:txBody>
-      </p:sp>
-      <p:sp>
-        <p:nvSpPr>
-          <p:cNvPr id="9" name="">
-            <a:extLst xmlns:a="http://schemas.openxmlformats.org/drawingml/2006/main">
-              <a:ext uri="{FF2B5EF4-FFF2-40B4-BE49-F238E27FC236}">
-                <a16:creationId xmlns:a16="http://schemas.microsoft.com/office/drawing/2014/main" id="{217B4FF9-D5B7-4AA7-94BE-1C1761A77486}"/>
-              </a:ext>
-            </a:extLst>
-          </p:cNvPr>
-          <p:cNvSpPr>
-            <a:spLocks xmlns:a="http://schemas.openxmlformats.org/drawingml/2006/main" noGrp="1"/>
-          </p:cNvSpPr>
-          <p:nvPr/>
-        </p:nvSpPr>
-        <p:spPr>
-          <a:xfrm xmlns:a="http://schemas.openxmlformats.org/drawingml/2006/main">
-            <a:off x="9458325" y="1990725"/>
-            <a:ext cx="2095500" cy="638175"/>
+              <a:t>Saúde em dezembro</a:t>
+            </a:r>
+          </a:p>
+        </p:txBody>
+      </p:sp>
+      <p:sp>
+        <p:nvSpPr>
+          <p:cNvPr id="19" name="">
+            <a:extLst xmlns:a="http://schemas.openxmlformats.org/drawingml/2006/main">
+              <a:ext uri="{FF2B5EF4-FFF2-40B4-BE49-F238E27FC236}">
+                <a16:creationId xmlns:a16="http://schemas.microsoft.com/office/drawing/2014/main" id="{72EA448C-817B-438D-BC8E-A550950FF7B3}"/>
+              </a:ext>
+            </a:extLst>
+          </p:cNvPr>
+          <p:cNvSpPr>
+            <a:spLocks xmlns:a="http://schemas.openxmlformats.org/drawingml/2006/main" noGrp="1"/>
+          </p:cNvSpPr>
+          <p:nvPr/>
+        </p:nvSpPr>
+        <p:spPr>
+          <a:xfrm xmlns:a="http://schemas.openxmlformats.org/drawingml/2006/main">
+            <a:off x="8020050" y="2581275"/>
+            <a:ext cx="3524250" cy="409575"/>
+          </a:xfrm>
+          <a:prstGeom xmlns:a="http://schemas.openxmlformats.org/drawingml/2006/main" prst="rect">
+            <a:avLst/>
+          </a:prstGeom>
+          <a:noFill xmlns:a="http://schemas.openxmlformats.org/drawingml/2006/main"/>
+          <a:ln xmlns:a="http://schemas.openxmlformats.org/drawingml/2006/main" w="0">
+            <a:noFill/>
+          </a:ln>
+        </p:spPr>
+        <p:txBody>
+          <a:bodyPr xmlns:a="http://schemas.openxmlformats.org/drawingml/2006/main" wrap="square" lIns="0" tIns="0" rIns="0" bIns="0">
+            <a:noAutofit/>
+          </a:bodyPr>
+          <a:lstStyle xmlns:a="http://schemas.openxmlformats.org/drawingml/2006/main"/>
+          <a:p xmlns:a="http://schemas.openxmlformats.org/drawingml/2006/main">
+            <a:pPr>
+              <a:defRPr sz="2250" b="1">
+                <a:solidFill>
+                  <a:srgbClr val="14283F"/>
+                </a:solidFill>
+                <a:latin typeface="Arial"/>
+                <a:ea typeface="Arial"/>
+                <a:cs typeface="Arial"/>
+              </a:defRPr>
+            </a:pPr>
+            <a:r>
+              <a:rPr sz="2250" b="1">
+                <a:solidFill>
+                  <a:srgbClr val="14283F"/>
+                </a:solidFill>
+                <a:latin typeface="Arial"/>
+                <a:ea typeface="Arial"/>
+                <a:cs typeface="Arial"/>
+              </a:rPr>
+              <a:t>7.790 registros</a:t>
+            </a:r>
+          </a:p>
+        </p:txBody>
+      </p:sp>
+      <p:sp>
+        <p:nvSpPr>
+          <p:cNvPr id="20" name="">
+            <a:extLst xmlns:a="http://schemas.openxmlformats.org/drawingml/2006/main">
+              <a:ext uri="{FF2B5EF4-FFF2-40B4-BE49-F238E27FC236}">
+                <a16:creationId xmlns:a16="http://schemas.microsoft.com/office/drawing/2014/main" id="{2680A437-1F3C-45EE-9683-55F3E05485AD}"/>
+              </a:ext>
+            </a:extLst>
+          </p:cNvPr>
+          <p:cNvSpPr>
+            <a:spLocks xmlns:a="http://schemas.openxmlformats.org/drawingml/2006/main" noGrp="1"/>
+          </p:cNvSpPr>
+          <p:nvPr/>
+        </p:nvSpPr>
+        <p:spPr>
+          <a:xfrm xmlns:a="http://schemas.openxmlformats.org/drawingml/2006/main">
+            <a:off x="8020050" y="3095625"/>
+            <a:ext cx="3524250" cy="409575"/>
+          </a:xfrm>
+          <a:prstGeom xmlns:a="http://schemas.openxmlformats.org/drawingml/2006/main" prst="rect">
+            <a:avLst/>
+          </a:prstGeom>
+          <a:noFill xmlns:a="http://schemas.openxmlformats.org/drawingml/2006/main"/>
+          <a:ln xmlns:a="http://schemas.openxmlformats.org/drawingml/2006/main" w="0">
+            <a:noFill/>
+          </a:ln>
+        </p:spPr>
+        <p:txBody>
+          <a:bodyPr xmlns:a="http://schemas.openxmlformats.org/drawingml/2006/main" wrap="square" lIns="0" tIns="0" rIns="0" bIns="0">
+            <a:noAutofit/>
+          </a:bodyPr>
+          <a:lstStyle xmlns:a="http://schemas.openxmlformats.org/drawingml/2006/main"/>
+          <a:p xmlns:a="http://schemas.openxmlformats.org/drawingml/2006/main">
+            <a:pPr>
+              <a:defRPr sz="2100" b="1">
+                <a:solidFill>
+                  <a:srgbClr val="14283F"/>
+                </a:solidFill>
+                <a:latin typeface="Arial"/>
+                <a:ea typeface="Arial"/>
+                <a:cs typeface="Arial"/>
+              </a:defRPr>
+            </a:pPr>
+            <a:r>
+              <a:rPr sz="2100" b="1">
+                <a:solidFill>
+                  <a:srgbClr val="14283F"/>
+                </a:solidFill>
+                <a:latin typeface="Arial"/>
+                <a:ea typeface="Arial"/>
+                <a:cs typeface="Arial"/>
+              </a:rPr>
+              <a:t>R$ 185.199.026,38</a:t>
+            </a:r>
+          </a:p>
+        </p:txBody>
+      </p:sp>
+      <p:sp>
+        <p:nvSpPr>
+          <p:cNvPr id="21" name="">
+            <a:extLst xmlns:a="http://schemas.openxmlformats.org/drawingml/2006/main">
+              <a:ext uri="{FF2B5EF4-FFF2-40B4-BE49-F238E27FC236}">
+                <a16:creationId xmlns:a16="http://schemas.microsoft.com/office/drawing/2014/main" id="{368F442C-4352-4A25-8C26-4ADF35A306CA}"/>
+              </a:ext>
+            </a:extLst>
+          </p:cNvPr>
+          <p:cNvSpPr>
+            <a:spLocks xmlns:a="http://schemas.openxmlformats.org/drawingml/2006/main" noGrp="1"/>
+          </p:cNvSpPr>
+          <p:nvPr/>
+        </p:nvSpPr>
+        <p:spPr>
+          <a:xfrm xmlns:a="http://schemas.openxmlformats.org/drawingml/2006/main">
+            <a:off x="8020050" y="3838575"/>
+            <a:ext cx="3524250" cy="1000125"/>
+          </a:xfrm>
+          <a:prstGeom xmlns:a="http://schemas.openxmlformats.org/drawingml/2006/main" prst="rect">
+            <a:avLst/>
+          </a:prstGeom>
+          <a:noFill xmlns:a="http://schemas.openxmlformats.org/drawingml/2006/main"/>
+          <a:ln xmlns:a="http://schemas.openxmlformats.org/drawingml/2006/main" w="0">
+            <a:noFill/>
+          </a:ln>
+        </p:spPr>
+        <p:txBody>
+          <a:bodyPr xmlns:a="http://schemas.openxmlformats.org/drawingml/2006/main" wrap="square" lIns="0" tIns="0" rIns="0" bIns="0">
+            <a:noAutofit/>
+          </a:bodyPr>
+          <a:lstStyle xmlns:a="http://schemas.openxmlformats.org/drawingml/2006/main"/>
+          <a:p xmlns:a="http://schemas.openxmlformats.org/drawingml/2006/main">
+            <a:pPr>
+              <a:defRPr sz="1800" b="0">
+                <a:solidFill>
+                  <a:srgbClr val="5D6D82"/>
+                </a:solidFill>
+                <a:latin typeface="Arial"/>
+                <a:ea typeface="Arial"/>
+                <a:cs typeface="Arial"/>
+              </a:defRPr>
+            </a:pPr>
+            <a:r>
+              <a:rPr sz="1800" b="0">
+                <a:solidFill>
+                  <a:srgbClr val="5D6D82"/>
+                </a:solidFill>
+                <a:latin typeface="Arial"/>
+                <a:ea typeface="Arial"/>
+                <a:cs typeface="Arial"/>
+              </a:rPr>
+              <a:t>Abrir filtros permite escolher mês e unidade. Fechar filtros recolhe os controles.</a:t>
+            </a:r>
+          </a:p>
+        </p:txBody>
+      </p:sp>
+      <p:sp>
+        <p:nvSpPr>
+          <p:cNvPr id="22" name="">
+            <a:extLst xmlns:a="http://schemas.openxmlformats.org/drawingml/2006/main">
+              <a:ext uri="{FF2B5EF4-FFF2-40B4-BE49-F238E27FC236}">
+                <a16:creationId xmlns:a16="http://schemas.microsoft.com/office/drawing/2014/main" id="{2D95EAE1-AE54-42FA-829F-CF548B89287A}"/>
+              </a:ext>
+            </a:extLst>
+          </p:cNvPr>
+          <p:cNvSpPr>
+            <a:spLocks xmlns:a="http://schemas.openxmlformats.org/drawingml/2006/main" noGrp="1"/>
+          </p:cNvSpPr>
+          <p:nvPr/>
+        </p:nvSpPr>
+        <p:spPr>
+          <a:xfrm xmlns:a="http://schemas.openxmlformats.org/drawingml/2006/main">
+            <a:off x="8020050" y="5153025"/>
+            <a:ext cx="3524250" cy="800100"/>
           </a:xfrm>
           <a:prstGeom xmlns:a="http://schemas.openxmlformats.org/drawingml/2006/main" prst="rect">
             <a:avLst/>
@@ -7063,7 +7758,7 @@
             <a:pPr>
               <a:defRPr sz="1875" b="0">
                 <a:solidFill>
-                  <a:srgbClr val="14283F"/>
+                  <a:srgbClr val="5D6D82"/>
                 </a:solidFill>
                 <a:latin typeface="Arial"/>
                 <a:ea typeface="Arial"/>
@@ -7073,445 +7768,23 @@
             <a:r>
               <a:rPr sz="1875" b="0">
                 <a:solidFill>
-                  <a:srgbClr val="14283F"/>
-                </a:solidFill>
-                <a:latin typeface="Arial"/>
-                <a:ea typeface="Arial"/>
-                <a:cs typeface="Arial"/>
-              </a:rPr>
-              <a:t>Saúde em dezembro</a:t>
-            </a:r>
-          </a:p>
-        </p:txBody>
-      </p:sp>
-      <p:sp>
-        <p:nvSpPr>
-          <p:cNvPr id="10" name="">
-            <a:extLst xmlns:a="http://schemas.openxmlformats.org/drawingml/2006/main">
-              <a:ext uri="{FF2B5EF4-FFF2-40B4-BE49-F238E27FC236}">
-                <a16:creationId xmlns:a16="http://schemas.microsoft.com/office/drawing/2014/main" id="{B6C77E41-3628-4CD8-8896-F83489C9083D}"/>
-              </a:ext>
-            </a:extLst>
-          </p:cNvPr>
-          <p:cNvSpPr>
-            <a:spLocks xmlns:a="http://schemas.openxmlformats.org/drawingml/2006/main" noGrp="1"/>
-          </p:cNvSpPr>
-          <p:nvPr/>
-        </p:nvSpPr>
-        <p:spPr>
-          <a:xfrm xmlns:a="http://schemas.openxmlformats.org/drawingml/2006/main">
-            <a:off x="8858250" y="2819400"/>
-            <a:ext cx="619125" cy="342900"/>
-          </a:xfrm>
-          <a:prstGeom xmlns:a="http://schemas.openxmlformats.org/drawingml/2006/main" prst="rect">
-            <a:avLst/>
-          </a:prstGeom>
-          <a:noFill xmlns:a="http://schemas.openxmlformats.org/drawingml/2006/main"/>
-          <a:ln xmlns:a="http://schemas.openxmlformats.org/drawingml/2006/main" w="0">
-            <a:noFill/>
-          </a:ln>
-        </p:spPr>
-        <p:txBody>
-          <a:bodyPr xmlns:a="http://schemas.openxmlformats.org/drawingml/2006/main" wrap="square" lIns="0" tIns="0" rIns="0" bIns="0">
-            <a:noAutofit/>
-          </a:bodyPr>
-          <a:lstStyle xmlns:a="http://schemas.openxmlformats.org/drawingml/2006/main"/>
-          <a:p xmlns:a="http://schemas.openxmlformats.org/drawingml/2006/main">
-            <a:pPr>
-              <a:defRPr sz="1800" b="1">
-                <a:solidFill>
-                  <a:srgbClr val="2563EB"/>
-                </a:solidFill>
-                <a:latin typeface="Arial"/>
-                <a:ea typeface="Arial"/>
-                <a:cs typeface="Arial"/>
-              </a:defRPr>
-            </a:pPr>
-            <a:r>
-              <a:rPr sz="1800" b="1">
-                <a:solidFill>
-                  <a:srgbClr val="2563EB"/>
-                </a:solidFill>
-                <a:latin typeface="Arial"/>
-                <a:ea typeface="Arial"/>
-                <a:cs typeface="Arial"/>
-              </a:rPr>
-              <a:t>02</a:t>
-            </a:r>
-          </a:p>
-        </p:txBody>
-      </p:sp>
-      <p:sp>
-        <p:nvSpPr>
-          <p:cNvPr id="11" name="">
-            <a:extLst xmlns:a="http://schemas.openxmlformats.org/drawingml/2006/main">
-              <a:ext uri="{FF2B5EF4-FFF2-40B4-BE49-F238E27FC236}">
-                <a16:creationId xmlns:a16="http://schemas.microsoft.com/office/drawing/2014/main" id="{12F74A48-BEFD-4FE5-AB02-042F88DB17BE}"/>
-              </a:ext>
-            </a:extLst>
-          </p:cNvPr>
-          <p:cNvSpPr>
-            <a:spLocks xmlns:a="http://schemas.openxmlformats.org/drawingml/2006/main" noGrp="1"/>
-          </p:cNvSpPr>
-          <p:nvPr/>
-        </p:nvSpPr>
-        <p:spPr>
-          <a:xfrm xmlns:a="http://schemas.openxmlformats.org/drawingml/2006/main">
-            <a:off x="9458325" y="2819400"/>
-            <a:ext cx="2095500" cy="638175"/>
-          </a:xfrm>
-          <a:prstGeom xmlns:a="http://schemas.openxmlformats.org/drawingml/2006/main" prst="rect">
-            <a:avLst/>
-          </a:prstGeom>
-          <a:noFill xmlns:a="http://schemas.openxmlformats.org/drawingml/2006/main"/>
-          <a:ln xmlns:a="http://schemas.openxmlformats.org/drawingml/2006/main" w="0">
-            <a:noFill/>
-          </a:ln>
-        </p:spPr>
-        <p:txBody>
-          <a:bodyPr xmlns:a="http://schemas.openxmlformats.org/drawingml/2006/main" wrap="square" lIns="0" tIns="0" rIns="0" bIns="0">
-            <a:noAutofit/>
-          </a:bodyPr>
-          <a:lstStyle xmlns:a="http://schemas.openxmlformats.org/drawingml/2006/main"/>
-          <a:p xmlns:a="http://schemas.openxmlformats.org/drawingml/2006/main">
-            <a:pPr>
-              <a:defRPr sz="1875" b="0">
-                <a:solidFill>
-                  <a:srgbClr val="14283F"/>
-                </a:solidFill>
-                <a:latin typeface="Arial"/>
-                <a:ea typeface="Arial"/>
-                <a:cs typeface="Arial"/>
-              </a:defRPr>
-            </a:pPr>
-            <a:r>
-              <a:rPr sz="1875" b="0">
-                <a:solidFill>
-                  <a:srgbClr val="14283F"/>
-                </a:solidFill>
-                <a:latin typeface="Arial"/>
-                <a:ea typeface="Arial"/>
-                <a:cs typeface="Arial"/>
-              </a:rPr>
-              <a:t>Arquivo e linha de origem</a:t>
-            </a:r>
-          </a:p>
-        </p:txBody>
-      </p:sp>
-      <p:sp>
-        <p:nvSpPr>
-          <p:cNvPr id="12" name="">
-            <a:extLst xmlns:a="http://schemas.openxmlformats.org/drawingml/2006/main">
-              <a:ext uri="{FF2B5EF4-FFF2-40B4-BE49-F238E27FC236}">
-                <a16:creationId xmlns:a16="http://schemas.microsoft.com/office/drawing/2014/main" id="{ED93305F-C71C-4B28-AAB4-819816462E98}"/>
-              </a:ext>
-            </a:extLst>
-          </p:cNvPr>
-          <p:cNvSpPr>
-            <a:spLocks xmlns:a="http://schemas.openxmlformats.org/drawingml/2006/main" noGrp="1"/>
-          </p:cNvSpPr>
-          <p:nvPr/>
-        </p:nvSpPr>
-        <p:spPr>
-          <a:xfrm xmlns:a="http://schemas.openxmlformats.org/drawingml/2006/main">
-            <a:off x="8858250" y="3648075"/>
-            <a:ext cx="619125" cy="342900"/>
-          </a:xfrm>
-          <a:prstGeom xmlns:a="http://schemas.openxmlformats.org/drawingml/2006/main" prst="rect">
-            <a:avLst/>
-          </a:prstGeom>
-          <a:noFill xmlns:a="http://schemas.openxmlformats.org/drawingml/2006/main"/>
-          <a:ln xmlns:a="http://schemas.openxmlformats.org/drawingml/2006/main" w="0">
-            <a:noFill/>
-          </a:ln>
-        </p:spPr>
-        <p:txBody>
-          <a:bodyPr xmlns:a="http://schemas.openxmlformats.org/drawingml/2006/main" wrap="square" lIns="0" tIns="0" rIns="0" bIns="0">
-            <a:noAutofit/>
-          </a:bodyPr>
-          <a:lstStyle xmlns:a="http://schemas.openxmlformats.org/drawingml/2006/main"/>
-          <a:p xmlns:a="http://schemas.openxmlformats.org/drawingml/2006/main">
-            <a:pPr>
-              <a:defRPr sz="1800" b="1">
-                <a:solidFill>
-                  <a:srgbClr val="2563EB"/>
-                </a:solidFill>
-                <a:latin typeface="Arial"/>
-                <a:ea typeface="Arial"/>
-                <a:cs typeface="Arial"/>
-              </a:defRPr>
-            </a:pPr>
-            <a:r>
-              <a:rPr sz="1800" b="1">
-                <a:solidFill>
-                  <a:srgbClr val="2563EB"/>
-                </a:solidFill>
-                <a:latin typeface="Arial"/>
-                <a:ea typeface="Arial"/>
-                <a:cs typeface="Arial"/>
-              </a:rPr>
-              <a:t>03</a:t>
-            </a:r>
-          </a:p>
-        </p:txBody>
-      </p:sp>
-      <p:sp>
-        <p:nvSpPr>
-          <p:cNvPr id="13" name="">
-            <a:extLst xmlns:a="http://schemas.openxmlformats.org/drawingml/2006/main">
-              <a:ext uri="{FF2B5EF4-FFF2-40B4-BE49-F238E27FC236}">
-                <a16:creationId xmlns:a16="http://schemas.microsoft.com/office/drawing/2014/main" id="{2381FDB7-9722-4463-A0FC-6340915D8C17}"/>
-              </a:ext>
-            </a:extLst>
-          </p:cNvPr>
-          <p:cNvSpPr>
-            <a:spLocks xmlns:a="http://schemas.openxmlformats.org/drawingml/2006/main" noGrp="1"/>
-          </p:cNvSpPr>
-          <p:nvPr/>
-        </p:nvSpPr>
-        <p:spPr>
-          <a:xfrm xmlns:a="http://schemas.openxmlformats.org/drawingml/2006/main">
-            <a:off x="9458325" y="3648075"/>
-            <a:ext cx="2095500" cy="638175"/>
-          </a:xfrm>
-          <a:prstGeom xmlns:a="http://schemas.openxmlformats.org/drawingml/2006/main" prst="rect">
-            <a:avLst/>
-          </a:prstGeom>
-          <a:noFill xmlns:a="http://schemas.openxmlformats.org/drawingml/2006/main"/>
-          <a:ln xmlns:a="http://schemas.openxmlformats.org/drawingml/2006/main" w="0">
-            <a:noFill/>
-          </a:ln>
-        </p:spPr>
-        <p:txBody>
-          <a:bodyPr xmlns:a="http://schemas.openxmlformats.org/drawingml/2006/main" wrap="square" lIns="0" tIns="0" rIns="0" bIns="0">
-            <a:noAutofit/>
-          </a:bodyPr>
-          <a:lstStyle xmlns:a="http://schemas.openxmlformats.org/drawingml/2006/main"/>
-          <a:p xmlns:a="http://schemas.openxmlformats.org/drawingml/2006/main">
-            <a:pPr>
-              <a:defRPr sz="1875" b="0">
-                <a:solidFill>
-                  <a:srgbClr val="14283F"/>
-                </a:solidFill>
-                <a:latin typeface="Arial"/>
-                <a:ea typeface="Arial"/>
-                <a:cs typeface="Arial"/>
-              </a:defRPr>
-            </a:pPr>
-            <a:r>
-              <a:rPr sz="1875" b="0">
-                <a:solidFill>
-                  <a:srgbClr val="14283F"/>
-                </a:solidFill>
-                <a:latin typeface="Arial"/>
-                <a:ea typeface="Arial"/>
-                <a:cs typeface="Arial"/>
-              </a:rPr>
-              <a:t>Exportação do recorte</a:t>
-            </a:r>
-          </a:p>
-        </p:txBody>
-      </p:sp>
-      <p:sp>
-        <p:nvSpPr>
-          <p:cNvPr id="14" name="">
-            <a:extLst xmlns:a="http://schemas.openxmlformats.org/drawingml/2006/main">
-              <a:ext uri="{FF2B5EF4-FFF2-40B4-BE49-F238E27FC236}">
-                <a16:creationId xmlns:a16="http://schemas.microsoft.com/office/drawing/2014/main" id="{82C73CDA-CB89-47A3-95F4-3FFDEE390EB0}"/>
-              </a:ext>
-            </a:extLst>
-          </p:cNvPr>
-          <p:cNvSpPr>
-            <a:spLocks xmlns:a="http://schemas.openxmlformats.org/drawingml/2006/main" noGrp="1"/>
-          </p:cNvSpPr>
-          <p:nvPr/>
-        </p:nvSpPr>
-        <p:spPr>
-          <a:xfrm xmlns:a="http://schemas.openxmlformats.org/drawingml/2006/main">
-            <a:off x="8858250" y="4476750"/>
-            <a:ext cx="619125" cy="342900"/>
-          </a:xfrm>
-          <a:prstGeom xmlns:a="http://schemas.openxmlformats.org/drawingml/2006/main" prst="rect">
-            <a:avLst/>
-          </a:prstGeom>
-          <a:noFill xmlns:a="http://schemas.openxmlformats.org/drawingml/2006/main"/>
-          <a:ln xmlns:a="http://schemas.openxmlformats.org/drawingml/2006/main" w="0">
-            <a:noFill/>
-          </a:ln>
-        </p:spPr>
-        <p:txBody>
-          <a:bodyPr xmlns:a="http://schemas.openxmlformats.org/drawingml/2006/main" wrap="square" lIns="0" tIns="0" rIns="0" bIns="0">
-            <a:noAutofit/>
-          </a:bodyPr>
-          <a:lstStyle xmlns:a="http://schemas.openxmlformats.org/drawingml/2006/main"/>
-          <a:p xmlns:a="http://schemas.openxmlformats.org/drawingml/2006/main">
-            <a:pPr>
-              <a:defRPr sz="1800" b="1">
-                <a:solidFill>
-                  <a:srgbClr val="2563EB"/>
-                </a:solidFill>
-                <a:latin typeface="Arial"/>
-                <a:ea typeface="Arial"/>
-                <a:cs typeface="Arial"/>
-              </a:defRPr>
-            </a:pPr>
-            <a:r>
-              <a:rPr sz="1800" b="1">
-                <a:solidFill>
-                  <a:srgbClr val="2563EB"/>
-                </a:solidFill>
-                <a:latin typeface="Arial"/>
-                <a:ea typeface="Arial"/>
-                <a:cs typeface="Arial"/>
-              </a:rPr>
-              <a:t>04</a:t>
-            </a:r>
-          </a:p>
-        </p:txBody>
-      </p:sp>
-      <p:sp>
-        <p:nvSpPr>
-          <p:cNvPr id="15" name="">
-            <a:extLst xmlns:a="http://schemas.openxmlformats.org/drawingml/2006/main">
-              <a:ext uri="{FF2B5EF4-FFF2-40B4-BE49-F238E27FC236}">
-                <a16:creationId xmlns:a16="http://schemas.microsoft.com/office/drawing/2014/main" id="{96849F96-84D6-4EFA-8E98-25B02499879F}"/>
-              </a:ext>
-            </a:extLst>
-          </p:cNvPr>
-          <p:cNvSpPr>
-            <a:spLocks xmlns:a="http://schemas.openxmlformats.org/drawingml/2006/main" noGrp="1"/>
-          </p:cNvSpPr>
-          <p:nvPr/>
-        </p:nvSpPr>
-        <p:spPr>
-          <a:xfrm xmlns:a="http://schemas.openxmlformats.org/drawingml/2006/main">
-            <a:off x="9458325" y="4476750"/>
-            <a:ext cx="2095500" cy="638175"/>
-          </a:xfrm>
-          <a:prstGeom xmlns:a="http://schemas.openxmlformats.org/drawingml/2006/main" prst="rect">
-            <a:avLst/>
-          </a:prstGeom>
-          <a:noFill xmlns:a="http://schemas.openxmlformats.org/drawingml/2006/main"/>
-          <a:ln xmlns:a="http://schemas.openxmlformats.org/drawingml/2006/main" w="0">
-            <a:noFill/>
-          </a:ln>
-        </p:spPr>
-        <p:txBody>
-          <a:bodyPr xmlns:a="http://schemas.openxmlformats.org/drawingml/2006/main" wrap="square" lIns="0" tIns="0" rIns="0" bIns="0">
-            <a:noAutofit/>
-          </a:bodyPr>
-          <a:lstStyle xmlns:a="http://schemas.openxmlformats.org/drawingml/2006/main"/>
-          <a:p xmlns:a="http://schemas.openxmlformats.org/drawingml/2006/main">
-            <a:pPr>
-              <a:defRPr sz="1875" b="0">
-                <a:solidFill>
-                  <a:srgbClr val="14283F"/>
-                </a:solidFill>
-                <a:latin typeface="Arial"/>
-                <a:ea typeface="Arial"/>
-                <a:cs typeface="Arial"/>
-              </a:defRPr>
-            </a:pPr>
-            <a:r>
-              <a:rPr sz="1875" b="0">
-                <a:solidFill>
-                  <a:srgbClr val="14283F"/>
-                </a:solidFill>
-                <a:latin typeface="Arial"/>
-                <a:ea typeface="Arial"/>
-                <a:cs typeface="Arial"/>
-              </a:rPr>
-              <a:t>Polícia Penal em janeiro</a:t>
-            </a:r>
-          </a:p>
-        </p:txBody>
-      </p:sp>
-      <p:sp>
-        <p:nvSpPr>
-          <p:cNvPr id="16" name="">
-            <a:extLst xmlns:a="http://schemas.openxmlformats.org/drawingml/2006/main">
-              <a:ext uri="{FF2B5EF4-FFF2-40B4-BE49-F238E27FC236}">
-                <a16:creationId xmlns:a16="http://schemas.microsoft.com/office/drawing/2014/main" id="{5A6BF6AC-CB6B-40FD-92CA-DBCEBFDF3827}"/>
-              </a:ext>
-            </a:extLst>
-          </p:cNvPr>
-          <p:cNvSpPr>
-            <a:spLocks xmlns:a="http://schemas.openxmlformats.org/drawingml/2006/main" noGrp="1"/>
-          </p:cNvSpPr>
-          <p:nvPr/>
-        </p:nvSpPr>
-        <p:spPr>
-          <a:xfrm xmlns:a="http://schemas.openxmlformats.org/drawingml/2006/main">
-            <a:off x="8858250" y="5381625"/>
-            <a:ext cx="2686050" cy="752475"/>
-          </a:xfrm>
-          <a:prstGeom xmlns:a="http://schemas.openxmlformats.org/drawingml/2006/main" prst="rect">
-            <a:avLst/>
-          </a:prstGeom>
-          <a:noFill xmlns:a="http://schemas.openxmlformats.org/drawingml/2006/main"/>
-          <a:ln xmlns:a="http://schemas.openxmlformats.org/drawingml/2006/main" w="0">
-            <a:noFill/>
-          </a:ln>
-        </p:spPr>
-        <p:txBody>
-          <a:bodyPr xmlns:a="http://schemas.openxmlformats.org/drawingml/2006/main" wrap="square" lIns="0" tIns="0" rIns="0" bIns="0">
-            <a:noAutofit/>
-          </a:bodyPr>
-          <a:lstStyle xmlns:a="http://schemas.openxmlformats.org/drawingml/2006/main"/>
-          <a:p xmlns:a="http://schemas.openxmlformats.org/drawingml/2006/main">
-            <a:pPr>
-              <a:defRPr sz="1725" b="0">
-                <a:solidFill>
                   <a:srgbClr val="5D6D82"/>
                 </a:solidFill>
                 <a:latin typeface="Arial"/>
                 <a:ea typeface="Arial"/>
                 <a:cs typeface="Arial"/>
-              </a:defRPr>
-            </a:pPr>
-            <a:r>
-              <a:rPr sz="1725" b="0">
-                <a:solidFill>
-                  <a:srgbClr val="5D6D82"/>
-                </a:solidFill>
-                <a:latin typeface="Arial"/>
-                <a:ea typeface="Arial"/>
-                <a:cs typeface="Arial"/>
-              </a:rPr>
-              <a:t>Sem registros é diferente</a:t>
-            </a:r>
-          </a:p>
-          <a:p xmlns:a="http://schemas.openxmlformats.org/drawingml/2006/main">
-            <a:pPr>
-              <a:defRPr sz="1725" b="0">
-                <a:solidFill>
-                  <a:srgbClr val="5D6D82"/>
-                </a:solidFill>
-                <a:latin typeface="Arial"/>
-                <a:ea typeface="Arial"/>
-                <a:cs typeface="Arial"/>
-              </a:defRPr>
-            </a:pPr>
-            <a:r>
-              <a:rPr sz="1725" b="0">
-                <a:solidFill>
-                  <a:srgbClr val="5D6D82"/>
-                </a:solidFill>
-                <a:latin typeface="Arial"/>
-                <a:ea typeface="Arial"/>
-                <a:cs typeface="Arial"/>
-              </a:rPr>
-              <a:t>de soma igual a zero.</a:t>
-            </a:r>
-          </a:p>
-        </p:txBody>
-      </p:sp>
-      <p:sp>
-        <p:nvSpPr>
-          <p:cNvPr id="17" name="">
-            <a:extLst xmlns:a="http://schemas.openxmlformats.org/drawingml/2006/main">
-              <a:ext uri="{FF2B5EF4-FFF2-40B4-BE49-F238E27FC236}">
-                <a16:creationId xmlns:a16="http://schemas.microsoft.com/office/drawing/2014/main" id="{ADDAAA82-72B5-41F7-89DB-E7CBBB82ECDD}"/>
+              </a:rPr>
+              <a:t>Polícia Penal em janeiro: zero registros.</a:t>
+            </a:r>
+          </a:p>
+        </p:txBody>
+      </p:sp>
+      <p:sp>
+        <p:nvSpPr>
+          <p:cNvPr id="23" name="">
+            <a:extLst xmlns:a="http://schemas.openxmlformats.org/drawingml/2006/main">
+              <a:ext uri="{FF2B5EF4-FFF2-40B4-BE49-F238E27FC236}">
+                <a16:creationId xmlns:a16="http://schemas.microsoft.com/office/drawing/2014/main" id="{169A85DC-7107-4A13-901C-7775B2EC236D}"/>
               </a:ext>
             </a:extLst>
           </p:cNvPr>
@@ -7558,7 +7831,7 @@
                 <a:ea typeface="Arial"/>
                 <a:cs typeface="Arial"/>
               </a:rPr>
-              <a:t>Python e SQLite locais. Interface HTML/CSS/JavaScript. Base pronta para uso offline.</a:t>
+              <a:t>A troca de tela preserva o recorte e não repete a consulta ao banco.</a:t>
             </a:r>
           </a:p>
         </p:txBody>
@@ -7566,7 +7839,7 @@
     </p:spTree>
     <p:extLst>
       <p:ext uri="{BB962C8B-B14F-4D97-AF65-F5344CB8AC3E}">
-        <p14:creationId xmlns:p14="http://schemas.microsoft.com/office/powerpoint/2010/main" val="5604765"/>
+        <p14:creationId xmlns:p14="http://schemas.microsoft.com/office/powerpoint/2010/main" val="1464253911"/>
       </p:ext>
     </p:extLst>
   </p:cSld>
@@ -7597,7 +7870,7 @@
           <p:cNvPr id="38" name="">
             <a:extLst xmlns:a="http://schemas.openxmlformats.org/drawingml/2006/main">
               <a:ext uri="{FF2B5EF4-FFF2-40B4-BE49-F238E27FC236}">
-                <a16:creationId xmlns:a16="http://schemas.microsoft.com/office/drawing/2014/main" id="{BDCDB78D-3DE3-40D1-BC24-73C086580724}"/>
+                <a16:creationId xmlns:a16="http://schemas.microsoft.com/office/drawing/2014/main" id="{8D9AEE53-DF93-4DF7-8359-37CC63D492F5}"/>
               </a:ext>
             </a:extLst>
           </p:cNvPr>
@@ -7654,7 +7927,7 @@
           <p:cNvPr id="2" name="">
             <a:extLst xmlns:a="http://schemas.openxmlformats.org/drawingml/2006/main">
               <a:ext uri="{FF2B5EF4-FFF2-40B4-BE49-F238E27FC236}">
-                <a16:creationId xmlns:a16="http://schemas.microsoft.com/office/drawing/2014/main" id="{9D523D35-88B5-4F86-A408-E007F33DFC40}"/>
+                <a16:creationId xmlns:a16="http://schemas.microsoft.com/office/drawing/2014/main" id="{C994868B-A14F-4883-B09E-C97792A450A0}"/>
               </a:ext>
             </a:extLst>
           </p:cNvPr>
@@ -7711,7 +7984,7 @@
           <p:cNvPr id="3" name="">
             <a:extLst xmlns:a="http://schemas.openxmlformats.org/drawingml/2006/main">
               <a:ext uri="{FF2B5EF4-FFF2-40B4-BE49-F238E27FC236}">
-                <a16:creationId xmlns:a16="http://schemas.microsoft.com/office/drawing/2014/main" id="{77461EBF-2C41-4142-AFFE-521137E5DC62}"/>
+                <a16:creationId xmlns:a16="http://schemas.microsoft.com/office/drawing/2014/main" id="{F0388D3D-A9A8-4A1A-AF5F-5E07DFF89946}"/>
               </a:ext>
             </a:extLst>
           </p:cNvPr>
@@ -7768,7 +8041,7 @@
           <p:cNvPr id="4" name="">
             <a:extLst xmlns:a="http://schemas.openxmlformats.org/drawingml/2006/main">
               <a:ext uri="{FF2B5EF4-FFF2-40B4-BE49-F238E27FC236}">
-                <a16:creationId xmlns:a16="http://schemas.microsoft.com/office/drawing/2014/main" id="{B4742484-04F7-4CD2-8098-EF672080955A}"/>
+                <a16:creationId xmlns:a16="http://schemas.microsoft.com/office/drawing/2014/main" id="{DE193D42-8E86-421E-8C52-7D352490E2BA}"/>
               </a:ext>
             </a:extLst>
           </p:cNvPr>
@@ -7798,7 +8071,7 @@
           <p:cNvPr id="5" name="">
             <a:extLst xmlns:a="http://schemas.openxmlformats.org/drawingml/2006/main">
               <a:ext uri="{FF2B5EF4-FFF2-40B4-BE49-F238E27FC236}">
-                <a16:creationId xmlns:a16="http://schemas.microsoft.com/office/drawing/2014/main" id="{05700541-BB0C-4682-A4EC-1E7C26FE26E9}"/>
+                <a16:creationId xmlns:a16="http://schemas.microsoft.com/office/drawing/2014/main" id="{4EE9B3C2-3578-40B7-968E-E1A739E7AE5A}"/>
               </a:ext>
             </a:extLst>
           </p:cNvPr>
@@ -7855,7 +8128,7 @@
           <p:cNvPr id="6" name="">
             <a:extLst xmlns:a="http://schemas.openxmlformats.org/drawingml/2006/main">
               <a:ext uri="{FF2B5EF4-FFF2-40B4-BE49-F238E27FC236}">
-                <a16:creationId xmlns:a16="http://schemas.microsoft.com/office/drawing/2014/main" id="{CBE16CE9-3557-4DE0-83BA-20CFA15D8B7F}"/>
+                <a16:creationId xmlns:a16="http://schemas.microsoft.com/office/drawing/2014/main" id="{3A816541-D058-439C-9F15-66035B6F52F3}"/>
               </a:ext>
             </a:extLst>
           </p:cNvPr>
@@ -7935,7 +8208,7 @@
           <p:cNvPr id="7" name="">
             <a:extLst xmlns:a="http://schemas.openxmlformats.org/drawingml/2006/main">
               <a:ext uri="{FF2B5EF4-FFF2-40B4-BE49-F238E27FC236}">
-                <a16:creationId xmlns:a16="http://schemas.microsoft.com/office/drawing/2014/main" id="{B53E242F-17AF-45FA-B204-9F24BCDCEAB8}"/>
+                <a16:creationId xmlns:a16="http://schemas.microsoft.com/office/drawing/2014/main" id="{F01BB1B7-A304-4AF7-A6FB-77C474020410}"/>
               </a:ext>
             </a:extLst>
           </p:cNvPr>
@@ -7992,7 +8265,7 @@
           <p:cNvPr id="8" name="">
             <a:extLst xmlns:a="http://schemas.openxmlformats.org/drawingml/2006/main">
               <a:ext uri="{FF2B5EF4-FFF2-40B4-BE49-F238E27FC236}">
-                <a16:creationId xmlns:a16="http://schemas.microsoft.com/office/drawing/2014/main" id="{7BBF20B6-DD86-417C-BE38-EF351478F9F0}"/>
+                <a16:creationId xmlns:a16="http://schemas.microsoft.com/office/drawing/2014/main" id="{DAFBA49E-43F4-4591-AFFC-432E0FEA2DF6}"/>
               </a:ext>
             </a:extLst>
           </p:cNvPr>
@@ -8049,7 +8322,7 @@
           <p:cNvPr id="9" name="">
             <a:extLst xmlns:a="http://schemas.openxmlformats.org/drawingml/2006/main">
               <a:ext uri="{FF2B5EF4-FFF2-40B4-BE49-F238E27FC236}">
-                <a16:creationId xmlns:a16="http://schemas.microsoft.com/office/drawing/2014/main" id="{411B30FB-3007-4A64-8159-2B02AC97E53D}"/>
+                <a16:creationId xmlns:a16="http://schemas.microsoft.com/office/drawing/2014/main" id="{1B3A18E6-9989-4D41-9B2C-D12DDFE8DE30}"/>
               </a:ext>
             </a:extLst>
           </p:cNvPr>
@@ -8129,7 +8402,7 @@
           <p:cNvPr id="10" name="">
             <a:extLst xmlns:a="http://schemas.openxmlformats.org/drawingml/2006/main">
               <a:ext uri="{FF2B5EF4-FFF2-40B4-BE49-F238E27FC236}">
-                <a16:creationId xmlns:a16="http://schemas.microsoft.com/office/drawing/2014/main" id="{1D9F71F7-3987-4CEC-8502-4ACB894FF0BB}"/>
+                <a16:creationId xmlns:a16="http://schemas.microsoft.com/office/drawing/2014/main" id="{88EA6312-424E-47BA-AEDE-3C52DC71F34A}"/>
               </a:ext>
             </a:extLst>
           </p:cNvPr>
@@ -8186,7 +8459,7 @@
           <p:cNvPr id="11" name="">
             <a:extLst xmlns:a="http://schemas.openxmlformats.org/drawingml/2006/main">
               <a:ext uri="{FF2B5EF4-FFF2-40B4-BE49-F238E27FC236}">
-                <a16:creationId xmlns:a16="http://schemas.microsoft.com/office/drawing/2014/main" id="{A3D30239-02C9-49A8-B1FC-9FE6D1106D12}"/>
+                <a16:creationId xmlns:a16="http://schemas.microsoft.com/office/drawing/2014/main" id="{413F4577-DB48-46F0-B7F5-FE268FB852DC}"/>
               </a:ext>
             </a:extLst>
           </p:cNvPr>
@@ -8243,7 +8516,7 @@
           <p:cNvPr id="12" name="">
             <a:extLst xmlns:a="http://schemas.openxmlformats.org/drawingml/2006/main">
               <a:ext uri="{FF2B5EF4-FFF2-40B4-BE49-F238E27FC236}">
-                <a16:creationId xmlns:a16="http://schemas.microsoft.com/office/drawing/2014/main" id="{94E0CDB4-7ADF-419B-A648-313BDD21A910}"/>
+                <a16:creationId xmlns:a16="http://schemas.microsoft.com/office/drawing/2014/main" id="{DE4C944E-93D0-49BC-AE08-3151C43E0151}"/>
               </a:ext>
             </a:extLst>
           </p:cNvPr>
@@ -8323,7 +8596,7 @@
           <p:cNvPr id="13" name="">
             <a:extLst xmlns:a="http://schemas.openxmlformats.org/drawingml/2006/main">
               <a:ext uri="{FF2B5EF4-FFF2-40B4-BE49-F238E27FC236}">
-                <a16:creationId xmlns:a16="http://schemas.microsoft.com/office/drawing/2014/main" id="{01977972-5566-4E52-ABB3-5264F8267A5D}"/>
+                <a16:creationId xmlns:a16="http://schemas.microsoft.com/office/drawing/2014/main" id="{B7ABAD4F-66AB-4A9C-A2AF-5798AFA3EBCF}"/>
               </a:ext>
             </a:extLst>
           </p:cNvPr>
@@ -8380,7 +8653,7 @@
           <p:cNvPr id="14" name="">
             <a:extLst xmlns:a="http://schemas.openxmlformats.org/drawingml/2006/main">
               <a:ext uri="{FF2B5EF4-FFF2-40B4-BE49-F238E27FC236}">
-                <a16:creationId xmlns:a16="http://schemas.microsoft.com/office/drawing/2014/main" id="{74A8BB70-35BD-4F7F-899A-170137530BC2}"/>
+                <a16:creationId xmlns:a16="http://schemas.microsoft.com/office/drawing/2014/main" id="{F6E0CCE9-5062-4FC5-B63E-93AB19E482A4}"/>
               </a:ext>
             </a:extLst>
           </p:cNvPr>
@@ -8437,7 +8710,7 @@
           <p:cNvPr id="15" name="">
             <a:extLst xmlns:a="http://schemas.openxmlformats.org/drawingml/2006/main">
               <a:ext uri="{FF2B5EF4-FFF2-40B4-BE49-F238E27FC236}">
-                <a16:creationId xmlns:a16="http://schemas.microsoft.com/office/drawing/2014/main" id="{5AD79A7D-0C27-4BC3-B25B-34B461534612}"/>
+                <a16:creationId xmlns:a16="http://schemas.microsoft.com/office/drawing/2014/main" id="{18E6CA98-D88B-422E-8018-8C369D981566}"/>
               </a:ext>
             </a:extLst>
           </p:cNvPr>
@@ -8517,7 +8790,7 @@
           <p:cNvPr id="16" name="">
             <a:extLst xmlns:a="http://schemas.openxmlformats.org/drawingml/2006/main">
               <a:ext uri="{FF2B5EF4-FFF2-40B4-BE49-F238E27FC236}">
-                <a16:creationId xmlns:a16="http://schemas.microsoft.com/office/drawing/2014/main" id="{21957C7A-0B70-4586-97C7-B5520A98CD47}"/>
+                <a16:creationId xmlns:a16="http://schemas.microsoft.com/office/drawing/2014/main" id="{9E9E479E-EAA6-4528-B5E7-5F59A7E7654B}"/>
               </a:ext>
             </a:extLst>
           </p:cNvPr>
@@ -8574,7 +8847,7 @@
           <p:cNvPr id="17" name="">
             <a:extLst xmlns:a="http://schemas.openxmlformats.org/drawingml/2006/main">
               <a:ext uri="{FF2B5EF4-FFF2-40B4-BE49-F238E27FC236}">
-                <a16:creationId xmlns:a16="http://schemas.microsoft.com/office/drawing/2014/main" id="{244F86F8-E42B-4770-9A74-0FF40D12368C}"/>
+                <a16:creationId xmlns:a16="http://schemas.microsoft.com/office/drawing/2014/main" id="{69F7B8F2-5AE3-4754-9630-8D46E9A562C2}"/>
               </a:ext>
             </a:extLst>
           </p:cNvPr>
@@ -8631,7 +8904,7 @@
           <p:cNvPr id="18" name="">
             <a:extLst xmlns:a="http://schemas.openxmlformats.org/drawingml/2006/main">
               <a:ext uri="{FF2B5EF4-FFF2-40B4-BE49-F238E27FC236}">
-                <a16:creationId xmlns:a16="http://schemas.microsoft.com/office/drawing/2014/main" id="{743E4495-EC57-497B-8561-4BC7074300F6}"/>
+                <a16:creationId xmlns:a16="http://schemas.microsoft.com/office/drawing/2014/main" id="{23DF8A64-9F64-401B-A3B4-3199D633CD9B}"/>
               </a:ext>
             </a:extLst>
           </p:cNvPr>
@@ -8661,7 +8934,7 @@
           <p:cNvPr id="19" name="">
             <a:extLst xmlns:a="http://schemas.openxmlformats.org/drawingml/2006/main">
               <a:ext uri="{FF2B5EF4-FFF2-40B4-BE49-F238E27FC236}">
-                <a16:creationId xmlns:a16="http://schemas.microsoft.com/office/drawing/2014/main" id="{BEDA654B-8649-4D75-B5A7-838FDF931934}"/>
+                <a16:creationId xmlns:a16="http://schemas.microsoft.com/office/drawing/2014/main" id="{A2055468-E6E0-465E-A025-77F74E7C301B}"/>
               </a:ext>
             </a:extLst>
           </p:cNvPr>
@@ -8718,7 +8991,7 @@
           <p:cNvPr id="20" name="">
             <a:extLst xmlns:a="http://schemas.openxmlformats.org/drawingml/2006/main">
               <a:ext uri="{FF2B5EF4-FFF2-40B4-BE49-F238E27FC236}">
-                <a16:creationId xmlns:a16="http://schemas.microsoft.com/office/drawing/2014/main" id="{6D3ED58F-E58B-4966-A53B-9D79FA61AB12}"/>
+                <a16:creationId xmlns:a16="http://schemas.microsoft.com/office/drawing/2014/main" id="{983FB048-660C-42EC-8D35-4CA5EA27023B}"/>
               </a:ext>
             </a:extLst>
           </p:cNvPr>
@@ -8775,7 +9048,7 @@
           <p:cNvPr id="21" name="">
             <a:extLst xmlns:a="http://schemas.openxmlformats.org/drawingml/2006/main">
               <a:ext uri="{FF2B5EF4-FFF2-40B4-BE49-F238E27FC236}">
-                <a16:creationId xmlns:a16="http://schemas.microsoft.com/office/drawing/2014/main" id="{68F72B1B-F4E1-4BD0-8AEE-251ED7611A3B}"/>
+                <a16:creationId xmlns:a16="http://schemas.microsoft.com/office/drawing/2014/main" id="{9402165D-0808-44AA-AD95-18AD1B34AF04}"/>
               </a:ext>
             </a:extLst>
           </p:cNvPr>
@@ -8832,7 +9105,7 @@
           <p:cNvPr id="22" name="">
             <a:extLst xmlns:a="http://schemas.openxmlformats.org/drawingml/2006/main">
               <a:ext uri="{FF2B5EF4-FFF2-40B4-BE49-F238E27FC236}">
-                <a16:creationId xmlns:a16="http://schemas.microsoft.com/office/drawing/2014/main" id="{E910E4E5-DC6A-4DFF-AF98-C4863ECB1D80}"/>
+                <a16:creationId xmlns:a16="http://schemas.microsoft.com/office/drawing/2014/main" id="{CE4B4D7A-245B-4336-A319-70A6B653D522}"/>
               </a:ext>
             </a:extLst>
           </p:cNvPr>
@@ -8889,7 +9162,7 @@
           <p:cNvPr id="23" name="">
             <a:extLst xmlns:a="http://schemas.openxmlformats.org/drawingml/2006/main">
               <a:ext uri="{FF2B5EF4-FFF2-40B4-BE49-F238E27FC236}">
-                <a16:creationId xmlns:a16="http://schemas.microsoft.com/office/drawing/2014/main" id="{9A631240-B03F-4DF7-BE9B-4A8D5F8AB0B8}"/>
+                <a16:creationId xmlns:a16="http://schemas.microsoft.com/office/drawing/2014/main" id="{344D8C9F-63B1-47DC-8F41-6F1C5A7927FC}"/>
               </a:ext>
             </a:extLst>
           </p:cNvPr>
@@ -8946,7 +9219,7 @@
           <p:cNvPr id="24" name="">
             <a:extLst xmlns:a="http://schemas.openxmlformats.org/drawingml/2006/main">
               <a:ext uri="{FF2B5EF4-FFF2-40B4-BE49-F238E27FC236}">
-                <a16:creationId xmlns:a16="http://schemas.microsoft.com/office/drawing/2014/main" id="{C2A3D074-BBF7-46C3-9179-7BA12B358FF5}"/>
+                <a16:creationId xmlns:a16="http://schemas.microsoft.com/office/drawing/2014/main" id="{C280CDF7-1CB4-4CD7-A255-4041596AA5C5}"/>
               </a:ext>
             </a:extLst>
           </p:cNvPr>
@@ -9003,7 +9276,7 @@
           <p:cNvPr id="25" name="">
             <a:extLst xmlns:a="http://schemas.openxmlformats.org/drawingml/2006/main">
               <a:ext uri="{FF2B5EF4-FFF2-40B4-BE49-F238E27FC236}">
-                <a16:creationId xmlns:a16="http://schemas.microsoft.com/office/drawing/2014/main" id="{CCAA94EA-1560-4447-9D87-8719277BCDD2}"/>
+                <a16:creationId xmlns:a16="http://schemas.microsoft.com/office/drawing/2014/main" id="{87D466EE-44FF-41BF-8F3E-656C36699BEA}"/>
               </a:ext>
             </a:extLst>
           </p:cNvPr>
@@ -9060,7 +9333,7 @@
           <p:cNvPr id="26" name="">
             <a:extLst xmlns:a="http://schemas.openxmlformats.org/drawingml/2006/main">
               <a:ext uri="{FF2B5EF4-FFF2-40B4-BE49-F238E27FC236}">
-                <a16:creationId xmlns:a16="http://schemas.microsoft.com/office/drawing/2014/main" id="{D4AD561F-0783-407A-84F9-E2CC71CE23FB}"/>
+                <a16:creationId xmlns:a16="http://schemas.microsoft.com/office/drawing/2014/main" id="{5D06E242-1C96-4764-9AB9-B954E75BB454}"/>
               </a:ext>
             </a:extLst>
           </p:cNvPr>
@@ -9117,7 +9390,7 @@
           <p:cNvPr id="27" name="">
             <a:extLst xmlns:a="http://schemas.openxmlformats.org/drawingml/2006/main">
               <a:ext uri="{FF2B5EF4-FFF2-40B4-BE49-F238E27FC236}">
-                <a16:creationId xmlns:a16="http://schemas.microsoft.com/office/drawing/2014/main" id="{ED098280-97FE-4A5A-8AEC-74C362545495}"/>
+                <a16:creationId xmlns:a16="http://schemas.microsoft.com/office/drawing/2014/main" id="{8D8BE261-6CB5-45E3-9B2E-1BEAE5D1C9EF}"/>
               </a:ext>
             </a:extLst>
           </p:cNvPr>
@@ -9174,7 +9447,7 @@
           <p:cNvPr id="28" name="">
             <a:extLst xmlns:a="http://schemas.openxmlformats.org/drawingml/2006/main">
               <a:ext uri="{FF2B5EF4-FFF2-40B4-BE49-F238E27FC236}">
-                <a16:creationId xmlns:a16="http://schemas.microsoft.com/office/drawing/2014/main" id="{EF63EEB1-785F-4B1D-9B67-D3C01A5EB57D}"/>
+                <a16:creationId xmlns:a16="http://schemas.microsoft.com/office/drawing/2014/main" id="{33590861-156C-4F66-87D6-618CA06B718E}"/>
               </a:ext>
             </a:extLst>
           </p:cNvPr>
@@ -9231,7 +9504,7 @@
           <p:cNvPr id="29" name="">
             <a:extLst xmlns:a="http://schemas.openxmlformats.org/drawingml/2006/main">
               <a:ext uri="{FF2B5EF4-FFF2-40B4-BE49-F238E27FC236}">
-                <a16:creationId xmlns:a16="http://schemas.microsoft.com/office/drawing/2014/main" id="{23B66853-C295-43AD-BC44-D23C40C8243A}"/>
+                <a16:creationId xmlns:a16="http://schemas.microsoft.com/office/drawing/2014/main" id="{20690750-BAE2-4018-BDC1-C061D6859C80}"/>
               </a:ext>
             </a:extLst>
           </p:cNvPr>
@@ -9288,7 +9561,7 @@
           <p:cNvPr id="30" name="">
             <a:extLst xmlns:a="http://schemas.openxmlformats.org/drawingml/2006/main">
               <a:ext uri="{FF2B5EF4-FFF2-40B4-BE49-F238E27FC236}">
-                <a16:creationId xmlns:a16="http://schemas.microsoft.com/office/drawing/2014/main" id="{28201166-82B5-484D-881C-FFBDE9BEDD4B}"/>
+                <a16:creationId xmlns:a16="http://schemas.microsoft.com/office/drawing/2014/main" id="{82D29D4E-70B1-4F4C-A3CE-76CA45EC7DC2}"/>
               </a:ext>
             </a:extLst>
           </p:cNvPr>
@@ -9345,7 +9618,7 @@
           <p:cNvPr id="31" name="">
             <a:extLst xmlns:a="http://schemas.openxmlformats.org/drawingml/2006/main">
               <a:ext uri="{FF2B5EF4-FFF2-40B4-BE49-F238E27FC236}">
-                <a16:creationId xmlns:a16="http://schemas.microsoft.com/office/drawing/2014/main" id="{20E99910-9614-485C-A162-3782F6543B97}"/>
+                <a16:creationId xmlns:a16="http://schemas.microsoft.com/office/drawing/2014/main" id="{88A25A64-98CA-4E28-8854-37A0A8E0B651}"/>
               </a:ext>
             </a:extLst>
           </p:cNvPr>
@@ -9402,7 +9675,7 @@
           <p:cNvPr id="32" name="">
             <a:extLst xmlns:a="http://schemas.openxmlformats.org/drawingml/2006/main">
               <a:ext uri="{FF2B5EF4-FFF2-40B4-BE49-F238E27FC236}">
-                <a16:creationId xmlns:a16="http://schemas.microsoft.com/office/drawing/2014/main" id="{3F71B73F-D874-4C1D-93D5-B16540C6CAF3}"/>
+                <a16:creationId xmlns:a16="http://schemas.microsoft.com/office/drawing/2014/main" id="{E7FC2192-8342-4C8A-82A6-4DFB65C25BA5}"/>
               </a:ext>
             </a:extLst>
           </p:cNvPr>
@@ -9459,7 +9732,7 @@
           <p:cNvPr id="33" name="">
             <a:extLst xmlns:a="http://schemas.openxmlformats.org/drawingml/2006/main">
               <a:ext uri="{FF2B5EF4-FFF2-40B4-BE49-F238E27FC236}">
-                <a16:creationId xmlns:a16="http://schemas.microsoft.com/office/drawing/2014/main" id="{8F0AEE30-86DB-4834-914A-CACA8B14258F}"/>
+                <a16:creationId xmlns:a16="http://schemas.microsoft.com/office/drawing/2014/main" id="{F0902F51-EA36-4D1E-9645-CBC37E9F64FE}"/>
               </a:ext>
             </a:extLst>
           </p:cNvPr>
@@ -9516,7 +9789,7 @@
           <p:cNvPr id="34" name="">
             <a:extLst xmlns:a="http://schemas.openxmlformats.org/drawingml/2006/main">
               <a:ext uri="{FF2B5EF4-FFF2-40B4-BE49-F238E27FC236}">
-                <a16:creationId xmlns:a16="http://schemas.microsoft.com/office/drawing/2014/main" id="{38043531-5836-473B-AAD3-4CF4F1C90291}"/>
+                <a16:creationId xmlns:a16="http://schemas.microsoft.com/office/drawing/2014/main" id="{1C36AB48-A6FD-4653-90E3-DE724FF62C6D}"/>
               </a:ext>
             </a:extLst>
           </p:cNvPr>
@@ -9573,7 +9846,7 @@
           <p:cNvPr id="35" name="">
             <a:extLst xmlns:a="http://schemas.openxmlformats.org/drawingml/2006/main">
               <a:ext uri="{FF2B5EF4-FFF2-40B4-BE49-F238E27FC236}">
-                <a16:creationId xmlns:a16="http://schemas.microsoft.com/office/drawing/2014/main" id="{7A958684-85EB-4449-B3EF-D4869BAA3D30}"/>
+                <a16:creationId xmlns:a16="http://schemas.microsoft.com/office/drawing/2014/main" id="{5BB4022C-27E7-494E-A696-9756964D2B5A}"/>
               </a:ext>
             </a:extLst>
           </p:cNvPr>
@@ -9630,7 +9903,7 @@
           <p:cNvPr id="36" name="">
             <a:extLst xmlns:a="http://schemas.openxmlformats.org/drawingml/2006/main">
               <a:ext uri="{FF2B5EF4-FFF2-40B4-BE49-F238E27FC236}">
-                <a16:creationId xmlns:a16="http://schemas.microsoft.com/office/drawing/2014/main" id="{2048008B-A4BB-432B-BDE1-A331AF32E3B4}"/>
+                <a16:creationId xmlns:a16="http://schemas.microsoft.com/office/drawing/2014/main" id="{8863ECFE-3D7B-4D7F-A34D-3BDF33D5E674}"/>
               </a:ext>
             </a:extLst>
           </p:cNvPr>
@@ -9687,7 +9960,7 @@
           <p:cNvPr id="37" name="">
             <a:extLst xmlns:a="http://schemas.openxmlformats.org/drawingml/2006/main">
               <a:ext uri="{FF2B5EF4-FFF2-40B4-BE49-F238E27FC236}">
-                <a16:creationId xmlns:a16="http://schemas.microsoft.com/office/drawing/2014/main" id="{604E63AD-7F18-4BCE-85D3-B8B89126189B}"/>
+                <a16:creationId xmlns:a16="http://schemas.microsoft.com/office/drawing/2014/main" id="{AEEA0E39-67DB-4E67-9A1F-E602E783D9B7}"/>
               </a:ext>
             </a:extLst>
           </p:cNvPr>
@@ -9742,7 +10015,7 @@
     </p:spTree>
     <p:extLst>
       <p:ext uri="{BB962C8B-B14F-4D97-AF65-F5344CB8AC3E}">
-        <p14:creationId xmlns:p14="http://schemas.microsoft.com/office/powerpoint/2010/main" val="1887273217"/>
+        <p14:creationId xmlns:p14="http://schemas.microsoft.com/office/powerpoint/2010/main" val="2122183096"/>
       </p:ext>
     </p:extLst>
   </p:cSld>
@@ -9773,7 +10046,7 @@
           <p:cNvPr id="19" name="">
             <a:extLst xmlns:a="http://schemas.openxmlformats.org/drawingml/2006/main">
               <a:ext uri="{FF2B5EF4-FFF2-40B4-BE49-F238E27FC236}">
-                <a16:creationId xmlns:a16="http://schemas.microsoft.com/office/drawing/2014/main" id="{F21DE1EA-0ADA-47C1-A93A-9E94358933E4}"/>
+                <a16:creationId xmlns:a16="http://schemas.microsoft.com/office/drawing/2014/main" id="{E12FFF4E-3A51-4476-8D1B-122498BE3151}"/>
               </a:ext>
             </a:extLst>
           </p:cNvPr>
@@ -9830,7 +10103,7 @@
           <p:cNvPr id="2" name="">
             <a:extLst xmlns:a="http://schemas.openxmlformats.org/drawingml/2006/main">
               <a:ext uri="{FF2B5EF4-FFF2-40B4-BE49-F238E27FC236}">
-                <a16:creationId xmlns:a16="http://schemas.microsoft.com/office/drawing/2014/main" id="{B5858ED4-D460-472B-B677-9669CCE20AC4}"/>
+                <a16:creationId xmlns:a16="http://schemas.microsoft.com/office/drawing/2014/main" id="{718D32A8-8CD5-49EC-B923-BC16FCF1D06B}"/>
               </a:ext>
             </a:extLst>
           </p:cNvPr>
@@ -9887,7 +10160,7 @@
           <p:cNvPr id="3" name="">
             <a:extLst xmlns:a="http://schemas.openxmlformats.org/drawingml/2006/main">
               <a:ext uri="{FF2B5EF4-FFF2-40B4-BE49-F238E27FC236}">
-                <a16:creationId xmlns:a16="http://schemas.microsoft.com/office/drawing/2014/main" id="{DBB3053D-573E-457C-AC53-CA0009E16875}"/>
+                <a16:creationId xmlns:a16="http://schemas.microsoft.com/office/drawing/2014/main" id="{3E27FCD8-9515-4669-869D-9C7D9532C39B}"/>
               </a:ext>
             </a:extLst>
           </p:cNvPr>
@@ -9944,7 +10217,7 @@
           <p:cNvPr id="4" name="">
             <a:extLst xmlns:a="http://schemas.openxmlformats.org/drawingml/2006/main">
               <a:ext uri="{FF2B5EF4-FFF2-40B4-BE49-F238E27FC236}">
-                <a16:creationId xmlns:a16="http://schemas.microsoft.com/office/drawing/2014/main" id="{10F810F4-3038-47CC-B61B-99B236B588D3}"/>
+                <a16:creationId xmlns:a16="http://schemas.microsoft.com/office/drawing/2014/main" id="{10BC9BB4-6722-4B9D-BCAC-B55222593860}"/>
               </a:ext>
             </a:extLst>
           </p:cNvPr>
@@ -9974,7 +10247,7 @@
           <p:cNvPr id="5" name="">
             <a:extLst xmlns:a="http://schemas.openxmlformats.org/drawingml/2006/main">
               <a:ext uri="{FF2B5EF4-FFF2-40B4-BE49-F238E27FC236}">
-                <a16:creationId xmlns:a16="http://schemas.microsoft.com/office/drawing/2014/main" id="{DBB2C070-E917-45FB-ABA8-CD59D943803B}"/>
+                <a16:creationId xmlns:a16="http://schemas.microsoft.com/office/drawing/2014/main" id="{0B062525-1B1E-4E42-B999-7D0B16C884E5}"/>
               </a:ext>
             </a:extLst>
           </p:cNvPr>
@@ -10753,7 +11026,7 @@
           <p:cNvPr id="7" name="">
             <a:extLst xmlns:a="http://schemas.openxmlformats.org/drawingml/2006/main">
               <a:ext uri="{FF2B5EF4-FFF2-40B4-BE49-F238E27FC236}">
-                <a16:creationId xmlns:a16="http://schemas.microsoft.com/office/drawing/2014/main" id="{68F54126-000B-4106-8906-5E283083BDC5}"/>
+                <a16:creationId xmlns:a16="http://schemas.microsoft.com/office/drawing/2014/main" id="{8376993C-ED62-4296-8A78-2E8FE29964EF}"/>
               </a:ext>
             </a:extLst>
           </p:cNvPr>
@@ -10810,7 +11083,7 @@
           <p:cNvPr id="8" name="">
             <a:extLst xmlns:a="http://schemas.openxmlformats.org/drawingml/2006/main">
               <a:ext uri="{FF2B5EF4-FFF2-40B4-BE49-F238E27FC236}">
-                <a16:creationId xmlns:a16="http://schemas.microsoft.com/office/drawing/2014/main" id="{529DC120-4EEE-4471-92B0-C6B955238913}"/>
+                <a16:creationId xmlns:a16="http://schemas.microsoft.com/office/drawing/2014/main" id="{814736E2-3478-41C1-AEF8-2EC322148E35}"/>
               </a:ext>
             </a:extLst>
           </p:cNvPr>
@@ -10890,7 +11163,7 @@
           <p:cNvPr id="9" name="">
             <a:extLst xmlns:a="http://schemas.openxmlformats.org/drawingml/2006/main">
               <a:ext uri="{FF2B5EF4-FFF2-40B4-BE49-F238E27FC236}">
-                <a16:creationId xmlns:a16="http://schemas.microsoft.com/office/drawing/2014/main" id="{A4480BB2-2EC5-41C6-BB2B-C5E31B2382B0}"/>
+                <a16:creationId xmlns:a16="http://schemas.microsoft.com/office/drawing/2014/main" id="{04D27442-A67B-4C7A-A203-011E429836FE}"/>
               </a:ext>
             </a:extLst>
           </p:cNvPr>
@@ -10947,7 +11220,7 @@
           <p:cNvPr id="10" name="">
             <a:extLst xmlns:a="http://schemas.openxmlformats.org/drawingml/2006/main">
               <a:ext uri="{FF2B5EF4-FFF2-40B4-BE49-F238E27FC236}">
-                <a16:creationId xmlns:a16="http://schemas.microsoft.com/office/drawing/2014/main" id="{1CB9A0D2-ABB2-4F33-9036-D715953752B9}"/>
+                <a16:creationId xmlns:a16="http://schemas.microsoft.com/office/drawing/2014/main" id="{78DCAF47-887B-4DB8-9114-A7F3C68B895F}"/>
               </a:ext>
             </a:extLst>
           </p:cNvPr>
@@ -11027,7 +11300,7 @@
           <p:cNvPr id="11" name="">
             <a:extLst xmlns:a="http://schemas.openxmlformats.org/drawingml/2006/main">
               <a:ext uri="{FF2B5EF4-FFF2-40B4-BE49-F238E27FC236}">
-                <a16:creationId xmlns:a16="http://schemas.microsoft.com/office/drawing/2014/main" id="{939CA9CF-5666-4FBB-8390-BB7421C12AAF}"/>
+                <a16:creationId xmlns:a16="http://schemas.microsoft.com/office/drawing/2014/main" id="{40F56567-16A3-483A-B4C4-CC54FD0DAC23}"/>
               </a:ext>
             </a:extLst>
           </p:cNvPr>
@@ -11057,7 +11330,7 @@
           <p:cNvPr id="12" name="">
             <a:extLst xmlns:a="http://schemas.openxmlformats.org/drawingml/2006/main">
               <a:ext uri="{FF2B5EF4-FFF2-40B4-BE49-F238E27FC236}">
-                <a16:creationId xmlns:a16="http://schemas.microsoft.com/office/drawing/2014/main" id="{9369436B-FEFF-49BD-B88F-7B50B8F1DAE6}"/>
+                <a16:creationId xmlns:a16="http://schemas.microsoft.com/office/drawing/2014/main" id="{7D0D3A6C-13CE-4275-83D0-9991F5587904}"/>
               </a:ext>
             </a:extLst>
           </p:cNvPr>
@@ -11114,7 +11387,7 @@
           <p:cNvPr id="13" name="">
             <a:extLst xmlns:a="http://schemas.openxmlformats.org/drawingml/2006/main">
               <a:ext uri="{FF2B5EF4-FFF2-40B4-BE49-F238E27FC236}">
-                <a16:creationId xmlns:a16="http://schemas.microsoft.com/office/drawing/2014/main" id="{4314E9AA-8ACD-4450-9613-17510894E300}"/>
+                <a16:creationId xmlns:a16="http://schemas.microsoft.com/office/drawing/2014/main" id="{6B1FE02D-EADF-484E-8E78-9ED282DFD25C}"/>
               </a:ext>
             </a:extLst>
           </p:cNvPr>
@@ -11194,7 +11467,7 @@
           <p:cNvPr id="14" name="">
             <a:extLst xmlns:a="http://schemas.openxmlformats.org/drawingml/2006/main">
               <a:ext uri="{FF2B5EF4-FFF2-40B4-BE49-F238E27FC236}">
-                <a16:creationId xmlns:a16="http://schemas.microsoft.com/office/drawing/2014/main" id="{BA6DA9D1-7D87-45D9-9C82-8CEF0ED47956}"/>
+                <a16:creationId xmlns:a16="http://schemas.microsoft.com/office/drawing/2014/main" id="{9842DC53-04E5-4A76-A57D-233A25D8CA88}"/>
               </a:ext>
             </a:extLst>
           </p:cNvPr>
@@ -11251,7 +11524,7 @@
           <p:cNvPr id="15" name="">
             <a:extLst xmlns:a="http://schemas.openxmlformats.org/drawingml/2006/main">
               <a:ext uri="{FF2B5EF4-FFF2-40B4-BE49-F238E27FC236}">
-                <a16:creationId xmlns:a16="http://schemas.microsoft.com/office/drawing/2014/main" id="{C9E87FE3-09CB-4A4E-8DE4-AF825CC5BF75}"/>
+                <a16:creationId xmlns:a16="http://schemas.microsoft.com/office/drawing/2014/main" id="{CAEBF204-2EDE-4717-8D84-6C1F61B7C340}"/>
               </a:ext>
             </a:extLst>
           </p:cNvPr>
@@ -11331,7 +11604,7 @@
           <p:cNvPr id="16" name="">
             <a:extLst xmlns:a="http://schemas.openxmlformats.org/drawingml/2006/main">
               <a:ext uri="{FF2B5EF4-FFF2-40B4-BE49-F238E27FC236}">
-                <a16:creationId xmlns:a16="http://schemas.microsoft.com/office/drawing/2014/main" id="{C51488EA-F250-420C-A66B-A11D9ECA1612}"/>
+                <a16:creationId xmlns:a16="http://schemas.microsoft.com/office/drawing/2014/main" id="{670ECBBA-9213-47B2-AAFF-22454FC356F7}"/>
               </a:ext>
             </a:extLst>
           </p:cNvPr>
@@ -11388,7 +11661,7 @@
           <p:cNvPr id="17" name="">
             <a:extLst xmlns:a="http://schemas.openxmlformats.org/drawingml/2006/main">
               <a:ext uri="{FF2B5EF4-FFF2-40B4-BE49-F238E27FC236}">
-                <a16:creationId xmlns:a16="http://schemas.microsoft.com/office/drawing/2014/main" id="{53EFB2F3-74B1-4DCD-8AAB-29AA3AD9FC01}"/>
+                <a16:creationId xmlns:a16="http://schemas.microsoft.com/office/drawing/2014/main" id="{E9472D87-2D24-4394-8722-DF97B08A479B}"/>
               </a:ext>
             </a:extLst>
           </p:cNvPr>
@@ -11468,7 +11741,7 @@
           <p:cNvPr id="18" name="">
             <a:extLst xmlns:a="http://schemas.openxmlformats.org/drawingml/2006/main">
               <a:ext uri="{FF2B5EF4-FFF2-40B4-BE49-F238E27FC236}">
-                <a16:creationId xmlns:a16="http://schemas.microsoft.com/office/drawing/2014/main" id="{0A70AC1B-C3E6-4116-AF1A-510B703B0CCE}"/>
+                <a16:creationId xmlns:a16="http://schemas.microsoft.com/office/drawing/2014/main" id="{D10D5D59-0784-421E-BEA6-DCFE437CD97A}"/>
               </a:ext>
             </a:extLst>
           </p:cNvPr>
@@ -11523,7 +11796,7 @@
     </p:spTree>
     <p:extLst>
       <p:ext uri="{BB962C8B-B14F-4D97-AF65-F5344CB8AC3E}">
-        <p14:creationId xmlns:p14="http://schemas.microsoft.com/office/powerpoint/2010/main" val="1070759839"/>
+        <p14:creationId xmlns:p14="http://schemas.microsoft.com/office/powerpoint/2010/main" val="559702032"/>
       </p:ext>
     </p:extLst>
   </p:cSld>
@@ -11554,7 +11827,7 @@
           <p:cNvPr id="15" name="">
             <a:extLst xmlns:a="http://schemas.openxmlformats.org/drawingml/2006/main">
               <a:ext uri="{FF2B5EF4-FFF2-40B4-BE49-F238E27FC236}">
-                <a16:creationId xmlns:a16="http://schemas.microsoft.com/office/drawing/2014/main" id="{6B3F70B8-05D6-483E-B7BE-FB1015127638}"/>
+                <a16:creationId xmlns:a16="http://schemas.microsoft.com/office/drawing/2014/main" id="{112DC9B0-CC05-4B8C-8FD2-37633B4D7DC0}"/>
               </a:ext>
             </a:extLst>
           </p:cNvPr>
@@ -11611,7 +11884,7 @@
           <p:cNvPr id="2" name="">
             <a:extLst xmlns:a="http://schemas.openxmlformats.org/drawingml/2006/main">
               <a:ext uri="{FF2B5EF4-FFF2-40B4-BE49-F238E27FC236}">
-                <a16:creationId xmlns:a16="http://schemas.microsoft.com/office/drawing/2014/main" id="{557B9F3F-004A-4168-9411-A2123BDD95C5}"/>
+                <a16:creationId xmlns:a16="http://schemas.microsoft.com/office/drawing/2014/main" id="{C9EB1F18-A969-4E9D-8681-A623FD8A05A9}"/>
               </a:ext>
             </a:extLst>
           </p:cNvPr>
@@ -11668,7 +11941,7 @@
           <p:cNvPr id="3" name="">
             <a:extLst xmlns:a="http://schemas.openxmlformats.org/drawingml/2006/main">
               <a:ext uri="{FF2B5EF4-FFF2-40B4-BE49-F238E27FC236}">
-                <a16:creationId xmlns:a16="http://schemas.microsoft.com/office/drawing/2014/main" id="{B6B7A4DF-D7EE-4D9A-8F4B-C8237970F856}"/>
+                <a16:creationId xmlns:a16="http://schemas.microsoft.com/office/drawing/2014/main" id="{AEF896C4-4C19-4DBC-993C-14756DCDE7F5}"/>
               </a:ext>
             </a:extLst>
           </p:cNvPr>
@@ -11725,7 +11998,7 @@
           <p:cNvPr id="4" name="">
             <a:extLst xmlns:a="http://schemas.openxmlformats.org/drawingml/2006/main">
               <a:ext uri="{FF2B5EF4-FFF2-40B4-BE49-F238E27FC236}">
-                <a16:creationId xmlns:a16="http://schemas.microsoft.com/office/drawing/2014/main" id="{B20263B4-CDD1-4AD8-B13D-7DDF079C1FC6}"/>
+                <a16:creationId xmlns:a16="http://schemas.microsoft.com/office/drawing/2014/main" id="{A0E14C9B-21D6-4BB0-B719-0F0C343EFF7A}"/>
               </a:ext>
             </a:extLst>
           </p:cNvPr>
@@ -11755,7 +12028,7 @@
           <p:cNvPr id="5" name="">
             <a:extLst xmlns:a="http://schemas.openxmlformats.org/drawingml/2006/main">
               <a:ext uri="{FF2B5EF4-FFF2-40B4-BE49-F238E27FC236}">
-                <a16:creationId xmlns:a16="http://schemas.microsoft.com/office/drawing/2014/main" id="{FD73DBDF-CCB7-40A8-AFF4-DEF7521C5ACE}"/>
+                <a16:creationId xmlns:a16="http://schemas.microsoft.com/office/drawing/2014/main" id="{EE40AB0D-2CF5-4332-9BAA-18CF686D292B}"/>
               </a:ext>
             </a:extLst>
           </p:cNvPr>
@@ -11812,7 +12085,7 @@
           <p:cNvPr id="6" name="">
             <a:extLst xmlns:a="http://schemas.openxmlformats.org/drawingml/2006/main">
               <a:ext uri="{FF2B5EF4-FFF2-40B4-BE49-F238E27FC236}">
-                <a16:creationId xmlns:a16="http://schemas.microsoft.com/office/drawing/2014/main" id="{EF4B5644-DF35-48F7-BDC9-F7D65FCC37A1}"/>
+                <a16:creationId xmlns:a16="http://schemas.microsoft.com/office/drawing/2014/main" id="{26FD87D9-68A5-414C-8AB2-5C4379BFA97D}"/>
               </a:ext>
             </a:extLst>
           </p:cNvPr>
@@ -11869,7 +12142,7 @@
           <p:cNvPr id="7" name="">
             <a:extLst xmlns:a="http://schemas.openxmlformats.org/drawingml/2006/main">
               <a:ext uri="{FF2B5EF4-FFF2-40B4-BE49-F238E27FC236}">
-                <a16:creationId xmlns:a16="http://schemas.microsoft.com/office/drawing/2014/main" id="{EE98E7A7-FB4E-4E2C-B9C2-2EC1E0911B19}"/>
+                <a16:creationId xmlns:a16="http://schemas.microsoft.com/office/drawing/2014/main" id="{BA5AD20F-304B-41BA-B44B-5A620C7391C5}"/>
               </a:ext>
             </a:extLst>
           </p:cNvPr>
@@ -11995,7 +12268,7 @@
           <p:cNvPr id="8" name="">
             <a:extLst xmlns:a="http://schemas.openxmlformats.org/drawingml/2006/main">
               <a:ext uri="{FF2B5EF4-FFF2-40B4-BE49-F238E27FC236}">
-                <a16:creationId xmlns:a16="http://schemas.microsoft.com/office/drawing/2014/main" id="{BE896D96-B466-4967-BEEB-15E1575F5577}"/>
+                <a16:creationId xmlns:a16="http://schemas.microsoft.com/office/drawing/2014/main" id="{0B2F2E6A-8FF0-47FA-8816-F6C9F62BEDF4}"/>
               </a:ext>
             </a:extLst>
           </p:cNvPr>
@@ -12052,7 +12325,7 @@
           <p:cNvPr id="9" name="">
             <a:extLst xmlns:a="http://schemas.openxmlformats.org/drawingml/2006/main">
               <a:ext uri="{FF2B5EF4-FFF2-40B4-BE49-F238E27FC236}">
-                <a16:creationId xmlns:a16="http://schemas.microsoft.com/office/drawing/2014/main" id="{0D84FDB1-B17F-4E17-A02B-8EF664FC0519}"/>
+                <a16:creationId xmlns:a16="http://schemas.microsoft.com/office/drawing/2014/main" id="{CEE6550A-E843-4369-84D2-8FBA4032A7DE}"/>
               </a:ext>
             </a:extLst>
           </p:cNvPr>
@@ -12178,7 +12451,7 @@
           <p:cNvPr id="10" name="">
             <a:extLst xmlns:a="http://schemas.openxmlformats.org/drawingml/2006/main">
               <a:ext uri="{FF2B5EF4-FFF2-40B4-BE49-F238E27FC236}">
-                <a16:creationId xmlns:a16="http://schemas.microsoft.com/office/drawing/2014/main" id="{F9F348B1-C899-4BD5-9130-0F38E6590633}"/>
+                <a16:creationId xmlns:a16="http://schemas.microsoft.com/office/drawing/2014/main" id="{8555938F-6AF8-459B-93BF-9F2E17C031B0}"/>
               </a:ext>
             </a:extLst>
           </p:cNvPr>
@@ -12208,7 +12481,7 @@
           <p:cNvPr id="11" name="">
             <a:extLst xmlns:a="http://schemas.openxmlformats.org/drawingml/2006/main">
               <a:ext uri="{FF2B5EF4-FFF2-40B4-BE49-F238E27FC236}">
-                <a16:creationId xmlns:a16="http://schemas.microsoft.com/office/drawing/2014/main" id="{0319C8D5-6517-46F1-9D67-DFADC149246B}"/>
+                <a16:creationId xmlns:a16="http://schemas.microsoft.com/office/drawing/2014/main" id="{FCEE0CB9-9E5C-4BB2-96F5-714936326530}"/>
               </a:ext>
             </a:extLst>
           </p:cNvPr>
@@ -12265,7 +12538,7 @@
           <p:cNvPr id="12" name="">
             <a:extLst xmlns:a="http://schemas.openxmlformats.org/drawingml/2006/main">
               <a:ext uri="{FF2B5EF4-FFF2-40B4-BE49-F238E27FC236}">
-                <a16:creationId xmlns:a16="http://schemas.microsoft.com/office/drawing/2014/main" id="{CFAA5409-C880-4733-8AB2-F6EF4D958946}"/>
+                <a16:creationId xmlns:a16="http://schemas.microsoft.com/office/drawing/2014/main" id="{5E1F66AA-950B-4734-BEB2-A670C4412D07}"/>
               </a:ext>
             </a:extLst>
           </p:cNvPr>
@@ -12322,7 +12595,7 @@
           <p:cNvPr id="13" name="">
             <a:extLst xmlns:a="http://schemas.openxmlformats.org/drawingml/2006/main">
               <a:ext uri="{FF2B5EF4-FFF2-40B4-BE49-F238E27FC236}">
-                <a16:creationId xmlns:a16="http://schemas.microsoft.com/office/drawing/2014/main" id="{9A4045E0-B0E3-4BD2-92FC-BD898713E329}"/>
+                <a16:creationId xmlns:a16="http://schemas.microsoft.com/office/drawing/2014/main" id="{110AF72A-DA5F-4970-86A6-2812C484465A}"/>
               </a:ext>
             </a:extLst>
           </p:cNvPr>
@@ -12379,7 +12652,7 @@
           <p:cNvPr id="14" name="">
             <a:extLst xmlns:a="http://schemas.openxmlformats.org/drawingml/2006/main">
               <a:ext uri="{FF2B5EF4-FFF2-40B4-BE49-F238E27FC236}">
-                <a16:creationId xmlns:a16="http://schemas.microsoft.com/office/drawing/2014/main" id="{D83BC0BB-5A6C-400E-93A0-009048B8737A}"/>
+                <a16:creationId xmlns:a16="http://schemas.microsoft.com/office/drawing/2014/main" id="{3FFCDB40-3049-4A81-B060-038155BC3B3F}"/>
               </a:ext>
             </a:extLst>
           </p:cNvPr>
@@ -12434,7 +12707,7 @@
     </p:spTree>
     <p:extLst>
       <p:ext uri="{BB962C8B-B14F-4D97-AF65-F5344CB8AC3E}">
-        <p14:creationId xmlns:p14="http://schemas.microsoft.com/office/powerpoint/2010/main" val="50800281"/>
+        <p14:creationId xmlns:p14="http://schemas.microsoft.com/office/powerpoint/2010/main" val="646708723"/>
       </p:ext>
     </p:extLst>
   </p:cSld>

</xml_diff>